<commit_message>
style(pitch): transition pitch deck to Dark Modern Corporate theme with actual Streamlit screenshot
</commit_message>
<xml_diff>
--- a/kryodrop_pitch_deck.pptx
+++ b/kryodrop_pitch_deck.pptx
@@ -3091,7 +3091,7 @@
     <p:bg>
       <p:bgPr>
         <a:solidFill>
-          <a:srgbClr val="1B365D"/>
+          <a:srgbClr val="071321"/>
         </a:solidFill>
         <a:effectLst/>
       </p:bgPr>
@@ -3205,7 +3205,7 @@
             <a:pPr>
               <a:defRPr sz="1400">
                 <a:solidFill>
-                  <a:srgbClr val="F4FAFC"/>
+                  <a:srgbClr val="9CA3AF"/>
                 </a:solidFill>
                 <a:latin typeface="Segoe UI"/>
               </a:defRPr>
@@ -3290,7 +3290,7 @@
     <p:bg>
       <p:bgPr>
         <a:solidFill>
-          <a:srgbClr val="F4FAFC"/>
+          <a:srgbClr val="071321"/>
         </a:solidFill>
         <a:effectLst/>
       </p:bgPr>
@@ -3363,7 +3363,7 @@
             <a:pPr>
               <a:defRPr sz="2800" b="1">
                 <a:solidFill>
-                  <a:srgbClr val="1B365D"/>
+                  <a:srgbClr val="FFFFFF"/>
                 </a:solidFill>
                 <a:latin typeface="Segoe UI"/>
               </a:defRPr>
@@ -3383,17 +3383,17 @@
         <p:spPr>
           <a:xfrm>
             <a:off x="731520" y="1463040"/>
-            <a:ext cx="5120640" cy="3108960"/>
+            <a:ext cx="3291840" cy="3108960"/>
           </a:xfrm>
           <a:prstGeom prst="roundRect">
             <a:avLst/>
           </a:prstGeom>
           <a:solidFill>
-            <a:srgbClr val="FFFFFF"/>
+            <a:srgbClr val="101C30"/>
           </a:solidFill>
-          <a:ln>
+          <a:ln w="19050">
             <a:solidFill>
-              <a:srgbClr val="FFFFFF"/>
+              <a:srgbClr val="1B2C49"/>
             </a:solidFill>
           </a:ln>
         </p:spPr>
@@ -3427,8 +3427,8 @@
         </p:nvSpPr>
         <p:spPr>
           <a:xfrm>
-            <a:off x="1005840" y="1737360"/>
-            <a:ext cx="4572000" cy="2560320"/>
+            <a:off x="3200400" y="1554480"/>
+            <a:ext cx="731520" cy="457200"/>
           </a:xfrm>
           <a:prstGeom prst="rect">
             <a:avLst/>
@@ -3436,7 +3436,43 @@
           <a:noFill/>
         </p:spPr>
         <p:txBody>
-          <a:bodyPr wrap="square" lIns="0" rIns="0" tIns="0" bIns="0">
+          <a:bodyPr wrap="square" lIns="0" tIns="0" rIns="0" bIns="0">
+            <a:spAutoFit/>
+          </a:bodyPr>
+          <a:lstStyle/>
+          <a:p>
+            <a:pPr>
+              <a:defRPr sz="2800" b="1">
+                <a:solidFill>
+                  <a:srgbClr val="EF4444"/>
+                </a:solidFill>
+                <a:latin typeface="Segoe UI"/>
+              </a:defRPr>
+            </a:pPr>
+            <a:r>
+              <a:t>01</a:t>
+            </a:r>
+          </a:p>
+        </p:txBody>
+      </p:sp>
+      <p:sp>
+        <p:nvSpPr>
+          <p:cNvPr id="6" name="TextBox 5"/>
+          <p:cNvSpPr txBox="1"/>
+          <p:nvPr/>
+        </p:nvSpPr>
+        <p:spPr>
+          <a:xfrm>
+            <a:off x="960120" y="1645920"/>
+            <a:ext cx="2834640" cy="2651760"/>
+          </a:xfrm>
+          <a:prstGeom prst="rect">
+            <a:avLst/>
+          </a:prstGeom>
+          <a:noFill/>
+        </p:spPr>
+        <p:txBody>
+          <a:bodyPr wrap="square" lIns="0" tIns="0" rIns="0" bIns="0">
             <a:spAutoFit/>
           </a:bodyPr>
           <a:lstStyle/>
@@ -3445,15 +3481,15 @@
               <a:spcAft>
                 <a:spcPts val="1200"/>
               </a:spcAft>
-              <a:defRPr sz="1600" b="1">
-                <a:solidFill>
-                  <a:srgbClr val="1B365D"/>
-                </a:solidFill>
-                <a:latin typeface="Segoe UI"/>
-              </a:defRPr>
-            </a:pPr>
-            <a:r>
-              <a:t>1. Factures d'Électricité en Heures Pleines (Sonelgaz)</a:t>
+              <a:defRPr sz="1400" b="1">
+                <a:solidFill>
+                  <a:srgbClr val="29B6D8"/>
+                </a:solidFill>
+                <a:latin typeface="Segoe UI"/>
+              </a:defRPr>
+            </a:pPr>
+            <a:r>
+              <a:t>Factures Sonelgaz HP</a:t>
             </a:r>
           </a:p>
           <a:p>
@@ -3461,71 +3497,39 @@
               <a:spcAft>
                 <a:spcPts val="800"/>
               </a:spcAft>
-              <a:defRPr sz="1100">
-                <a:solidFill>
-                  <a:srgbClr val="111827"/>
-                </a:solidFill>
-                <a:latin typeface="Segoe UI"/>
-              </a:defRPr>
-            </a:pPr>
-            <a:r>
-              <a:t>Les compresseurs frigorifiques tournent à plein régime en journée, subissant les tarifs électriques les plus élevés (Heures Pleines).</a:t>
-            </a:r>
-          </a:p>
-          <a:p>
-            <a:pPr>
-              <a:spcAft>
-                <a:spcPts val="800"/>
-              </a:spcAft>
-              <a:defRPr sz="1100">
-                <a:solidFill>
-                  <a:srgbClr val="111827"/>
-                </a:solidFill>
-                <a:latin typeface="Segoe UI"/>
-              </a:defRPr>
-            </a:pPr>
-            <a:r>
-              <a:t>La prime fixe annuelle de puissance souscrite est gonflée par ces appels de courant de pointe diurnes.</a:t>
-            </a:r>
-          </a:p>
-          <a:p>
-            <a:pPr>
-              <a:spcAft>
-                <a:spcPts val="800"/>
-              </a:spcAft>
-              <a:defRPr sz="1100">
-                <a:solidFill>
-                  <a:srgbClr val="111827"/>
-                </a:solidFill>
-                <a:latin typeface="Segoe UI"/>
-              </a:defRPr>
-            </a:pPr>
-            <a:r>
-              <a:t>Aucune flexibilité d'exploitation sans barrière de stockage d'énergie.</a:t>
-            </a:r>
-          </a:p>
-        </p:txBody>
-      </p:sp>
-      <p:sp>
-        <p:nvSpPr>
-          <p:cNvPr id="6" name="Rounded Rectangle 5"/>
+              <a:defRPr sz="1050">
+                <a:solidFill>
+                  <a:srgbClr val="FFFFFF"/>
+                </a:solidFill>
+                <a:latin typeface="Segoe UI"/>
+              </a:defRPr>
+            </a:pPr>
+            <a:r>
+              <a:t>Les compresseurs frigorifiques tournent à plein régime en journée, subissant les tarifs électriques Heures Pleines (HP) x3.6 plus élevés qu'en Heures Creuses (HC).</a:t>
+            </a:r>
+          </a:p>
+        </p:txBody>
+      </p:sp>
+      <p:sp>
+        <p:nvSpPr>
+          <p:cNvPr id="7" name="Rounded Rectangle 6"/>
           <p:cNvSpPr/>
           <p:nvPr/>
         </p:nvSpPr>
         <p:spPr>
           <a:xfrm>
-            <a:off x="6309360" y="1463040"/>
-            <a:ext cx="5120640" cy="3108960"/>
+            <a:off x="4389120" y="1463040"/>
+            <a:ext cx="3291840" cy="3108960"/>
           </a:xfrm>
           <a:prstGeom prst="roundRect">
             <a:avLst/>
           </a:prstGeom>
           <a:solidFill>
-            <a:srgbClr val="FFFFFF"/>
+            <a:srgbClr val="101C30"/>
           </a:solidFill>
-          <a:ln>
+          <a:ln w="19050">
             <a:solidFill>
-              <a:srgbClr val="FFFFFF"/>
+              <a:srgbClr val="1B2C49"/>
             </a:solidFill>
           </a:ln>
         </p:spPr>
@@ -3553,14 +3557,14 @@
       </p:sp>
       <p:sp>
         <p:nvSpPr>
-          <p:cNvPr id="7" name="TextBox 6"/>
+          <p:cNvPr id="8" name="TextBox 7"/>
           <p:cNvSpPr txBox="1"/>
           <p:nvPr/>
         </p:nvSpPr>
         <p:spPr>
           <a:xfrm>
-            <a:off x="6583680" y="1737360"/>
-            <a:ext cx="4572000" cy="2560320"/>
+            <a:off x="6858000" y="1554480"/>
+            <a:ext cx="731520" cy="457200"/>
           </a:xfrm>
           <a:prstGeom prst="rect">
             <a:avLst/>
@@ -3568,7 +3572,43 @@
           <a:noFill/>
         </p:spPr>
         <p:txBody>
-          <a:bodyPr wrap="square" lIns="0" rIns="0" tIns="0" bIns="0">
+          <a:bodyPr wrap="square" lIns="0" tIns="0" rIns="0" bIns="0">
+            <a:spAutoFit/>
+          </a:bodyPr>
+          <a:lstStyle/>
+          <a:p>
+            <a:pPr>
+              <a:defRPr sz="2800" b="1">
+                <a:solidFill>
+                  <a:srgbClr val="EF4444"/>
+                </a:solidFill>
+                <a:latin typeface="Segoe UI"/>
+              </a:defRPr>
+            </a:pPr>
+            <a:r>
+              <a:t>02</a:t>
+            </a:r>
+          </a:p>
+        </p:txBody>
+      </p:sp>
+      <p:sp>
+        <p:nvSpPr>
+          <p:cNvPr id="9" name="TextBox 8"/>
+          <p:cNvSpPr txBox="1"/>
+          <p:nvPr/>
+        </p:nvSpPr>
+        <p:spPr>
+          <a:xfrm>
+            <a:off x="4617720" y="1645920"/>
+            <a:ext cx="2834640" cy="2651760"/>
+          </a:xfrm>
+          <a:prstGeom prst="rect">
+            <a:avLst/>
+          </a:prstGeom>
+          <a:noFill/>
+        </p:spPr>
+        <p:txBody>
+          <a:bodyPr wrap="square" lIns="0" tIns="0" rIns="0" bIns="0">
             <a:spAutoFit/>
           </a:bodyPr>
           <a:lstStyle/>
@@ -3577,15 +3617,15 @@
               <a:spcAft>
                 <a:spcPts val="1200"/>
               </a:spcAft>
-              <a:defRPr sz="1600" b="1">
-                <a:solidFill>
-                  <a:srgbClr val="1B365D"/>
-                </a:solidFill>
-                <a:latin typeface="Segoe UI"/>
-              </a:defRPr>
-            </a:pPr>
-            <a:r>
-              <a:t>2. Ruptures &amp; Vulnérabilité (Coupures Réseau)</a:t>
+              <a:defRPr sz="1400" b="1">
+                <a:solidFill>
+                  <a:srgbClr val="29B6D8"/>
+                </a:solidFill>
+                <a:latin typeface="Segoe UI"/>
+              </a:defRPr>
+            </a:pPr>
+            <a:r>
+              <a:t>Vulnérabilité Réseau</a:t>
             </a:r>
           </a:p>
           <a:p>
@@ -3593,71 +3633,39 @@
               <a:spcAft>
                 <a:spcPts val="800"/>
               </a:spcAft>
-              <a:defRPr sz="1100">
-                <a:solidFill>
-                  <a:srgbClr val="111827"/>
-                </a:solidFill>
-                <a:latin typeface="Segoe UI"/>
-              </a:defRPr>
-            </a:pPr>
-            <a:r>
-              <a:t>Les coupures de courant d'été (délestages récurrents) et les pannes du groupe compresseur provoquent la rupture immédiate de la chaîne du froid.</a:t>
-            </a:r>
-          </a:p>
-          <a:p>
-            <a:pPr>
-              <a:spcAft>
-                <a:spcPts val="800"/>
-              </a:spcAft>
-              <a:defRPr sz="1100">
-                <a:solidFill>
-                  <a:srgbClr val="111827"/>
-                </a:solidFill>
-                <a:latin typeface="Segoe UI"/>
-              </a:defRPr>
-            </a:pPr>
-            <a:r>
-              <a:t>Coût direct : perte sèche de marchandises et risques sanitaires majeurs.</a:t>
-            </a:r>
-          </a:p>
-          <a:p>
-            <a:pPr>
-              <a:spcAft>
-                <a:spcPts val="800"/>
-              </a:spcAft>
-              <a:defRPr sz="1100">
-                <a:solidFill>
-                  <a:srgbClr val="111827"/>
-                </a:solidFill>
-                <a:latin typeface="Segoe UI"/>
-              </a:defRPr>
-            </a:pPr>
-            <a:r>
-              <a:t>Une seule coupure sévère peut détruire la rentabilité annuelle d'un site.</a:t>
-            </a:r>
-          </a:p>
-        </p:txBody>
-      </p:sp>
-      <p:sp>
-        <p:nvSpPr>
-          <p:cNvPr id="8" name="Rounded Rectangle 7"/>
+              <a:defRPr sz="1050">
+                <a:solidFill>
+                  <a:srgbClr val="FFFFFF"/>
+                </a:solidFill>
+                <a:latin typeface="Segoe UI"/>
+              </a:defRPr>
+            </a:pPr>
+            <a:r>
+              <a:t>Les coupures de courant d'été et les délestages répétitifs provoquent une hausse immédiate de la température de la chambre froide, menaçant le stock.</a:t>
+            </a:r>
+          </a:p>
+        </p:txBody>
+      </p:sp>
+      <p:sp>
+        <p:nvSpPr>
+          <p:cNvPr id="10" name="Rounded Rectangle 9"/>
           <p:cNvSpPr/>
           <p:nvPr/>
         </p:nvSpPr>
         <p:spPr>
           <a:xfrm>
-            <a:off x="731520" y="4846320"/>
-            <a:ext cx="5120640" cy="1463040"/>
+            <a:off x="8046720" y="1463040"/>
+            <a:ext cx="3291840" cy="3108960"/>
           </a:xfrm>
           <a:prstGeom prst="roundRect">
             <a:avLst/>
           </a:prstGeom>
           <a:solidFill>
-            <a:srgbClr val="FFFFFF"/>
+            <a:srgbClr val="101C30"/>
           </a:solidFill>
-          <a:ln>
+          <a:ln w="19050">
             <a:solidFill>
-              <a:srgbClr val="FFFFFF"/>
+              <a:srgbClr val="1B2C49"/>
             </a:solidFill>
           </a:ln>
         </p:spPr>
@@ -3685,14 +3693,150 @@
       </p:sp>
       <p:sp>
         <p:nvSpPr>
-          <p:cNvPr id="9" name="TextBox 8"/>
+          <p:cNvPr id="11" name="TextBox 10"/>
           <p:cNvSpPr txBox="1"/>
           <p:nvPr/>
         </p:nvSpPr>
         <p:spPr>
           <a:xfrm>
+            <a:off x="10515600" y="1554480"/>
+            <a:ext cx="731520" cy="457200"/>
+          </a:xfrm>
+          <a:prstGeom prst="rect">
+            <a:avLst/>
+          </a:prstGeom>
+          <a:noFill/>
+        </p:spPr>
+        <p:txBody>
+          <a:bodyPr wrap="square" lIns="0" tIns="0" rIns="0" bIns="0">
+            <a:spAutoFit/>
+          </a:bodyPr>
+          <a:lstStyle/>
+          <a:p>
+            <a:pPr>
+              <a:defRPr sz="2800" b="1">
+                <a:solidFill>
+                  <a:srgbClr val="EF4444"/>
+                </a:solidFill>
+                <a:latin typeface="Segoe UI"/>
+              </a:defRPr>
+            </a:pPr>
+            <a:r>
+              <a:t>03</a:t>
+            </a:r>
+          </a:p>
+        </p:txBody>
+      </p:sp>
+      <p:sp>
+        <p:nvSpPr>
+          <p:cNvPr id="12" name="TextBox 11"/>
+          <p:cNvSpPr txBox="1"/>
+          <p:nvPr/>
+        </p:nvSpPr>
+        <p:spPr>
+          <a:xfrm>
+            <a:off x="8275320" y="1645920"/>
+            <a:ext cx="2834640" cy="2651760"/>
+          </a:xfrm>
+          <a:prstGeom prst="rect">
+            <a:avLst/>
+          </a:prstGeom>
+          <a:noFill/>
+        </p:spPr>
+        <p:txBody>
+          <a:bodyPr wrap="square" lIns="0" tIns="0" rIns="0" bIns="0">
+            <a:spAutoFit/>
+          </a:bodyPr>
+          <a:lstStyle/>
+          <a:p>
+            <a:pPr>
+              <a:spcAft>
+                <a:spcPts val="1200"/>
+              </a:spcAft>
+              <a:defRPr sz="1400" b="1">
+                <a:solidFill>
+                  <a:srgbClr val="29B6D8"/>
+                </a:solidFill>
+                <a:latin typeface="Segoe UI"/>
+              </a:defRPr>
+            </a:pPr>
+            <a:r>
+              <a:t>Pertes de Marchandises</a:t>
+            </a:r>
+          </a:p>
+          <a:p>
+            <a:pPr>
+              <a:spcAft>
+                <a:spcPts val="800"/>
+              </a:spcAft>
+              <a:defRPr sz="1050">
+                <a:solidFill>
+                  <a:srgbClr val="FFFFFF"/>
+                </a:solidFill>
+                <a:latin typeface="Segoe UI"/>
+              </a:defRPr>
+            </a:pPr>
+            <a:r>
+              <a:t>Une seule rupture de chaîne de froid entraîne la perte sèche de denrées périssables de grande valeur. Risques sanitaires et financiers colossaux pour l'exploitant.</a:t>
+            </a:r>
+          </a:p>
+        </p:txBody>
+      </p:sp>
+      <p:sp>
+        <p:nvSpPr>
+          <p:cNvPr id="13" name="Rounded Rectangle 12"/>
+          <p:cNvSpPr/>
+          <p:nvPr/>
+        </p:nvSpPr>
+        <p:spPr>
+          <a:xfrm>
+            <a:off x="731520" y="4846320"/>
+            <a:ext cx="3291840" cy="1463040"/>
+          </a:xfrm>
+          <a:prstGeom prst="roundRect">
+            <a:avLst/>
+          </a:prstGeom>
+          <a:solidFill>
+            <a:srgbClr val="101C30"/>
+          </a:solidFill>
+          <a:ln w="19050">
+            <a:solidFill>
+              <a:srgbClr val="1B2C49"/>
+            </a:solidFill>
+          </a:ln>
+        </p:spPr>
+        <p:style>
+          <a:lnRef idx="1">
+            <a:schemeClr val="accent1"/>
+          </a:lnRef>
+          <a:fillRef idx="3">
+            <a:schemeClr val="accent1"/>
+          </a:fillRef>
+          <a:effectRef idx="2">
+            <a:schemeClr val="accent1"/>
+          </a:effectRef>
+          <a:fontRef idx="minor">
+            <a:schemeClr val="lt1"/>
+          </a:fontRef>
+        </p:style>
+        <p:txBody>
+          <a:bodyPr rtlCol="0" anchor="ctr"/>
+          <a:lstStyle/>
+          <a:p>
+            <a:pPr algn="ctr"/>
+          </a:p>
+        </p:txBody>
+      </p:sp>
+      <p:sp>
+        <p:nvSpPr>
+          <p:cNvPr id="14" name="TextBox 13"/>
+          <p:cNvSpPr txBox="1"/>
+          <p:nvPr/>
+        </p:nvSpPr>
+        <p:spPr>
+          <a:xfrm>
             <a:off x="914400" y="5029200"/>
-            <a:ext cx="4754880" cy="1097280"/>
+            <a:ext cx="2926080" cy="1097280"/>
           </a:xfrm>
           <a:prstGeom prst="rect">
             <a:avLst/>
@@ -3706,9 +3850,9 @@
           <a:lstStyle/>
           <a:p>
             <a:pPr algn="ctr">
-              <a:defRPr sz="4400" b="1">
-                <a:solidFill>
-                  <a:srgbClr val="DC2626"/>
+              <a:defRPr sz="4000" b="1">
+                <a:solidFill>
+                  <a:srgbClr val="EF4444"/>
                 </a:solidFill>
                 <a:latin typeface="Segoe UI"/>
               </a:defRPr>
@@ -3724,37 +3868,37 @@
               </a:spcBef>
               <a:defRPr sz="1000" b="1">
                 <a:solidFill>
-                  <a:srgbClr val="6B7280"/>
-                </a:solidFill>
-                <a:latin typeface="Segoe UI"/>
-              </a:defRPr>
-            </a:pPr>
-            <a:r>
-              <a:t>Surcoût lié aux Heures Pleines diurnes (Sonelgaz)</a:t>
-            </a:r>
-          </a:p>
-        </p:txBody>
-      </p:sp>
-      <p:sp>
-        <p:nvSpPr>
-          <p:cNvPr id="10" name="Rounded Rectangle 9"/>
+                  <a:srgbClr val="FFFFFF"/>
+                </a:solidFill>
+                <a:latin typeface="Segoe UI"/>
+              </a:defRPr>
+            </a:pPr>
+            <a:r>
+              <a:t>Surcoût en Heures Pleines</a:t>
+            </a:r>
+          </a:p>
+        </p:txBody>
+      </p:sp>
+      <p:sp>
+        <p:nvSpPr>
+          <p:cNvPr id="15" name="Rounded Rectangle 14"/>
           <p:cNvSpPr/>
           <p:nvPr/>
         </p:nvSpPr>
         <p:spPr>
           <a:xfrm>
-            <a:off x="6309360" y="4846320"/>
-            <a:ext cx="5120640" cy="1463040"/>
+            <a:off x="4389120" y="4846320"/>
+            <a:ext cx="3291840" cy="1463040"/>
           </a:xfrm>
           <a:prstGeom prst="roundRect">
             <a:avLst/>
           </a:prstGeom>
           <a:solidFill>
-            <a:srgbClr val="FFFFFF"/>
+            <a:srgbClr val="101C30"/>
           </a:solidFill>
-          <a:ln>
+          <a:ln w="19050">
             <a:solidFill>
-              <a:srgbClr val="FFFFFF"/>
+              <a:srgbClr val="1B2C49"/>
             </a:solidFill>
           </a:ln>
         </p:spPr>
@@ -3782,14 +3926,14 @@
       </p:sp>
       <p:sp>
         <p:nvSpPr>
-          <p:cNvPr id="11" name="TextBox 10"/>
+          <p:cNvPr id="16" name="TextBox 15"/>
           <p:cNvSpPr txBox="1"/>
           <p:nvPr/>
         </p:nvSpPr>
         <p:spPr>
           <a:xfrm>
-            <a:off x="6492240" y="5029200"/>
-            <a:ext cx="4754880" cy="1097280"/>
+            <a:off x="4572000" y="5029200"/>
+            <a:ext cx="2926080" cy="1097280"/>
           </a:xfrm>
           <a:prstGeom prst="rect">
             <a:avLst/>
@@ -3803,15 +3947,15 @@
           <a:lstStyle/>
           <a:p>
             <a:pPr algn="ctr">
-              <a:defRPr sz="4400" b="1">
-                <a:solidFill>
-                  <a:srgbClr val="DC2626"/>
-                </a:solidFill>
-                <a:latin typeface="Segoe UI"/>
-              </a:defRPr>
-            </a:pPr>
-            <a:r>
-              <a:t>1.5M DA</a:t>
+              <a:defRPr sz="4000" b="1">
+                <a:solidFill>
+                  <a:srgbClr val="EF4444"/>
+                </a:solidFill>
+                <a:latin typeface="Segoe UI"/>
+              </a:defRPr>
+            </a:pPr>
+            <a:r>
+              <a:t>13 Heures</a:t>
             </a:r>
           </a:p>
           <a:p>
@@ -3821,13 +3965,110 @@
               </a:spcBef>
               <a:defRPr sz="1000" b="1">
                 <a:solidFill>
-                  <a:srgbClr val="6B7280"/>
-                </a:solidFill>
-                <a:latin typeface="Segoe UI"/>
-              </a:defRPr>
-            </a:pPr>
-            <a:r>
-              <a:t>Valeur moyenne d'un stock de denrées exposé en chambre froide</a:t>
+                  <a:srgbClr val="FFFFFF"/>
+                </a:solidFill>
+                <a:latin typeface="Segoe UI"/>
+              </a:defRPr>
+            </a:pPr>
+            <a:r>
+              <a:t>Délestages d'été moyens supportés</a:t>
+            </a:r>
+          </a:p>
+        </p:txBody>
+      </p:sp>
+      <p:sp>
+        <p:nvSpPr>
+          <p:cNvPr id="17" name="Rounded Rectangle 16"/>
+          <p:cNvSpPr/>
+          <p:nvPr/>
+        </p:nvSpPr>
+        <p:spPr>
+          <a:xfrm>
+            <a:off x="8046720" y="4846320"/>
+            <a:ext cx="3291840" cy="1463040"/>
+          </a:xfrm>
+          <a:prstGeom prst="roundRect">
+            <a:avLst/>
+          </a:prstGeom>
+          <a:solidFill>
+            <a:srgbClr val="101C30"/>
+          </a:solidFill>
+          <a:ln w="19050">
+            <a:solidFill>
+              <a:srgbClr val="1B2C49"/>
+            </a:solidFill>
+          </a:ln>
+        </p:spPr>
+        <p:style>
+          <a:lnRef idx="1">
+            <a:schemeClr val="accent1"/>
+          </a:lnRef>
+          <a:fillRef idx="3">
+            <a:schemeClr val="accent1"/>
+          </a:fillRef>
+          <a:effectRef idx="2">
+            <a:schemeClr val="accent1"/>
+          </a:effectRef>
+          <a:fontRef idx="minor">
+            <a:schemeClr val="lt1"/>
+          </a:fontRef>
+        </p:style>
+        <p:txBody>
+          <a:bodyPr rtlCol="0" anchor="ctr"/>
+          <a:lstStyle/>
+          <a:p>
+            <a:pPr algn="ctr"/>
+          </a:p>
+        </p:txBody>
+      </p:sp>
+      <p:sp>
+        <p:nvSpPr>
+          <p:cNvPr id="18" name="TextBox 17"/>
+          <p:cNvSpPr txBox="1"/>
+          <p:nvPr/>
+        </p:nvSpPr>
+        <p:spPr>
+          <a:xfrm>
+            <a:off x="8229600" y="5029200"/>
+            <a:ext cx="2926080" cy="1097280"/>
+          </a:xfrm>
+          <a:prstGeom prst="rect">
+            <a:avLst/>
+          </a:prstGeom>
+          <a:noFill/>
+        </p:spPr>
+        <p:txBody>
+          <a:bodyPr wrap="square" lIns="0" rIns="0" tIns="0" bIns="0">
+            <a:spAutoFit/>
+          </a:bodyPr>
+          <a:lstStyle/>
+          <a:p>
+            <a:pPr algn="ctr">
+              <a:defRPr sz="4000" b="1">
+                <a:solidFill>
+                  <a:srgbClr val="EF4444"/>
+                </a:solidFill>
+                <a:latin typeface="Segoe UI"/>
+              </a:defRPr>
+            </a:pPr>
+            <a:r>
+              <a:t>1.5M DA</a:t>
+            </a:r>
+          </a:p>
+          <a:p>
+            <a:pPr algn="ctr">
+              <a:spcBef>
+                <a:spcPts val="400"/>
+              </a:spcBef>
+              <a:defRPr sz="1000" b="1">
+                <a:solidFill>
+                  <a:srgbClr val="FFFFFF"/>
+                </a:solidFill>
+                <a:latin typeface="Segoe UI"/>
+              </a:defRPr>
+            </a:pPr>
+            <a:r>
+              <a:t>Perte par incident de délestage</a:t>
             </a:r>
           </a:p>
         </p:txBody>
@@ -3846,7 +4087,7 @@
     <p:bg>
       <p:bgPr>
         <a:solidFill>
-          <a:srgbClr val="F4FAFC"/>
+          <a:srgbClr val="071321"/>
         </a:solidFill>
         <a:effectLst/>
       </p:bgPr>
@@ -3919,7 +4160,7 @@
             <a:pPr>
               <a:defRPr sz="2800" b="1">
                 <a:solidFill>
-                  <a:srgbClr val="1B365D"/>
+                  <a:srgbClr val="FFFFFF"/>
                 </a:solidFill>
                 <a:latin typeface="Segoe UI"/>
               </a:defRPr>
@@ -3939,17 +4180,17 @@
         <p:spPr>
           <a:xfrm>
             <a:off x="731520" y="1463040"/>
-            <a:ext cx="5943600" cy="4846320"/>
+            <a:ext cx="5669280" cy="4846320"/>
           </a:xfrm>
           <a:prstGeom prst="roundRect">
             <a:avLst/>
           </a:prstGeom>
           <a:solidFill>
-            <a:srgbClr val="1B365D"/>
+            <a:srgbClr val="101C30"/>
           </a:solidFill>
-          <a:ln>
+          <a:ln w="19050">
             <a:solidFill>
-              <a:srgbClr val="1B365D"/>
+              <a:srgbClr val="29B6D8"/>
             </a:solidFill>
           </a:ln>
         </p:spPr>
@@ -3984,7 +4225,7 @@
         <p:spPr>
           <a:xfrm>
             <a:off x="1005840" y="1737360"/>
-            <a:ext cx="5394960" cy="4297680"/>
+            <a:ext cx="5120640" cy="4297680"/>
           </a:xfrm>
           <a:prstGeom prst="rect">
             <a:avLst/>
@@ -4070,18 +4311,18 @@
         </p:nvSpPr>
         <p:spPr>
           <a:xfrm>
-            <a:off x="7040880" y="1463040"/>
-            <a:ext cx="4389120" cy="2194560"/>
+            <a:off x="6766560" y="1463040"/>
+            <a:ext cx="4663440" cy="2194560"/>
           </a:xfrm>
           <a:prstGeom prst="roundRect">
             <a:avLst/>
           </a:prstGeom>
           <a:solidFill>
-            <a:srgbClr val="FFFFFF"/>
+            <a:srgbClr val="101C30"/>
           </a:solidFill>
-          <a:ln>
+          <a:ln w="19050">
             <a:solidFill>
-              <a:srgbClr val="FFFFFF"/>
+              <a:srgbClr val="1B2C49"/>
             </a:solidFill>
           </a:ln>
         </p:spPr>
@@ -4115,8 +4356,8 @@
         </p:nvSpPr>
         <p:spPr>
           <a:xfrm>
-            <a:off x="7315200" y="1737360"/>
-            <a:ext cx="3840480" cy="1645920"/>
+            <a:off x="7040880" y="1645920"/>
+            <a:ext cx="4114800" cy="1828800"/>
           </a:xfrm>
           <a:prstGeom prst="rect">
             <a:avLst/>
@@ -4124,40 +4365,37 @@
           <a:noFill/>
         </p:spPr>
         <p:txBody>
-          <a:bodyPr wrap="square" lIns="0" rIns="0" tIns="0" bIns="0">
+          <a:bodyPr wrap="square" lIns="0" tIns="0" rIns="0" bIns="0">
             <a:spAutoFit/>
           </a:bodyPr>
           <a:lstStyle/>
-          <a:p>
-            <a:pPr>
-              <a:spcAft>
-                <a:spcPts val="1200"/>
-              </a:spcAft>
-              <a:defRPr sz="1600" b="1">
-                <a:solidFill>
-                  <a:srgbClr val="1B365D"/>
-                </a:solidFill>
-                <a:latin typeface="Segoe UI"/>
-              </a:defRPr>
-            </a:pPr>
-            <a:r>
-              <a:t>Arbitrage Énergétique Direct</a:t>
-            </a:r>
-          </a:p>
           <a:p>
             <a:pPr>
               <a:spcAft>
                 <a:spcPts val="800"/>
               </a:spcAft>
-              <a:defRPr sz="1100">
-                <a:solidFill>
-                  <a:srgbClr val="111827"/>
-                </a:solidFill>
-                <a:latin typeface="Segoe UI"/>
-              </a:defRPr>
-            </a:pPr>
-            <a:r>
-              <a:t>Déplacement de 100% de la consommation de pointe vers les heures creuses nocturnes, permettant d'économiser sur les coûts variables et de réduire la prime de puissance souscrite.</a:t>
+              <a:defRPr sz="1500" b="1">
+                <a:solidFill>
+                  <a:srgbClr val="29B6D8"/>
+                </a:solidFill>
+                <a:latin typeface="Segoe UI"/>
+              </a:defRPr>
+            </a:pPr>
+            <a:r>
+              <a:t>Arbitrage Énergétique Direct</a:t>
+            </a:r>
+          </a:p>
+          <a:p>
+            <a:pPr>
+              <a:defRPr sz="1050">
+                <a:solidFill>
+                  <a:srgbClr val="FFFFFF"/>
+                </a:solidFill>
+                <a:latin typeface="Segoe UI"/>
+              </a:defRPr>
+            </a:pPr>
+            <a:r>
+              <a:t>Déplacement de 100% de la consommation de pointe vers les heures creuses nocturnes, permettant d'économiser sur les coûts de facture variables et fixes.</a:t>
             </a:r>
           </a:p>
         </p:txBody>
@@ -4170,18 +4408,18 @@
         </p:nvSpPr>
         <p:spPr>
           <a:xfrm>
-            <a:off x="7040880" y="4114800"/>
-            <a:ext cx="4389120" cy="2194560"/>
+            <a:off x="6766560" y="4114800"/>
+            <a:ext cx="4663440" cy="2194560"/>
           </a:xfrm>
           <a:prstGeom prst="roundRect">
             <a:avLst/>
           </a:prstGeom>
           <a:solidFill>
-            <a:srgbClr val="FFFFFF"/>
+            <a:srgbClr val="101C30"/>
           </a:solidFill>
-          <a:ln>
+          <a:ln w="19050">
             <a:solidFill>
-              <a:srgbClr val="FFFFFF"/>
+              <a:srgbClr val="1B2C49"/>
             </a:solidFill>
           </a:ln>
         </p:spPr>
@@ -4215,8 +4453,8 @@
         </p:nvSpPr>
         <p:spPr>
           <a:xfrm>
-            <a:off x="7315200" y="4389120"/>
-            <a:ext cx="3840480" cy="1645920"/>
+            <a:off x="7040880" y="4297680"/>
+            <a:ext cx="4114800" cy="1828800"/>
           </a:xfrm>
           <a:prstGeom prst="rect">
             <a:avLst/>
@@ -4224,34 +4462,31 @@
           <a:noFill/>
         </p:spPr>
         <p:txBody>
-          <a:bodyPr wrap="square" lIns="0" rIns="0" tIns="0" bIns="0">
+          <a:bodyPr wrap="square" lIns="0" tIns="0" rIns="0" bIns="0">
             <a:spAutoFit/>
           </a:bodyPr>
           <a:lstStyle/>
-          <a:p>
-            <a:pPr>
-              <a:spcAft>
-                <a:spcPts val="1200"/>
-              </a:spcAft>
-              <a:defRPr sz="1600" b="1">
-                <a:solidFill>
-                  <a:srgbClr val="1B365D"/>
-                </a:solidFill>
-                <a:latin typeface="Segoe UI"/>
-              </a:defRPr>
-            </a:pPr>
-            <a:r>
-              <a:t>Sécurisation Active (13h)</a:t>
-            </a:r>
-          </a:p>
           <a:p>
             <a:pPr>
               <a:spcAft>
                 <a:spcPts val="800"/>
               </a:spcAft>
-              <a:defRPr sz="1100">
-                <a:solidFill>
-                  <a:srgbClr val="111827"/>
+              <a:defRPr sz="1500" b="1">
+                <a:solidFill>
+                  <a:srgbClr val="29B6D8"/>
+                </a:solidFill>
+                <a:latin typeface="Segoe UI"/>
+              </a:defRPr>
+            </a:pPr>
+            <a:r>
+              <a:t>Sécurisation Active (13h)</a:t>
+            </a:r>
+          </a:p>
+          <a:p>
+            <a:pPr>
+              <a:defRPr sz="1050">
+                <a:solidFill>
+                  <a:srgbClr val="FFFFFF"/>
                 </a:solidFill>
                 <a:latin typeface="Segoe UI"/>
               </a:defRPr>
@@ -4270,7 +4505,7 @@
         </p:nvSpPr>
         <p:spPr>
           <a:xfrm>
-            <a:off x="7040880" y="1463040"/>
+            <a:off x="6766560" y="1463040"/>
             <a:ext cx="73152" cy="2194560"/>
           </a:xfrm>
           <a:prstGeom prst="rect">
@@ -4315,7 +4550,7 @@
         </p:nvSpPr>
         <p:spPr>
           <a:xfrm>
-            <a:off x="7040880" y="4114800"/>
+            <a:off x="6766560" y="4114800"/>
             <a:ext cx="73152" cy="2194560"/>
           </a:xfrm>
           <a:prstGeom prst="rect">
@@ -4366,7 +4601,7 @@
     <p:bg>
       <p:bgPr>
         <a:solidFill>
-          <a:srgbClr val="F4FAFC"/>
+          <a:srgbClr val="071321"/>
         </a:solidFill>
         <a:effectLst/>
       </p:bgPr>
@@ -4439,7 +4674,7 @@
             <a:pPr>
               <a:defRPr sz="2800" b="1">
                 <a:solidFill>
-                  <a:srgbClr val="1B365D"/>
+                  <a:srgbClr val="FFFFFF"/>
                 </a:solidFill>
                 <a:latin typeface="Segoe UI"/>
               </a:defRPr>
@@ -4465,11 +4700,11 @@
             <a:avLst/>
           </a:prstGeom>
           <a:solidFill>
-            <a:srgbClr val="FFFFFF"/>
+            <a:srgbClr val="101C30"/>
           </a:solidFill>
-          <a:ln>
+          <a:ln w="19050">
             <a:solidFill>
-              <a:srgbClr val="FFFFFF"/>
+              <a:srgbClr val="1B2C49"/>
             </a:solidFill>
           </a:ln>
         </p:spPr>
@@ -4523,7 +4758,7 @@
               </a:spcAft>
               <a:defRPr sz="1600" b="1">
                 <a:solidFill>
-                  <a:srgbClr val="1B365D"/>
+                  <a:srgbClr val="29B6D8"/>
                 </a:solidFill>
                 <a:latin typeface="Segoe UI"/>
               </a:defRPr>
@@ -4539,7 +4774,7 @@
               </a:spcAft>
               <a:defRPr sz="1100">
                 <a:solidFill>
-                  <a:srgbClr val="111827"/>
+                  <a:srgbClr val="FFFFFF"/>
                 </a:solidFill>
                 <a:latin typeface="Segoe UI"/>
               </a:defRPr>
@@ -4555,7 +4790,7 @@
               </a:spcAft>
               <a:defRPr sz="1100">
                 <a:solidFill>
-                  <a:srgbClr val="111827"/>
+                  <a:srgbClr val="FFFFFF"/>
                 </a:solidFill>
                 <a:latin typeface="Segoe UI"/>
               </a:defRPr>
@@ -4571,7 +4806,7 @@
               </a:spcAft>
               <a:defRPr sz="1100">
                 <a:solidFill>
-                  <a:srgbClr val="111827"/>
+                  <a:srgbClr val="FFFFFF"/>
                 </a:solidFill>
                 <a:latin typeface="Segoe UI"/>
               </a:defRPr>
@@ -4587,7 +4822,7 @@
               </a:spcAft>
               <a:defRPr sz="1100">
                 <a:solidFill>
-                  <a:srgbClr val="111827"/>
+                  <a:srgbClr val="FFFFFF"/>
                 </a:solidFill>
                 <a:latin typeface="Segoe UI"/>
               </a:defRPr>
@@ -4613,11 +4848,11 @@
             <a:avLst/>
           </a:prstGeom>
           <a:solidFill>
-            <a:srgbClr val="FFFFFF"/>
+            <a:srgbClr val="101C30"/>
           </a:solidFill>
-          <a:ln>
+          <a:ln w="19050">
             <a:solidFill>
-              <a:srgbClr val="FFFFFF"/>
+              <a:srgbClr val="29B6D8"/>
             </a:solidFill>
           </a:ln>
         </p:spPr>
@@ -4643,9 +4878,54 @@
           </a:p>
         </p:txBody>
       </p:sp>
+      <p:sp>
+        <p:nvSpPr>
+          <p:cNvPr id="7" name="Rectangle 6"/>
+          <p:cNvSpPr/>
+          <p:nvPr/>
+        </p:nvSpPr>
+        <p:spPr>
+          <a:xfrm>
+            <a:off x="5989320" y="1874520"/>
+            <a:ext cx="5303520" cy="3931920"/>
+          </a:xfrm>
+          <a:prstGeom prst="rect">
+            <a:avLst/>
+          </a:prstGeom>
+          <a:solidFill>
+            <a:srgbClr val="101C30"/>
+          </a:solidFill>
+          <a:ln w="19050">
+            <a:solidFill>
+              <a:srgbClr val="29B6D8"/>
+            </a:solidFill>
+          </a:ln>
+        </p:spPr>
+        <p:style>
+          <a:lnRef idx="1">
+            <a:schemeClr val="accent1"/>
+          </a:lnRef>
+          <a:fillRef idx="3">
+            <a:schemeClr val="accent1"/>
+          </a:fillRef>
+          <a:effectRef idx="2">
+            <a:schemeClr val="accent1"/>
+          </a:effectRef>
+          <a:fontRef idx="minor">
+            <a:schemeClr val="lt1"/>
+          </a:fontRef>
+        </p:style>
+        <p:txBody>
+          <a:bodyPr rtlCol="0" anchor="ctr"/>
+          <a:lstStyle/>
+          <a:p>
+            <a:pPr algn="ctr"/>
+          </a:p>
+        </p:txBody>
+      </p:sp>
       <p:pic>
         <p:nvPicPr>
-          <p:cNvPr id="7" name="Picture 6" descr="Capture d'écran 2026-07-08 182424.png"/>
+          <p:cNvPr id="8" name="Picture 7" descr="streamlit_app.png"/>
           <p:cNvPicPr>
             <a:picLocks noChangeAspect="1"/>
           </p:cNvPicPr>
@@ -4681,7 +4961,7 @@
     <p:bg>
       <p:bgPr>
         <a:solidFill>
-          <a:srgbClr val="F4FAFC"/>
+          <a:srgbClr val="071321"/>
         </a:solidFill>
         <a:effectLst/>
       </p:bgPr>
@@ -4754,7 +5034,7 @@
             <a:pPr>
               <a:defRPr sz="2800" b="1">
                 <a:solidFill>
-                  <a:srgbClr val="1B365D"/>
+                  <a:srgbClr val="FFFFFF"/>
                 </a:solidFill>
                 <a:latin typeface="Segoe UI"/>
               </a:defRPr>
@@ -4780,11 +5060,11 @@
             <a:avLst/>
           </a:prstGeom>
           <a:solidFill>
-            <a:srgbClr val="FFFFFF"/>
+            <a:srgbClr val="101C30"/>
           </a:solidFill>
-          <a:ln>
+          <a:ln w="19050">
             <a:solidFill>
-              <a:srgbClr val="FFFFFF"/>
+              <a:srgbClr val="1B2C49"/>
             </a:solidFill>
           </a:ln>
         </p:spPr>
@@ -4838,7 +5118,7 @@
               </a:spcAft>
               <a:defRPr sz="1600" b="1">
                 <a:solidFill>
-                  <a:srgbClr val="1B365D"/>
+                  <a:srgbClr val="29B6D8"/>
                 </a:solidFill>
                 <a:latin typeface="Segoe UI"/>
               </a:defRPr>
@@ -4854,7 +5134,7 @@
               </a:spcAft>
               <a:defRPr sz="1100">
                 <a:solidFill>
-                  <a:srgbClr val="111827"/>
+                  <a:srgbClr val="FFFFFF"/>
                 </a:solidFill>
                 <a:latin typeface="Segoe UI"/>
               </a:defRPr>
@@ -4870,7 +5150,7 @@
               </a:spcAft>
               <a:defRPr sz="1100">
                 <a:solidFill>
-                  <a:srgbClr val="111827"/>
+                  <a:srgbClr val="FFFFFF"/>
                 </a:solidFill>
                 <a:latin typeface="Segoe UI"/>
               </a:defRPr>
@@ -4886,7 +5166,7 @@
               </a:spcAft>
               <a:defRPr sz="1100">
                 <a:solidFill>
-                  <a:srgbClr val="111827"/>
+                  <a:srgbClr val="FFFFFF"/>
                 </a:solidFill>
                 <a:latin typeface="Segoe UI"/>
               </a:defRPr>
@@ -4902,7 +5182,7 @@
               </a:spcAft>
               <a:defRPr sz="1100">
                 <a:solidFill>
-                  <a:srgbClr val="111827"/>
+                  <a:srgbClr val="FFFFFF"/>
                 </a:solidFill>
                 <a:latin typeface="Segoe UI"/>
               </a:defRPr>
@@ -4928,11 +5208,11 @@
             <a:avLst/>
           </a:prstGeom>
           <a:solidFill>
-            <a:srgbClr val="FFFFFF"/>
+            <a:srgbClr val="101C30"/>
           </a:solidFill>
-          <a:ln>
+          <a:ln w="19050">
             <a:solidFill>
-              <a:srgbClr val="FFFFFF"/>
+              <a:srgbClr val="29B6D8"/>
             </a:solidFill>
           </a:ln>
         </p:spPr>
@@ -4958,9 +5238,54 @@
           </a:p>
         </p:txBody>
       </p:sp>
+      <p:sp>
+        <p:nvSpPr>
+          <p:cNvPr id="7" name="Rectangle 6"/>
+          <p:cNvSpPr/>
+          <p:nvPr/>
+        </p:nvSpPr>
+        <p:spPr>
+          <a:xfrm>
+            <a:off x="5989320" y="1874520"/>
+            <a:ext cx="5303520" cy="3931920"/>
+          </a:xfrm>
+          <a:prstGeom prst="rect">
+            <a:avLst/>
+          </a:prstGeom>
+          <a:solidFill>
+            <a:srgbClr val="101C30"/>
+          </a:solidFill>
+          <a:ln w="19050">
+            <a:solidFill>
+              <a:srgbClr val="29B6D8"/>
+            </a:solidFill>
+          </a:ln>
+        </p:spPr>
+        <p:style>
+          <a:lnRef idx="1">
+            <a:schemeClr val="accent1"/>
+          </a:lnRef>
+          <a:fillRef idx="3">
+            <a:schemeClr val="accent1"/>
+          </a:fillRef>
+          <a:effectRef idx="2">
+            <a:schemeClr val="accent1"/>
+          </a:effectRef>
+          <a:fontRef idx="minor">
+            <a:schemeClr val="lt1"/>
+          </a:fontRef>
+        </p:style>
+        <p:txBody>
+          <a:bodyPr rtlCol="0" anchor="ctr"/>
+          <a:lstStyle/>
+          <a:p>
+            <a:pPr algn="ctr"/>
+          </a:p>
+        </p:txBody>
+      </p:sp>
       <p:pic>
         <p:nvPicPr>
-          <p:cNvPr id="7" name="Picture 6" descr="Capture d'écran 2026-07-08 192651.png"/>
+          <p:cNvPr id="8" name="Picture 7" descr="Capture d'écran 2026-07-08 192651.png"/>
           <p:cNvPicPr>
             <a:picLocks noChangeAspect="1"/>
           </p:cNvPicPr>
@@ -4996,7 +5321,7 @@
     <p:bg>
       <p:bgPr>
         <a:solidFill>
-          <a:srgbClr val="F4FAFC"/>
+          <a:srgbClr val="071321"/>
         </a:solidFill>
         <a:effectLst/>
       </p:bgPr>
@@ -5069,7 +5394,7 @@
             <a:pPr>
               <a:defRPr sz="2800" b="1">
                 <a:solidFill>
-                  <a:srgbClr val="1B365D"/>
+                  <a:srgbClr val="FFFFFF"/>
                 </a:solidFill>
                 <a:latin typeface="Segoe UI"/>
               </a:defRPr>
@@ -5095,11 +5420,11 @@
             <a:avLst/>
           </a:prstGeom>
           <a:solidFill>
-            <a:srgbClr val="FFFFFF"/>
+            <a:srgbClr val="101C30"/>
           </a:solidFill>
-          <a:ln>
+          <a:ln w="19050">
             <a:solidFill>
-              <a:srgbClr val="FFFFFF"/>
+              <a:srgbClr val="1B2C49"/>
             </a:solidFill>
           </a:ln>
         </p:spPr>
@@ -5153,7 +5478,7 @@
               </a:spcAft>
               <a:defRPr sz="1600" b="1">
                 <a:solidFill>
-                  <a:srgbClr val="1B365D"/>
+                  <a:srgbClr val="29B6D8"/>
                 </a:solidFill>
                 <a:latin typeface="Segoe UI"/>
               </a:defRPr>
@@ -5169,7 +5494,7 @@
               </a:spcAft>
               <a:defRPr sz="1100">
                 <a:solidFill>
-                  <a:srgbClr val="111827"/>
+                  <a:srgbClr val="FFFFFF"/>
                 </a:solidFill>
                 <a:latin typeface="Segoe UI"/>
               </a:defRPr>
@@ -5185,7 +5510,7 @@
               </a:spcAft>
               <a:defRPr sz="1100">
                 <a:solidFill>
-                  <a:srgbClr val="111827"/>
+                  <a:srgbClr val="FFFFFF"/>
                 </a:solidFill>
                 <a:latin typeface="Segoe UI"/>
               </a:defRPr>
@@ -5201,7 +5526,7 @@
               </a:spcAft>
               <a:defRPr sz="1100">
                 <a:solidFill>
-                  <a:srgbClr val="111827"/>
+                  <a:srgbClr val="FFFFFF"/>
                 </a:solidFill>
                 <a:latin typeface="Segoe UI"/>
               </a:defRPr>
@@ -5217,7 +5542,7 @@
               </a:spcAft>
               <a:defRPr sz="1100">
                 <a:solidFill>
-                  <a:srgbClr val="111827"/>
+                  <a:srgbClr val="FFFFFF"/>
                 </a:solidFill>
                 <a:latin typeface="Segoe UI"/>
               </a:defRPr>
@@ -5243,11 +5568,11 @@
             <a:avLst/>
           </a:prstGeom>
           <a:solidFill>
-            <a:srgbClr val="FFFFFF"/>
+            <a:srgbClr val="101C30"/>
           </a:solidFill>
-          <a:ln>
+          <a:ln w="19050">
             <a:solidFill>
-              <a:srgbClr val="FFFFFF"/>
+              <a:srgbClr val="1B2C49"/>
             </a:solidFill>
           </a:ln>
         </p:spPr>
@@ -5288,11 +5613,11 @@
             <a:avLst/>
           </a:prstGeom>
           <a:solidFill>
-            <a:srgbClr val="F4FAFC"/>
+            <a:srgbClr val="101C30"/>
           </a:solidFill>
-          <a:ln>
+          <a:ln w="19050">
             <a:solidFill>
-              <a:srgbClr val="F4FAFC"/>
+              <a:srgbClr val="1B2C49"/>
             </a:solidFill>
           </a:ln>
         </p:spPr>
@@ -5343,7 +5668,7 @@
             <a:pPr>
               <a:defRPr sz="1200" b="1">
                 <a:solidFill>
-                  <a:srgbClr val="1B365D"/>
+                  <a:srgbClr val="29B6D8"/>
                 </a:solidFill>
                 <a:latin typeface="Segoe UI"/>
               </a:defRPr>
@@ -5356,7 +5681,7 @@
             <a:pPr>
               <a:defRPr sz="1000">
                 <a:solidFill>
-                  <a:srgbClr val="111827"/>
+                  <a:srgbClr val="FFFFFF"/>
                 </a:solidFill>
                 <a:latin typeface="Segoe UI"/>
               </a:defRPr>
@@ -5384,9 +5709,9 @@
           <a:solidFill>
             <a:srgbClr val="1B365D"/>
           </a:solidFill>
-          <a:ln>
+          <a:ln w="19050">
             <a:solidFill>
-              <a:srgbClr val="1B365D"/>
+              <a:srgbClr val="29B6D8"/>
             </a:solidFill>
           </a:ln>
         </p:spPr>
@@ -5476,11 +5801,11 @@
             <a:avLst/>
           </a:prstGeom>
           <a:solidFill>
-            <a:srgbClr val="F4FAFC"/>
+            <a:srgbClr val="101C30"/>
           </a:solidFill>
-          <a:ln>
+          <a:ln w="19050">
             <a:solidFill>
-              <a:srgbClr val="F4FAFC"/>
+              <a:srgbClr val="1B2C49"/>
             </a:solidFill>
           </a:ln>
         </p:spPr>
@@ -5531,7 +5856,7 @@
             <a:pPr>
               <a:defRPr sz="1200" b="1">
                 <a:solidFill>
-                  <a:srgbClr val="1B365D"/>
+                  <a:srgbClr val="29B6D8"/>
                 </a:solidFill>
                 <a:latin typeface="Segoe UI"/>
               </a:defRPr>
@@ -5544,7 +5869,7 @@
             <a:pPr>
               <a:defRPr sz="1000">
                 <a:solidFill>
-                  <a:srgbClr val="111827"/>
+                  <a:srgbClr val="FFFFFF"/>
                 </a:solidFill>
                 <a:latin typeface="Segoe UI"/>
               </a:defRPr>
@@ -5569,7 +5894,7 @@
     <p:bg>
       <p:bgPr>
         <a:solidFill>
-          <a:srgbClr val="F4FAFC"/>
+          <a:srgbClr val="071321"/>
         </a:solidFill>
         <a:effectLst/>
       </p:bgPr>
@@ -5642,7 +5967,7 @@
             <a:pPr>
               <a:defRPr sz="2800" b="1">
                 <a:solidFill>
-                  <a:srgbClr val="1B365D"/>
+                  <a:srgbClr val="FFFFFF"/>
                 </a:solidFill>
                 <a:latin typeface="Segoe UI"/>
               </a:defRPr>
@@ -5668,11 +5993,11 @@
             <a:avLst/>
           </a:prstGeom>
           <a:solidFill>
-            <a:srgbClr val="FFFFFF"/>
+            <a:srgbClr val="101C30"/>
           </a:solidFill>
-          <a:ln>
+          <a:ln w="19050">
             <a:solidFill>
-              <a:srgbClr val="FFFFFF"/>
+              <a:srgbClr val="1B2C49"/>
             </a:solidFill>
           </a:ln>
         </p:spPr>
@@ -5721,9 +6046,9 @@
           <a:lstStyle/>
           <a:p>
             <a:pPr algn="ctr">
-              <a:defRPr sz="4400" b="1">
-                <a:solidFill>
-                  <a:srgbClr val="16A34A"/>
+              <a:defRPr sz="4000" b="1">
+                <a:solidFill>
+                  <a:srgbClr val="22C55E"/>
                 </a:solidFill>
                 <a:latin typeface="Segoe UI"/>
               </a:defRPr>
@@ -5739,7 +6064,7 @@
               </a:spcBef>
               <a:defRPr sz="1000" b="1">
                 <a:solidFill>
-                  <a:srgbClr val="6B7280"/>
+                  <a:srgbClr val="FFFFFF"/>
                 </a:solidFill>
                 <a:latin typeface="Segoe UI"/>
               </a:defRPr>
@@ -5765,11 +6090,11 @@
             <a:avLst/>
           </a:prstGeom>
           <a:solidFill>
-            <a:srgbClr val="FFFFFF"/>
+            <a:srgbClr val="101C30"/>
           </a:solidFill>
-          <a:ln>
+          <a:ln w="19050">
             <a:solidFill>
-              <a:srgbClr val="FFFFFF"/>
+              <a:srgbClr val="1B2C49"/>
             </a:solidFill>
           </a:ln>
         </p:spPr>
@@ -5818,9 +6143,9 @@
           <a:lstStyle/>
           <a:p>
             <a:pPr algn="ctr">
-              <a:defRPr sz="4400" b="1">
-                <a:solidFill>
-                  <a:srgbClr val="16A34A"/>
+              <a:defRPr sz="4000" b="1">
+                <a:solidFill>
+                  <a:srgbClr val="22C55E"/>
                 </a:solidFill>
                 <a:latin typeface="Segoe UI"/>
               </a:defRPr>
@@ -5836,7 +6161,7 @@
               </a:spcBef>
               <a:defRPr sz="1000" b="1">
                 <a:solidFill>
-                  <a:srgbClr val="6B7280"/>
+                  <a:srgbClr val="FFFFFF"/>
                 </a:solidFill>
                 <a:latin typeface="Segoe UI"/>
               </a:defRPr>
@@ -5862,11 +6187,11 @@
             <a:avLst/>
           </a:prstGeom>
           <a:solidFill>
-            <a:srgbClr val="FFFFFF"/>
+            <a:srgbClr val="101C30"/>
           </a:solidFill>
-          <a:ln>
+          <a:ln w="19050">
             <a:solidFill>
-              <a:srgbClr val="FFFFFF"/>
+              <a:srgbClr val="1B2C49"/>
             </a:solidFill>
           </a:ln>
         </p:spPr>
@@ -5915,9 +6240,9 @@
           <a:lstStyle/>
           <a:p>
             <a:pPr algn="ctr">
-              <a:defRPr sz="4400" b="1">
-                <a:solidFill>
-                  <a:srgbClr val="16A34A"/>
+              <a:defRPr sz="4000" b="1">
+                <a:solidFill>
+                  <a:srgbClr val="22C55E"/>
                 </a:solidFill>
                 <a:latin typeface="Segoe UI"/>
               </a:defRPr>
@@ -5933,7 +6258,7 @@
               </a:spcBef>
               <a:defRPr sz="1000" b="1">
                 <a:solidFill>
-                  <a:srgbClr val="6B7280"/>
+                  <a:srgbClr val="FFFFFF"/>
                 </a:solidFill>
                 <a:latin typeface="Segoe UI"/>
               </a:defRPr>
@@ -5959,11 +6284,11 @@
             <a:avLst/>
           </a:prstGeom>
           <a:solidFill>
-            <a:srgbClr val="FFFFFF"/>
+            <a:srgbClr val="101C30"/>
           </a:solidFill>
-          <a:ln>
+          <a:ln w="19050">
             <a:solidFill>
-              <a:srgbClr val="FFFFFF"/>
+              <a:srgbClr val="1B2C49"/>
             </a:solidFill>
           </a:ln>
         </p:spPr>
@@ -6095,7 +6420,7 @@
                       <a:pPr algn="l">
                         <a:defRPr sz="1000" b="1">
                           <a:solidFill>
-                            <a:srgbClr val="111827"/>
+                            <a:srgbClr val="FFFFFF"/>
                           </a:solidFill>
                           <a:latin typeface="Segoe UI"/>
                         </a:defRPr>
@@ -6107,7 +6432,7 @@
                   </a:txBody>
                   <a:tcPr>
                     <a:solidFill>
-                      <a:srgbClr val="FFFFFF"/>
+                      <a:srgbClr val="101C30"/>
                     </a:solidFill>
                   </a:tcPr>
                 </a:tc>
@@ -6117,9 +6442,9 @@
                     <a:lstStyle/>
                     <a:p>
                       <a:pPr algn="l">
-                        <a:defRPr sz="900" b="0">
+                        <a:defRPr sz="950" b="0">
                           <a:solidFill>
-                            <a:srgbClr val="111827"/>
+                            <a:srgbClr val="9CA3AF"/>
                           </a:solidFill>
                           <a:latin typeface="Segoe UI"/>
                         </a:defRPr>
@@ -6131,7 +6456,7 @@
                   </a:txBody>
                   <a:tcPr>
                     <a:solidFill>
-                      <a:srgbClr val="FFFFFF"/>
+                      <a:srgbClr val="101C30"/>
                     </a:solidFill>
                   </a:tcPr>
                 </a:tc>
@@ -6141,21 +6466,21 @@
                     <a:lstStyle/>
                     <a:p>
                       <a:pPr algn="ctr">
-                        <a:defRPr sz="900" b="0">
+                        <a:defRPr sz="950" b="0">
                           <a:solidFill>
-                            <a:srgbClr val="16A34A"/>
+                            <a:srgbClr val="22C55E"/>
                           </a:solidFill>
                           <a:latin typeface="Segoe UI"/>
                         </a:defRPr>
                       </a:pPr>
                       <a:r>
-                        <a:t>Économie de 30% sur le kWh variable</a:t>
+                        <a:t>Économie de 30% sur le kWh</a:t>
                       </a:r>
                     </a:p>
                   </a:txBody>
                   <a:tcPr>
                     <a:solidFill>
-                      <a:srgbClr val="FFFFFF"/>
+                      <a:srgbClr val="101C30"/>
                     </a:solidFill>
                   </a:tcPr>
                 </a:tc>
@@ -6169,7 +6494,7 @@
                       <a:pPr algn="l">
                         <a:defRPr sz="1000" b="1">
                           <a:solidFill>
-                            <a:srgbClr val="111827"/>
+                            <a:srgbClr val="FFFFFF"/>
                           </a:solidFill>
                           <a:latin typeface="Segoe UI"/>
                         </a:defRPr>
@@ -6181,7 +6506,7 @@
                   </a:txBody>
                   <a:tcPr>
                     <a:solidFill>
-                      <a:srgbClr val="F4FAFC"/>
+                      <a:srgbClr val="071321"/>
                     </a:solidFill>
                   </a:tcPr>
                 </a:tc>
@@ -6191,21 +6516,21 @@
                     <a:lstStyle/>
                     <a:p>
                       <a:pPr algn="l">
-                        <a:defRPr sz="900" b="0">
+                        <a:defRPr sz="950" b="0">
                           <a:solidFill>
-                            <a:srgbClr val="111827"/>
+                            <a:srgbClr val="9CA3AF"/>
                           </a:solidFill>
                           <a:latin typeface="Segoe UI"/>
                         </a:defRPr>
                       </a:pPr>
                       <a:r>
-                        <a:t>Réduction de la prime fixe de puissance souscrite indexée sur le volume de la chambre</a:t>
+                        <a:t>Réduction de la puissance souscrite indexée sur le volume de la chambre</a:t>
                       </a:r>
                     </a:p>
                   </a:txBody>
                   <a:tcPr>
                     <a:solidFill>
-                      <a:srgbClr val="F4FAFC"/>
+                      <a:srgbClr val="071321"/>
                     </a:solidFill>
                   </a:tcPr>
                 </a:tc>
@@ -6215,21 +6540,21 @@
                     <a:lstStyle/>
                     <a:p>
                       <a:pPr algn="ctr">
-                        <a:defRPr sz="900" b="0">
+                        <a:defRPr sz="950" b="0">
                           <a:solidFill>
-                            <a:srgbClr val="16A34A"/>
+                            <a:srgbClr val="22C55E"/>
                           </a:solidFill>
                           <a:latin typeface="Segoe UI"/>
                         </a:defRPr>
                       </a:pPr>
                       <a:r>
-                        <a:t>Gain annuel fixe (Sonelgaz)</a:t>
+                        <a:t>Gain annuel fixe</a:t>
                       </a:r>
                     </a:p>
                   </a:txBody>
                   <a:tcPr>
                     <a:solidFill>
-                      <a:srgbClr val="F4FAFC"/>
+                      <a:srgbClr val="071321"/>
                     </a:solidFill>
                   </a:tcPr>
                 </a:tc>
@@ -6243,7 +6568,7 @@
                       <a:pPr algn="l">
                         <a:defRPr sz="1000" b="1">
                           <a:solidFill>
-                            <a:srgbClr val="111827"/>
+                            <a:srgbClr val="FFFFFF"/>
                           </a:solidFill>
                           <a:latin typeface="Segoe UI"/>
                         </a:defRPr>
@@ -6255,7 +6580,7 @@
                   </a:txBody>
                   <a:tcPr>
                     <a:solidFill>
-                      <a:srgbClr val="FFFFFF"/>
+                      <a:srgbClr val="101C30"/>
                     </a:solidFill>
                   </a:tcPr>
                 </a:tc>
@@ -6265,21 +6590,21 @@
                     <a:lstStyle/>
                     <a:p>
                       <a:pPr algn="l">
-                        <a:defRPr sz="900" b="0">
+                        <a:defRPr sz="950" b="0">
                           <a:solidFill>
-                            <a:srgbClr val="111827"/>
+                            <a:srgbClr val="9CA3AF"/>
                           </a:solidFill>
                           <a:latin typeface="Segoe UI"/>
                         </a:defRPr>
                       </a:pPr>
                       <a:r>
-                        <a:t>Sauvegarde statistique du stock de marchandises face aux délestages et coupures d'électricité</a:t>
+                        <a:t>Sécurisation active du stock de marchandises face aux coupures</a:t>
                       </a:r>
                     </a:p>
                   </a:txBody>
                   <a:tcPr>
                     <a:solidFill>
-                      <a:srgbClr val="FFFFFF"/>
+                      <a:srgbClr val="101C30"/>
                     </a:solidFill>
                   </a:tcPr>
                 </a:tc>
@@ -6289,21 +6614,21 @@
                     <a:lstStyle/>
                     <a:p>
                       <a:pPr algn="ctr">
-                        <a:defRPr sz="900" b="0">
+                        <a:defRPr sz="950" b="0">
                           <a:solidFill>
-                            <a:srgbClr val="16A34A"/>
+                            <a:srgbClr val="22C55E"/>
                           </a:solidFill>
                           <a:latin typeface="Segoe UI"/>
                         </a:defRPr>
                       </a:pPr>
                       <a:r>
-                        <a:t>Risques de pertes éliminés</a:t>
+                        <a:t>Pertes de stock éliminées</a:t>
                       </a:r>
                     </a:p>
                   </a:txBody>
                   <a:tcPr>
                     <a:solidFill>
-                      <a:srgbClr val="FFFFFF"/>
+                      <a:srgbClr val="101C30"/>
                     </a:solidFill>
                   </a:tcPr>
                 </a:tc>
@@ -6317,7 +6642,7 @@
                       <a:pPr algn="l">
                         <a:defRPr sz="1000" b="1">
                           <a:solidFill>
-                            <a:srgbClr val="111827"/>
+                            <a:srgbClr val="FFFFFF"/>
                           </a:solidFill>
                           <a:latin typeface="Segoe UI"/>
                         </a:defRPr>
@@ -6329,7 +6654,7 @@
                   </a:txBody>
                   <a:tcPr>
                     <a:solidFill>
-                      <a:srgbClr val="F4FAFC"/>
+                      <a:srgbClr val="071321"/>
                     </a:solidFill>
                   </a:tcPr>
                 </a:tc>
@@ -6339,21 +6664,21 @@
                     <a:lstStyle/>
                     <a:p>
                       <a:pPr algn="l">
-                        <a:defRPr sz="900" b="0">
+                        <a:defRPr sz="950" b="0">
                           <a:solidFill>
-                            <a:srgbClr val="111827"/>
+                            <a:srgbClr val="9CA3AF"/>
                           </a:solidFill>
                           <a:latin typeface="Segoe UI"/>
                         </a:defRPr>
                       </a:pPr>
                       <a:r>
-                        <a:t>Investissement remboursé par les économies opérationnelles nettes cumulées</a:t>
+                        <a:t>Investissement amorti par les économies opérationnelles nettes</a:t>
                       </a:r>
                     </a:p>
                   </a:txBody>
                   <a:tcPr>
                     <a:solidFill>
-                      <a:srgbClr val="F4FAFC"/>
+                      <a:srgbClr val="071321"/>
                     </a:solidFill>
                   </a:tcPr>
                 </a:tc>
@@ -6363,9 +6688,9 @@
                     <a:lstStyle/>
                     <a:p>
                       <a:pPr algn="ctr">
-                        <a:defRPr sz="900" b="1">
+                        <a:defRPr sz="950" b="1">
                           <a:solidFill>
-                            <a:srgbClr val="1B365D"/>
+                            <a:srgbClr val="29B6D8"/>
                           </a:solidFill>
                           <a:latin typeface="Segoe UI"/>
                         </a:defRPr>
@@ -6377,7 +6702,7 @@
                   </a:txBody>
                   <a:tcPr>
                     <a:solidFill>
-                      <a:srgbClr val="F4FAFC"/>
+                      <a:srgbClr val="071321"/>
                     </a:solidFill>
                   </a:tcPr>
                 </a:tc>
@@ -6400,7 +6725,7 @@
     <p:bg>
       <p:bgPr>
         <a:solidFill>
-          <a:srgbClr val="F4FAFC"/>
+          <a:srgbClr val="071321"/>
         </a:solidFill>
         <a:effectLst/>
       </p:bgPr>
@@ -6473,7 +6798,7 @@
             <a:pPr>
               <a:defRPr sz="2800" b="1">
                 <a:solidFill>
-                  <a:srgbClr val="1B365D"/>
+                  <a:srgbClr val="FFFFFF"/>
                 </a:solidFill>
                 <a:latin typeface="Segoe UI"/>
               </a:defRPr>
@@ -6499,11 +6824,11 @@
             <a:avLst/>
           </a:prstGeom>
           <a:solidFill>
-            <a:srgbClr val="FFFFFF"/>
+            <a:srgbClr val="101C30"/>
           </a:solidFill>
-          <a:ln>
+          <a:ln w="19050">
             <a:solidFill>
-              <a:srgbClr val="FFFFFF"/>
+              <a:srgbClr val="1B2C49"/>
             </a:solidFill>
           </a:ln>
         </p:spPr>
@@ -6557,7 +6882,7 @@
               </a:spcAft>
               <a:defRPr sz="1600" b="1">
                 <a:solidFill>
-                  <a:srgbClr val="1B365D"/>
+                  <a:srgbClr val="29B6D8"/>
                 </a:solidFill>
                 <a:latin typeface="Segoe UI"/>
               </a:defRPr>
@@ -6573,7 +6898,7 @@
               </a:spcAft>
               <a:defRPr sz="1100">
                 <a:solidFill>
-                  <a:srgbClr val="111827"/>
+                  <a:srgbClr val="FFFFFF"/>
                 </a:solidFill>
                 <a:latin typeface="Segoe UI"/>
               </a:defRPr>
@@ -6589,7 +6914,7 @@
               </a:spcAft>
               <a:defRPr sz="1100">
                 <a:solidFill>
-                  <a:srgbClr val="111827"/>
+                  <a:srgbClr val="FFFFFF"/>
                 </a:solidFill>
                 <a:latin typeface="Segoe UI"/>
               </a:defRPr>
@@ -6605,7 +6930,7 @@
               </a:spcAft>
               <a:defRPr sz="1100">
                 <a:solidFill>
-                  <a:srgbClr val="111827"/>
+                  <a:srgbClr val="FFFFFF"/>
                 </a:solidFill>
                 <a:latin typeface="Segoe UI"/>
               </a:defRPr>
@@ -6631,11 +6956,11 @@
             <a:avLst/>
           </a:prstGeom>
           <a:solidFill>
-            <a:srgbClr val="FFFFFF"/>
+            <a:srgbClr val="101C30"/>
           </a:solidFill>
-          <a:ln>
+          <a:ln w="19050">
             <a:solidFill>
-              <a:srgbClr val="FFFFFF"/>
+              <a:srgbClr val="1B2C49"/>
             </a:solidFill>
           </a:ln>
         </p:spPr>
@@ -6689,7 +7014,7 @@
               </a:spcAft>
               <a:defRPr sz="1600" b="1">
                 <a:solidFill>
-                  <a:srgbClr val="1B365D"/>
+                  <a:srgbClr val="29B6D8"/>
                 </a:solidFill>
                 <a:latin typeface="Segoe UI"/>
               </a:defRPr>
@@ -6705,7 +7030,7 @@
               </a:spcAft>
               <a:defRPr sz="1100">
                 <a:solidFill>
-                  <a:srgbClr val="111827"/>
+                  <a:srgbClr val="FFFFFF"/>
                 </a:solidFill>
                 <a:latin typeface="Segoe UI"/>
               </a:defRPr>
@@ -6721,7 +7046,7 @@
               </a:spcAft>
               <a:defRPr sz="1100">
                 <a:solidFill>
-                  <a:srgbClr val="111827"/>
+                  <a:srgbClr val="FFFFFF"/>
                 </a:solidFill>
                 <a:latin typeface="Segoe UI"/>
               </a:defRPr>
@@ -6737,7 +7062,7 @@
               </a:spcAft>
               <a:defRPr sz="1100">
                 <a:solidFill>
-                  <a:srgbClr val="111827"/>
+                  <a:srgbClr val="FFFFFF"/>
                 </a:solidFill>
                 <a:latin typeface="Segoe UI"/>
               </a:defRPr>
@@ -6753,7 +7078,7 @@
               </a:spcAft>
               <a:defRPr sz="1100">
                 <a:solidFill>
-                  <a:srgbClr val="111827"/>
+                  <a:srgbClr val="FFFFFF"/>
                 </a:solidFill>
                 <a:latin typeface="Segoe UI"/>
               </a:defRPr>

</xml_diff>

<commit_message>
style(pitch): rebrand to KryoDrop, add student authors, increase text size, and center alignment
</commit_message>
<xml_diff>
--- a/kryodrop_pitch_deck.pptx
+++ b/kryodrop_pitch_deck.pptx
@@ -3111,8 +3111,8 @@
         </p:nvSpPr>
         <p:spPr>
           <a:xfrm>
-            <a:off x="914400" y="1828800"/>
-            <a:ext cx="109728" cy="3200400"/>
+            <a:off x="914400" y="1463040"/>
+            <a:ext cx="109728" cy="3931920"/>
           </a:xfrm>
           <a:prstGeom prst="rect">
             <a:avLst/>
@@ -3156,8 +3156,8 @@
         </p:nvSpPr>
         <p:spPr>
           <a:xfrm>
-            <a:off x="1280160" y="1737360"/>
-            <a:ext cx="6583680" cy="3657600"/>
+            <a:off x="1280160" y="1371600"/>
+            <a:ext cx="6583680" cy="2560320"/>
           </a:xfrm>
           <a:prstGeom prst="rect">
             <a:avLst/>
@@ -3198,7 +3198,7 @@
               </a:defRPr>
             </a:pPr>
             <a:r>
-              <a:t>ThermaShift : Le stockage thermique intelligent pour l'agro-industrie</a:t>
+              <a:t>Le stockage thermique intelligent pour l'agro-industrie</a:t>
             </a:r>
           </a:p>
           <a:p>
@@ -3211,14 +3211,82 @@
               </a:defRPr>
             </a:pPr>
             <a:r>
-              <a:t>Solution brevetée de stockage thermique par matériau à changement de phase (MCP-TES) pour optimiser et décarboner les chambres froides industrielles.</a:t>
+              <a:t>Solution innovante de stockage thermique par matériau à changement de phase (MCP-TES) pour optimiser et décarboner les chambres froides industrielles.</a:t>
+            </a:r>
+          </a:p>
+        </p:txBody>
+      </p:sp>
+      <p:sp>
+        <p:nvSpPr>
+          <p:cNvPr id="4" name="TextBox 3"/>
+          <p:cNvSpPr txBox="1"/>
+          <p:nvPr/>
+        </p:nvSpPr>
+        <p:spPr>
+          <a:xfrm>
+            <a:off x="1280160" y="4114800"/>
+            <a:ext cx="6583680" cy="1280160"/>
+          </a:xfrm>
+          <a:prstGeom prst="rect">
+            <a:avLst/>
+          </a:prstGeom>
+          <a:noFill/>
+        </p:spPr>
+        <p:txBody>
+          <a:bodyPr wrap="square" lIns="0" tIns="0" rIns="0" bIns="0">
+            <a:spAutoFit/>
+          </a:bodyPr>
+          <a:lstStyle/>
+          <a:p>
+            <a:pPr>
+              <a:spcAft>
+                <a:spcPts val="600"/>
+              </a:spcAft>
+              <a:defRPr sz="1100" b="1">
+                <a:solidFill>
+                  <a:srgbClr val="29B6D8"/>
+                </a:solidFill>
+                <a:latin typeface="Segoe UI"/>
+              </a:defRPr>
+            </a:pPr>
+            <a:r>
+              <a:t>PROJET DÉVELOPPÉ PAR :</a:t>
+            </a:r>
+          </a:p>
+          <a:p>
+            <a:pPr>
+              <a:spcAft>
+                <a:spcPts val="400"/>
+              </a:spcAft>
+              <a:defRPr sz="1100" b="1">
+                <a:solidFill>
+                  <a:srgbClr val="FFFFFF"/>
+                </a:solidFill>
+                <a:latin typeface="Segoe UI"/>
+              </a:defRPr>
+            </a:pPr>
+            <a:r>
+              <a:t>BOUIRA Islem Akram — Étudiant 5ème année mécanique (Systèmes Énergétiques) @ ENPO</a:t>
+            </a:r>
+          </a:p>
+          <a:p>
+            <a:pPr>
+              <a:defRPr sz="1100" b="1">
+                <a:solidFill>
+                  <a:srgbClr val="FFFFFF"/>
+                </a:solidFill>
+                <a:latin typeface="Segoe UI"/>
+              </a:defRPr>
+            </a:pPr>
+            <a:r>
+              <a:t>ZANE Mohamed Elamine — Étudiant 4ème année électrotechnique @ ENPA</a:t>
             </a:r>
           </a:p>
         </p:txBody>
       </p:sp>
       <p:pic>
         <p:nvPicPr>
-          <p:cNvPr id="4" name="Picture 3" descr="logo_icon.png"/>
+          <p:cNvPr id="5" name="Picture 4" descr="logo_icon.png"/>
           <p:cNvPicPr>
             <a:picLocks noChangeAspect="1"/>
           </p:cNvPicPr>
@@ -3242,7 +3310,7 @@
       </p:pic>
       <p:sp>
         <p:nvSpPr>
-          <p:cNvPr id="5" name="TextBox 4"/>
+          <p:cNvPr id="6" name="TextBox 5"/>
           <p:cNvSpPr txBox="1"/>
           <p:nvPr/>
         </p:nvSpPr>
@@ -3257,7 +3325,7 @@
           <a:noFill/>
         </p:spPr>
         <p:txBody>
-          <a:bodyPr wrap="square" lIns="0" tIns="0" rIns="0" bIns="0">
+          <a:bodyPr wrap="square" lIns="0" tIns="0" rIns="0" bIns="0" anchor="ctr">
             <a:spAutoFit/>
           </a:bodyPr>
           <a:lstStyle/>
@@ -3472,16 +3540,16 @@
           <a:noFill/>
         </p:spPr>
         <p:txBody>
-          <a:bodyPr wrap="square" lIns="0" tIns="0" rIns="0" bIns="0">
+          <a:bodyPr wrap="square" lIns="0" tIns="0" rIns="0" bIns="0" anchor="ctr">
             <a:spAutoFit/>
           </a:bodyPr>
           <a:lstStyle/>
           <a:p>
-            <a:pPr>
+            <a:pPr algn="ctr">
               <a:spcAft>
                 <a:spcPts val="1200"/>
               </a:spcAft>
-              <a:defRPr sz="1400" b="1">
+              <a:defRPr sz="1500" b="1">
                 <a:solidFill>
                   <a:srgbClr val="29B6D8"/>
                 </a:solidFill>
@@ -3493,11 +3561,8 @@
             </a:r>
           </a:p>
           <a:p>
-            <a:pPr>
-              <a:spcAft>
-                <a:spcPts val="800"/>
-              </a:spcAft>
-              <a:defRPr sz="1050">
+            <a:pPr algn="ctr">
+              <a:defRPr sz="1250">
                 <a:solidFill>
                   <a:srgbClr val="FFFFFF"/>
                 </a:solidFill>
@@ -3608,16 +3673,16 @@
           <a:noFill/>
         </p:spPr>
         <p:txBody>
-          <a:bodyPr wrap="square" lIns="0" tIns="0" rIns="0" bIns="0">
+          <a:bodyPr wrap="square" lIns="0" tIns="0" rIns="0" bIns="0" anchor="ctr">
             <a:spAutoFit/>
           </a:bodyPr>
           <a:lstStyle/>
           <a:p>
-            <a:pPr>
+            <a:pPr algn="ctr">
               <a:spcAft>
                 <a:spcPts val="1200"/>
               </a:spcAft>
-              <a:defRPr sz="1400" b="1">
+              <a:defRPr sz="1500" b="1">
                 <a:solidFill>
                   <a:srgbClr val="29B6D8"/>
                 </a:solidFill>
@@ -3629,11 +3694,8 @@
             </a:r>
           </a:p>
           <a:p>
-            <a:pPr>
-              <a:spcAft>
-                <a:spcPts val="800"/>
-              </a:spcAft>
-              <a:defRPr sz="1050">
+            <a:pPr algn="ctr">
+              <a:defRPr sz="1250">
                 <a:solidFill>
                   <a:srgbClr val="FFFFFF"/>
                 </a:solidFill>
@@ -3744,16 +3806,16 @@
           <a:noFill/>
         </p:spPr>
         <p:txBody>
-          <a:bodyPr wrap="square" lIns="0" tIns="0" rIns="0" bIns="0">
+          <a:bodyPr wrap="square" lIns="0" tIns="0" rIns="0" bIns="0" anchor="ctr">
             <a:spAutoFit/>
           </a:bodyPr>
           <a:lstStyle/>
           <a:p>
-            <a:pPr>
+            <a:pPr algn="ctr">
               <a:spcAft>
                 <a:spcPts val="1200"/>
               </a:spcAft>
-              <a:defRPr sz="1400" b="1">
+              <a:defRPr sz="1500" b="1">
                 <a:solidFill>
                   <a:srgbClr val="29B6D8"/>
                 </a:solidFill>
@@ -3765,11 +3827,8 @@
             </a:r>
           </a:p>
           <a:p>
-            <a:pPr>
-              <a:spcAft>
-                <a:spcPts val="800"/>
-              </a:spcAft>
-              <a:defRPr sz="1050">
+            <a:pPr algn="ctr">
+              <a:defRPr sz="1250">
                 <a:solidFill>
                   <a:srgbClr val="FFFFFF"/>
                 </a:solidFill>
@@ -3844,7 +3903,7 @@
           <a:noFill/>
         </p:spPr>
         <p:txBody>
-          <a:bodyPr wrap="square" lIns="0" rIns="0" tIns="0" bIns="0">
+          <a:bodyPr wrap="square" lIns="0" rIns="0" tIns="0" bIns="0" anchor="ctr">
             <a:spAutoFit/>
           </a:bodyPr>
           <a:lstStyle/>
@@ -3941,7 +4000,7 @@
           <a:noFill/>
         </p:spPr>
         <p:txBody>
-          <a:bodyPr wrap="square" lIns="0" rIns="0" tIns="0" bIns="0">
+          <a:bodyPr wrap="square" lIns="0" rIns="0" tIns="0" bIns="0" anchor="ctr">
             <a:spAutoFit/>
           </a:bodyPr>
           <a:lstStyle/>
@@ -4038,7 +4097,7 @@
           <a:noFill/>
         </p:spPr>
         <p:txBody>
-          <a:bodyPr wrap="square" lIns="0" rIns="0" tIns="0" bIns="0">
+          <a:bodyPr wrap="square" lIns="0" rIns="0" tIns="0" bIns="0" anchor="ctr">
             <a:spAutoFit/>
           </a:bodyPr>
           <a:lstStyle/>
@@ -4166,7 +4225,7 @@
               </a:defRPr>
             </a:pPr>
             <a:r>
-              <a:t>KryoDrop : Charger la Nuit, Libérer le Jour</a:t>
+              <a:t>KryoDrop : Charger la Nuit, Restituer le Jour</a:t>
             </a:r>
           </a:p>
         </p:txBody>
@@ -4233,16 +4292,16 @@
           <a:noFill/>
         </p:spPr>
         <p:txBody>
-          <a:bodyPr wrap="square" lIns="0" rIns="0" tIns="0" bIns="0">
+          <a:bodyPr wrap="square" lIns="0" rIns="0" tIns="0" bIns="0" anchor="ctr">
             <a:spAutoFit/>
           </a:bodyPr>
           <a:lstStyle/>
           <a:p>
-            <a:pPr>
+            <a:pPr algn="ctr">
               <a:spcAft>
-                <a:spcPts val="1200"/>
+                <a:spcPts val="1000"/>
               </a:spcAft>
-              <a:defRPr sz="1600" b="1">
+              <a:defRPr sz="1700" b="1">
                 <a:solidFill>
                   <a:srgbClr val="29B6D8"/>
                 </a:solidFill>
@@ -4254,11 +4313,11 @@
             </a:r>
           </a:p>
           <a:p>
-            <a:pPr>
+            <a:pPr algn="ctr">
               <a:spcAft>
                 <a:spcPts val="800"/>
               </a:spcAft>
-              <a:defRPr sz="1100">
+              <a:defRPr sz="1250">
                 <a:solidFill>
                   <a:srgbClr val="FFFFFF"/>
                 </a:solidFill>
@@ -4266,15 +4325,15 @@
               </a:defRPr>
             </a:pPr>
             <a:r>
-              <a:t>• Stockage de Froid (Nuit) : Le compresseur fonctionne de nuit pendant les Heures Creuses (tarif réduit). Le COP nocturne est supérieur de 20% grâce à la fraîcheur de l'air extérieur, permettant une solidification du MCP (paraffine) à haute efficacité énergétique.</a:t>
-            </a:r>
-          </a:p>
-          <a:p>
-            <a:pPr>
+              <a:t>• Stockage de Froid (Nuit) : Le compresseur fonctionne de nuit pendant les Heures Creuses (tarif réduit). Le COP nocturne est supérieur de 20% grâce à la fraîcheur de l'air extérieur, permettant une solidification du MCP à haute efficacité énergétique.</a:t>
+            </a:r>
+          </a:p>
+          <a:p>
+            <a:pPr algn="ctr">
               <a:spcAft>
                 <a:spcPts val="800"/>
               </a:spcAft>
-              <a:defRPr sz="1100">
+              <a:defRPr sz="1250">
                 <a:solidFill>
                   <a:srgbClr val="FFFFFF"/>
                 </a:solidFill>
@@ -4286,11 +4345,11 @@
             </a:r>
           </a:p>
           <a:p>
-            <a:pPr>
+            <a:pPr algn="ctr">
               <a:spcAft>
                 <a:spcPts val="800"/>
               </a:spcAft>
-              <a:defRPr sz="1100">
+              <a:defRPr sz="1250">
                 <a:solidFill>
                   <a:srgbClr val="FFFFFF"/>
                 </a:solidFill>
@@ -4365,16 +4424,16 @@
           <a:noFill/>
         </p:spPr>
         <p:txBody>
-          <a:bodyPr wrap="square" lIns="0" tIns="0" rIns="0" bIns="0">
+          <a:bodyPr wrap="square" lIns="0" tIns="0" rIns="0" bIns="0" anchor="ctr">
             <a:spAutoFit/>
           </a:bodyPr>
           <a:lstStyle/>
           <a:p>
-            <a:pPr>
+            <a:pPr algn="ctr">
               <a:spcAft>
                 <a:spcPts val="800"/>
               </a:spcAft>
-              <a:defRPr sz="1500" b="1">
+              <a:defRPr sz="1600" b="1">
                 <a:solidFill>
                   <a:srgbClr val="29B6D8"/>
                 </a:solidFill>
@@ -4386,8 +4445,8 @@
             </a:r>
           </a:p>
           <a:p>
-            <a:pPr>
-              <a:defRPr sz="1050">
+            <a:pPr algn="ctr">
+              <a:defRPr sz="1250">
                 <a:solidFill>
                   <a:srgbClr val="FFFFFF"/>
                 </a:solidFill>
@@ -4462,16 +4521,16 @@
           <a:noFill/>
         </p:spPr>
         <p:txBody>
-          <a:bodyPr wrap="square" lIns="0" tIns="0" rIns="0" bIns="0">
+          <a:bodyPr wrap="square" lIns="0" tIns="0" rIns="0" bIns="0" anchor="ctr">
             <a:spAutoFit/>
           </a:bodyPr>
           <a:lstStyle/>
           <a:p>
-            <a:pPr>
+            <a:pPr algn="ctr">
               <a:spcAft>
                 <a:spcPts val="800"/>
               </a:spcAft>
-              <a:defRPr sz="1500" b="1">
+              <a:defRPr sz="1600" b="1">
                 <a:solidFill>
                   <a:srgbClr val="29B6D8"/>
                 </a:solidFill>
@@ -4483,8 +4542,8 @@
             </a:r>
           </a:p>
           <a:p>
-            <a:pPr>
-              <a:defRPr sz="1050">
+            <a:pPr algn="ctr">
+              <a:defRPr sz="1250">
                 <a:solidFill>
                   <a:srgbClr val="FFFFFF"/>
                 </a:solidFill>
@@ -4747,16 +4806,16 @@
           <a:noFill/>
         </p:spPr>
         <p:txBody>
-          <a:bodyPr wrap="square" lIns="0" rIns="0" tIns="0" bIns="0">
+          <a:bodyPr wrap="square" lIns="0" rIns="0" tIns="0" bIns="0" anchor="ctr">
             <a:spAutoFit/>
           </a:bodyPr>
           <a:lstStyle/>
           <a:p>
-            <a:pPr>
+            <a:pPr algn="ctr">
               <a:spcAft>
-                <a:spcPts val="1200"/>
+                <a:spcPts val="1000"/>
               </a:spcAft>
-              <a:defRPr sz="1600" b="1">
+              <a:defRPr sz="1700" b="1">
                 <a:solidFill>
                   <a:srgbClr val="29B6D8"/>
                 </a:solidFill>
@@ -4768,11 +4827,11 @@
             </a:r>
           </a:p>
           <a:p>
-            <a:pPr>
+            <a:pPr algn="ctr">
               <a:spcAft>
                 <a:spcPts val="800"/>
               </a:spcAft>
-              <a:defRPr sz="1100">
+              <a:defRPr sz="1250">
                 <a:solidFill>
                   <a:srgbClr val="FFFFFF"/>
                 </a:solidFill>
@@ -4784,11 +4843,11 @@
             </a:r>
           </a:p>
           <a:p>
-            <a:pPr>
+            <a:pPr algn="ctr">
               <a:spcAft>
                 <a:spcPts val="800"/>
               </a:spcAft>
-              <a:defRPr sz="1100">
+              <a:defRPr sz="1250">
                 <a:solidFill>
                   <a:srgbClr val="FFFFFF"/>
                 </a:solidFill>
@@ -4800,11 +4859,11 @@
             </a:r>
           </a:p>
           <a:p>
-            <a:pPr>
+            <a:pPr algn="ctr">
               <a:spcAft>
                 <a:spcPts val="800"/>
               </a:spcAft>
-              <a:defRPr sz="1100">
+              <a:defRPr sz="1250">
                 <a:solidFill>
                   <a:srgbClr val="FFFFFF"/>
                 </a:solidFill>
@@ -4816,11 +4875,11 @@
             </a:r>
           </a:p>
           <a:p>
-            <a:pPr>
+            <a:pPr algn="ctr">
               <a:spcAft>
                 <a:spcPts val="800"/>
               </a:spcAft>
-              <a:defRPr sz="1100">
+              <a:defRPr sz="1250">
                 <a:solidFill>
                   <a:srgbClr val="FFFFFF"/>
                 </a:solidFill>
@@ -5107,16 +5166,16 @@
           <a:noFill/>
         </p:spPr>
         <p:txBody>
-          <a:bodyPr wrap="square" lIns="0" rIns="0" tIns="0" bIns="0">
+          <a:bodyPr wrap="square" lIns="0" rIns="0" tIns="0" bIns="0" anchor="ctr">
             <a:spAutoFit/>
           </a:bodyPr>
           <a:lstStyle/>
           <a:p>
-            <a:pPr>
+            <a:pPr algn="ctr">
               <a:spcAft>
-                <a:spcPts val="1200"/>
+                <a:spcPts val="1000"/>
               </a:spcAft>
-              <a:defRPr sz="1600" b="1">
+              <a:defRPr sz="1700" b="1">
                 <a:solidFill>
                   <a:srgbClr val="29B6D8"/>
                 </a:solidFill>
@@ -5128,11 +5187,11 @@
             </a:r>
           </a:p>
           <a:p>
-            <a:pPr>
+            <a:pPr algn="ctr">
               <a:spcAft>
                 <a:spcPts val="800"/>
               </a:spcAft>
-              <a:defRPr sz="1100">
+              <a:defRPr sz="1250">
                 <a:solidFill>
                   <a:srgbClr val="FFFFFF"/>
                 </a:solidFill>
@@ -5144,11 +5203,11 @@
             </a:r>
           </a:p>
           <a:p>
-            <a:pPr>
+            <a:pPr algn="ctr">
               <a:spcAft>
                 <a:spcPts val="800"/>
               </a:spcAft>
-              <a:defRPr sz="1100">
+              <a:defRPr sz="1250">
                 <a:solidFill>
                   <a:srgbClr val="FFFFFF"/>
                 </a:solidFill>
@@ -5160,11 +5219,11 @@
             </a:r>
           </a:p>
           <a:p>
-            <a:pPr>
+            <a:pPr algn="ctr">
               <a:spcAft>
                 <a:spcPts val="800"/>
               </a:spcAft>
-              <a:defRPr sz="1100">
+              <a:defRPr sz="1250">
                 <a:solidFill>
                   <a:srgbClr val="FFFFFF"/>
                 </a:solidFill>
@@ -5176,11 +5235,11 @@
             </a:r>
           </a:p>
           <a:p>
-            <a:pPr>
+            <a:pPr algn="ctr">
               <a:spcAft>
                 <a:spcPts val="800"/>
               </a:spcAft>
-              <a:defRPr sz="1100">
+              <a:defRPr sz="1250">
                 <a:solidFill>
                   <a:srgbClr val="FFFFFF"/>
                 </a:solidFill>
@@ -5467,16 +5526,16 @@
           <a:noFill/>
         </p:spPr>
         <p:txBody>
-          <a:bodyPr wrap="square" lIns="0" rIns="0" tIns="0" bIns="0">
+          <a:bodyPr wrap="square" lIns="0" rIns="0" tIns="0" bIns="0" anchor="ctr">
             <a:spAutoFit/>
           </a:bodyPr>
           <a:lstStyle/>
           <a:p>
-            <a:pPr>
+            <a:pPr algn="ctr">
               <a:spcAft>
-                <a:spcPts val="1200"/>
+                <a:spcPts val="1000"/>
               </a:spcAft>
-              <a:defRPr sz="1600" b="1">
+              <a:defRPr sz="1700" b="1">
                 <a:solidFill>
                   <a:srgbClr val="29B6D8"/>
                 </a:solidFill>
@@ -5488,11 +5547,11 @@
             </a:r>
           </a:p>
           <a:p>
-            <a:pPr>
+            <a:pPr algn="ctr">
               <a:spcAft>
                 <a:spcPts val="800"/>
               </a:spcAft>
-              <a:defRPr sz="1100">
+              <a:defRPr sz="1250">
                 <a:solidFill>
                   <a:srgbClr val="FFFFFF"/>
                 </a:solidFill>
@@ -5504,11 +5563,11 @@
             </a:r>
           </a:p>
           <a:p>
-            <a:pPr>
+            <a:pPr algn="ctr">
               <a:spcAft>
                 <a:spcPts val="800"/>
               </a:spcAft>
-              <a:defRPr sz="1100">
+              <a:defRPr sz="1250">
                 <a:solidFill>
                   <a:srgbClr val="FFFFFF"/>
                 </a:solidFill>
@@ -5520,11 +5579,11 @@
             </a:r>
           </a:p>
           <a:p>
-            <a:pPr>
+            <a:pPr algn="ctr">
               <a:spcAft>
                 <a:spcPts val="800"/>
               </a:spcAft>
-              <a:defRPr sz="1100">
+              <a:defRPr sz="1250">
                 <a:solidFill>
                   <a:srgbClr val="FFFFFF"/>
                 </a:solidFill>
@@ -5536,11 +5595,11 @@
             </a:r>
           </a:p>
           <a:p>
-            <a:pPr>
+            <a:pPr algn="ctr">
               <a:spcAft>
                 <a:spcPts val="800"/>
               </a:spcAft>
-              <a:defRPr sz="1100">
+              <a:defRPr sz="1250">
                 <a:solidFill>
                   <a:srgbClr val="FFFFFF"/>
                 </a:solidFill>
@@ -5660,12 +5719,12 @@
           <a:noFill/>
         </p:spPr>
         <p:txBody>
-          <a:bodyPr wrap="square" lIns="0" tIns="0" rIns="0" bIns="0">
+          <a:bodyPr wrap="square" lIns="0" tIns="0" rIns="0" bIns="0" anchor="ctr">
             <a:spAutoFit/>
           </a:bodyPr>
           <a:lstStyle/>
           <a:p>
-            <a:pPr>
+            <a:pPr algn="ctr">
               <a:defRPr sz="1200" b="1">
                 <a:solidFill>
                   <a:srgbClr val="29B6D8"/>
@@ -5678,8 +5737,8 @@
             </a:r>
           </a:p>
           <a:p>
-            <a:pPr>
-              <a:defRPr sz="1000">
+            <a:pPr algn="ctr">
+              <a:defRPr sz="1100">
                 <a:solidFill>
                   <a:srgbClr val="FFFFFF"/>
                 </a:solidFill>
@@ -5754,12 +5813,12 @@
           <a:noFill/>
         </p:spPr>
         <p:txBody>
-          <a:bodyPr wrap="square" lIns="0" tIns="0" rIns="0" bIns="0">
+          <a:bodyPr wrap="square" lIns="0" tIns="0" rIns="0" bIns="0" anchor="ctr">
             <a:spAutoFit/>
           </a:bodyPr>
           <a:lstStyle/>
           <a:p>
-            <a:pPr>
+            <a:pPr algn="ctr">
               <a:defRPr sz="1200" b="1">
                 <a:solidFill>
                   <a:srgbClr val="29B6D8"/>
@@ -5772,8 +5831,8 @@
             </a:r>
           </a:p>
           <a:p>
-            <a:pPr>
-              <a:defRPr sz="1000">
+            <a:pPr algn="ctr">
+              <a:defRPr sz="1100">
                 <a:solidFill>
                   <a:srgbClr val="FFFFFF"/>
                 </a:solidFill>
@@ -5848,12 +5907,12 @@
           <a:noFill/>
         </p:spPr>
         <p:txBody>
-          <a:bodyPr wrap="square" lIns="0" tIns="0" rIns="0" bIns="0">
+          <a:bodyPr wrap="square" lIns="0" tIns="0" rIns="0" bIns="0" anchor="ctr">
             <a:spAutoFit/>
           </a:bodyPr>
           <a:lstStyle/>
           <a:p>
-            <a:pPr>
+            <a:pPr algn="ctr">
               <a:defRPr sz="1200" b="1">
                 <a:solidFill>
                   <a:srgbClr val="29B6D8"/>
@@ -5866,8 +5925,8 @@
             </a:r>
           </a:p>
           <a:p>
-            <a:pPr>
-              <a:defRPr sz="1000">
+            <a:pPr algn="ctr">
+              <a:defRPr sz="1100">
                 <a:solidFill>
                   <a:srgbClr val="FFFFFF"/>
                 </a:solidFill>
@@ -6040,7 +6099,7 @@
           <a:noFill/>
         </p:spPr>
         <p:txBody>
-          <a:bodyPr wrap="square" lIns="0" rIns="0" tIns="0" bIns="0">
+          <a:bodyPr wrap="square" lIns="0" rIns="0" tIns="0" bIns="0" anchor="ctr">
             <a:spAutoFit/>
           </a:bodyPr>
           <a:lstStyle/>
@@ -6137,7 +6196,7 @@
           <a:noFill/>
         </p:spPr>
         <p:txBody>
-          <a:bodyPr wrap="square" lIns="0" rIns="0" tIns="0" bIns="0">
+          <a:bodyPr wrap="square" lIns="0" rIns="0" tIns="0" bIns="0" anchor="ctr">
             <a:spAutoFit/>
           </a:bodyPr>
           <a:lstStyle/>
@@ -6234,7 +6293,7 @@
           <a:noFill/>
         </p:spPr>
         <p:txBody>
-          <a:bodyPr wrap="square" lIns="0" rIns="0" tIns="0" bIns="0">
+          <a:bodyPr wrap="square" lIns="0" rIns="0" tIns="0" bIns="0" anchor="ctr">
             <a:spAutoFit/>
           </a:bodyPr>
           <a:lstStyle/>
@@ -6356,7 +6415,7 @@
                       </a:r>
                     </a:p>
                   </a:txBody>
-                  <a:tcPr>
+                  <a:tcPr anchor="ctr">
                     <a:solidFill>
                       <a:srgbClr val="1B365D"/>
                     </a:solidFill>
@@ -6380,7 +6439,7 @@
                       </a:r>
                     </a:p>
                   </a:txBody>
-                  <a:tcPr>
+                  <a:tcPr anchor="ctr">
                     <a:solidFill>
                       <a:srgbClr val="1B365D"/>
                     </a:solidFill>
@@ -6404,7 +6463,7 @@
                       </a:r>
                     </a:p>
                   </a:txBody>
-                  <a:tcPr>
+                  <a:tcPr anchor="ctr">
                     <a:solidFill>
                       <a:srgbClr val="1B365D"/>
                     </a:solidFill>
@@ -6417,7 +6476,7 @@
                     <a:bodyPr/>
                     <a:lstStyle/>
                     <a:p>
-                      <a:pPr algn="l">
+                      <a:pPr algn="ctr">
                         <a:defRPr sz="1000" b="1">
                           <a:solidFill>
                             <a:srgbClr val="FFFFFF"/>
@@ -6430,7 +6489,7 @@
                       </a:r>
                     </a:p>
                   </a:txBody>
-                  <a:tcPr>
+                  <a:tcPr anchor="ctr">
                     <a:solidFill>
                       <a:srgbClr val="101C30"/>
                     </a:solidFill>
@@ -6441,7 +6500,7 @@
                     <a:bodyPr/>
                     <a:lstStyle/>
                     <a:p>
-                      <a:pPr algn="l">
+                      <a:pPr algn="ctr">
                         <a:defRPr sz="950" b="0">
                           <a:solidFill>
                             <a:srgbClr val="9CA3AF"/>
@@ -6454,7 +6513,7 @@
                       </a:r>
                     </a:p>
                   </a:txBody>
-                  <a:tcPr>
+                  <a:tcPr anchor="ctr">
                     <a:solidFill>
                       <a:srgbClr val="101C30"/>
                     </a:solidFill>
@@ -6478,7 +6537,7 @@
                       </a:r>
                     </a:p>
                   </a:txBody>
-                  <a:tcPr>
+                  <a:tcPr anchor="ctr">
                     <a:solidFill>
                       <a:srgbClr val="101C30"/>
                     </a:solidFill>
@@ -6491,7 +6550,7 @@
                     <a:bodyPr/>
                     <a:lstStyle/>
                     <a:p>
-                      <a:pPr algn="l">
+                      <a:pPr algn="ctr">
                         <a:defRPr sz="1000" b="1">
                           <a:solidFill>
                             <a:srgbClr val="FFFFFF"/>
@@ -6504,7 +6563,7 @@
                       </a:r>
                     </a:p>
                   </a:txBody>
-                  <a:tcPr>
+                  <a:tcPr anchor="ctr">
                     <a:solidFill>
                       <a:srgbClr val="071321"/>
                     </a:solidFill>
@@ -6515,7 +6574,7 @@
                     <a:bodyPr/>
                     <a:lstStyle/>
                     <a:p>
-                      <a:pPr algn="l">
+                      <a:pPr algn="ctr">
                         <a:defRPr sz="950" b="0">
                           <a:solidFill>
                             <a:srgbClr val="9CA3AF"/>
@@ -6528,7 +6587,7 @@
                       </a:r>
                     </a:p>
                   </a:txBody>
-                  <a:tcPr>
+                  <a:tcPr anchor="ctr">
                     <a:solidFill>
                       <a:srgbClr val="071321"/>
                     </a:solidFill>
@@ -6552,7 +6611,7 @@
                       </a:r>
                     </a:p>
                   </a:txBody>
-                  <a:tcPr>
+                  <a:tcPr anchor="ctr">
                     <a:solidFill>
                       <a:srgbClr val="071321"/>
                     </a:solidFill>
@@ -6565,7 +6624,7 @@
                     <a:bodyPr/>
                     <a:lstStyle/>
                     <a:p>
-                      <a:pPr algn="l">
+                      <a:pPr algn="ctr">
                         <a:defRPr sz="1000" b="1">
                           <a:solidFill>
                             <a:srgbClr val="FFFFFF"/>
@@ -6578,7 +6637,7 @@
                       </a:r>
                     </a:p>
                   </a:txBody>
-                  <a:tcPr>
+                  <a:tcPr anchor="ctr">
                     <a:solidFill>
                       <a:srgbClr val="101C30"/>
                     </a:solidFill>
@@ -6589,7 +6648,7 @@
                     <a:bodyPr/>
                     <a:lstStyle/>
                     <a:p>
-                      <a:pPr algn="l">
+                      <a:pPr algn="ctr">
                         <a:defRPr sz="950" b="0">
                           <a:solidFill>
                             <a:srgbClr val="9CA3AF"/>
@@ -6602,7 +6661,7 @@
                       </a:r>
                     </a:p>
                   </a:txBody>
-                  <a:tcPr>
+                  <a:tcPr anchor="ctr">
                     <a:solidFill>
                       <a:srgbClr val="101C30"/>
                     </a:solidFill>
@@ -6626,7 +6685,7 @@
                       </a:r>
                     </a:p>
                   </a:txBody>
-                  <a:tcPr>
+                  <a:tcPr anchor="ctr">
                     <a:solidFill>
                       <a:srgbClr val="101C30"/>
                     </a:solidFill>
@@ -6639,7 +6698,7 @@
                     <a:bodyPr/>
                     <a:lstStyle/>
                     <a:p>
-                      <a:pPr algn="l">
+                      <a:pPr algn="ctr">
                         <a:defRPr sz="1000" b="1">
                           <a:solidFill>
                             <a:srgbClr val="FFFFFF"/>
@@ -6652,7 +6711,7 @@
                       </a:r>
                     </a:p>
                   </a:txBody>
-                  <a:tcPr>
+                  <a:tcPr anchor="ctr">
                     <a:solidFill>
                       <a:srgbClr val="071321"/>
                     </a:solidFill>
@@ -6663,7 +6722,7 @@
                     <a:bodyPr/>
                     <a:lstStyle/>
                     <a:p>
-                      <a:pPr algn="l">
+                      <a:pPr algn="ctr">
                         <a:defRPr sz="950" b="0">
                           <a:solidFill>
                             <a:srgbClr val="9CA3AF"/>
@@ -6676,7 +6735,7 @@
                       </a:r>
                     </a:p>
                   </a:txBody>
-                  <a:tcPr>
+                  <a:tcPr anchor="ctr">
                     <a:solidFill>
                       <a:srgbClr val="071321"/>
                     </a:solidFill>
@@ -6700,7 +6759,7 @@
                       </a:r>
                     </a:p>
                   </a:txBody>
-                  <a:tcPr>
+                  <a:tcPr anchor="ctr">
                     <a:solidFill>
                       <a:srgbClr val="071321"/>
                     </a:solidFill>
@@ -6871,16 +6930,16 @@
           <a:noFill/>
         </p:spPr>
         <p:txBody>
-          <a:bodyPr wrap="square" lIns="0" rIns="0" tIns="0" bIns="0">
+          <a:bodyPr wrap="square" lIns="0" rIns="0" tIns="0" bIns="0" anchor="ctr">
             <a:spAutoFit/>
           </a:bodyPr>
           <a:lstStyle/>
           <a:p>
-            <a:pPr>
+            <a:pPr algn="ctr">
               <a:spcAft>
-                <a:spcPts val="1200"/>
+                <a:spcPts val="1000"/>
               </a:spcAft>
-              <a:defRPr sz="1600" b="1">
+              <a:defRPr sz="1700" b="1">
                 <a:solidFill>
                   <a:srgbClr val="29B6D8"/>
                 </a:solidFill>
@@ -6888,15 +6947,15 @@
               </a:defRPr>
             </a:pPr>
             <a:r>
-              <a:t>Synergie ENPO-MA (Mécanique &amp; Énergétique)</a:t>
-            </a:r>
-          </a:p>
-          <a:p>
-            <a:pPr>
+              <a:t>BOUIRA Islem Akram</a:t>
+            </a:r>
+          </a:p>
+          <a:p>
+            <a:pPr algn="ctr">
               <a:spcAft>
                 <a:spcPts val="800"/>
               </a:spcAft>
-              <a:defRPr sz="1100">
+              <a:defRPr sz="1250">
                 <a:solidFill>
                   <a:srgbClr val="FFFFFF"/>
                 </a:solidFill>
@@ -6904,15 +6963,15 @@
               </a:defRPr>
             </a:pPr>
             <a:r>
-              <a:t>• Modélisation Physique &amp; Thermique : Analyse transitoire du changement de phase solide-liquide (MCP), résolution des équations de conduction et convection forcée.</a:t>
-            </a:r>
-          </a:p>
-          <a:p>
-            <a:pPr>
+              <a:t>Étudiant en 5ème année mécanique (Système Énergétique) @ ENPO</a:t>
+            </a:r>
+          </a:p>
+          <a:p>
+            <a:pPr algn="ctr">
               <a:spcAft>
                 <a:spcPts val="800"/>
               </a:spcAft>
-              <a:defRPr sz="1100">
+              <a:defRPr sz="1250">
                 <a:solidFill>
                   <a:srgbClr val="FFFFFF"/>
                 </a:solidFill>
@@ -6920,15 +6979,15 @@
               </a:defRPr>
             </a:pPr>
             <a:r>
-              <a:t>• Conception Mécanique CAO : Conception complète de l'échangeur, des profilés d'ailettes en étoile SolidWorks et de la structure de supportage suspendue.</a:t>
-            </a:r>
-          </a:p>
-          <a:p>
-            <a:pPr>
+              <a:t>• Modélisation Physique &amp; Thermique : Analyse transitoire du changement de phase solide-liquide (MCP) et résolution des flux de chaleur.</a:t>
+            </a:r>
+          </a:p>
+          <a:p>
+            <a:pPr algn="ctr">
               <a:spcAft>
                 <a:spcPts val="800"/>
               </a:spcAft>
-              <a:defRPr sz="1100">
+              <a:defRPr sz="1250">
                 <a:solidFill>
                   <a:srgbClr val="FFFFFF"/>
                 </a:solidFill>
@@ -6936,7 +6995,23 @@
               </a:defRPr>
             </a:pPr>
             <a:r>
-              <a:t>• Résistance des Matériaux (RDM) : Validation de la tenue mécanique des suspentes M14, calculs de flexion (flèche médiane) des tubes de 2m, et analyses DFM de fabrication locale.</a:t>
+              <a:t>• Conception Mécanique CAO : Conception de l'échangeur de chaleur, modélisation des ailettes en étoile, et système d'ancrage modulaire.</a:t>
+            </a:r>
+          </a:p>
+          <a:p>
+            <a:pPr algn="ctr">
+              <a:spcAft>
+                <a:spcPts val="800"/>
+              </a:spcAft>
+              <a:defRPr sz="1250">
+                <a:solidFill>
+                  <a:srgbClr val="FFFFFF"/>
+                </a:solidFill>
+                <a:latin typeface="Segoe UI"/>
+              </a:defRPr>
+            </a:pPr>
+            <a:r>
+              <a:t>• Résistance des Matériaux (RDM) : Tenue mécanique des suspentes M14, flèche des cylindres et calculs DFM de fabrication locale.</a:t>
             </a:r>
           </a:p>
         </p:txBody>
@@ -7003,16 +7078,16 @@
           <a:noFill/>
         </p:spPr>
         <p:txBody>
-          <a:bodyPr wrap="square" lIns="0" rIns="0" tIns="0" bIns="0">
+          <a:bodyPr wrap="square" lIns="0" rIns="0" tIns="0" bIns="0" anchor="ctr">
             <a:spAutoFit/>
           </a:bodyPr>
           <a:lstStyle/>
           <a:p>
-            <a:pPr>
+            <a:pPr algn="ctr">
               <a:spcAft>
-                <a:spcPts val="1200"/>
+                <a:spcPts val="1000"/>
               </a:spcAft>
-              <a:defRPr sz="1600" b="1">
+              <a:defRPr sz="1700" b="1">
                 <a:solidFill>
                   <a:srgbClr val="29B6D8"/>
                 </a:solidFill>
@@ -7020,15 +7095,15 @@
               </a:defRPr>
             </a:pPr>
             <a:r>
-              <a:t>Synergie ENPA (Électrotechnique &amp; Automatisme)</a:t>
-            </a:r>
-          </a:p>
-          <a:p>
-            <a:pPr>
+              <a:t>ZANE Mohamed Elamine</a:t>
+            </a:r>
+          </a:p>
+          <a:p>
+            <a:pPr algn="ctr">
               <a:spcAft>
                 <a:spcPts val="800"/>
               </a:spcAft>
-              <a:defRPr sz="1100">
+              <a:defRPr sz="1250">
                 <a:solidFill>
                   <a:srgbClr val="FFFFFF"/>
                 </a:solidFill>
@@ -7036,15 +7111,15 @@
               </a:defRPr>
             </a:pPr>
             <a:r>
-              <a:t>• Conception de l'Armoire Électrique : Câblage de puissance, schémas de protection et intégration des contacteurs compresseurs et de la soufflerie.</a:t>
-            </a:r>
-          </a:p>
-          <a:p>
-            <a:pPr>
+              <a:t>Étudiant en 4ème année électrotechnique @ ENPA</a:t>
+            </a:r>
+          </a:p>
+          <a:p>
+            <a:pPr algn="ctr">
               <a:spcAft>
                 <a:spcPts val="800"/>
               </a:spcAft>
-              <a:defRPr sz="1100">
+              <a:defRPr sz="1250">
                 <a:solidFill>
                   <a:srgbClr val="FFFFFF"/>
                 </a:solidFill>
@@ -7052,15 +7127,15 @@
               </a:defRPr>
             </a:pPr>
             <a:r>
-              <a:t>• Programmation Automate (PLC) : Écriture de la logique de régulation, gestion PID des vannes, et détection automatique des coupures de courant.</a:t>
-            </a:r>
-          </a:p>
-          <a:p>
-            <a:pPr>
+              <a:t>• Armoire Électrique &amp; Puissance : Conception du câblage de puissance, des relais thermiques et des sectionneurs de protection.</a:t>
+            </a:r>
+          </a:p>
+          <a:p>
+            <a:pPr algn="ctr">
               <a:spcAft>
                 <a:spcPts val="800"/>
               </a:spcAft>
-              <a:defRPr sz="1100">
+              <a:defRPr sz="1250">
                 <a:solidFill>
                   <a:srgbClr val="FFFFFF"/>
                 </a:solidFill>
@@ -7068,15 +7143,15 @@
               </a:defRPr>
             </a:pPr>
             <a:r>
-              <a:t>• Interface IHM &amp; Supervision : Conception de l'écran tactile pour le suivi des températures, de l'état de charge (SOC) et des historiques d'exploitation.</a:t>
-            </a:r>
-          </a:p>
-          <a:p>
-            <a:pPr>
+              <a:t>• Automatisme PLC &amp; IHM : Écriture de la logique PID de régulation du basculement charge/décharge et interface de contrôle locale.</a:t>
+            </a:r>
+          </a:p>
+          <a:p>
+            <a:pPr algn="ctr">
               <a:spcAft>
                 <a:spcPts val="800"/>
               </a:spcAft>
-              <a:defRPr sz="1100">
+              <a:defRPr sz="1250">
                 <a:solidFill>
                   <a:srgbClr val="FFFFFF"/>
                 </a:solidFill>
@@ -7084,7 +7159,7 @@
               </a:defRPr>
             </a:pPr>
             <a:r>
-              <a:t>• Secours Électrique : Dimensionnement de l'UPS et du pack de batteries LiFePO4 de secours.</a:t>
+              <a:t>• Secours Électrique (UPS) : Dimensionnement et supervision du pack de batteries de secours LiFePO4 pour sécuriser la soufflerie en cas de panne.</a:t>
             </a:r>
           </a:p>
         </p:txBody>

</xml_diff>

<commit_message>
feat: finalise system logic, anti-givre spacing, autocad schema, final grafcet & pitch deck
</commit_message>
<xml_diff>
--- a/kryodrop_pitch_deck.pptx
+++ b/kryodrop_pitch_deck.pptx
@@ -13,6 +13,8 @@
     <p:sldId id="261" r:id="rId12"/>
     <p:sldId id="262" r:id="rId13"/>
     <p:sldId id="263" r:id="rId14"/>
+    <p:sldId id="264" r:id="rId15"/>
+    <p:sldId id="265" r:id="rId16"/>
   </p:sldIdLst>
   <p:sldSz cx="12191695" cy="6858000" type="screen4x3"/>
   <p:notesSz cx="6858000" cy="9144000"/>
@@ -3111,6 +3113,49 @@
         </p:nvSpPr>
         <p:spPr>
           <a:xfrm>
+            <a:off x="137160" y="137160"/>
+            <a:ext cx="11914632" cy="6583680"/>
+          </a:xfrm>
+          <a:prstGeom prst="rect">
+            <a:avLst/>
+          </a:prstGeom>
+          <a:noFill/>
+          <a:ln w="19050">
+            <a:solidFill>
+              <a:srgbClr val="1E293B"/>
+            </a:solidFill>
+          </a:ln>
+        </p:spPr>
+        <p:style>
+          <a:lnRef idx="1">
+            <a:schemeClr val="accent1"/>
+          </a:lnRef>
+          <a:fillRef idx="3">
+            <a:schemeClr val="accent1"/>
+          </a:fillRef>
+          <a:effectRef idx="2">
+            <a:schemeClr val="accent1"/>
+          </a:effectRef>
+          <a:fontRef idx="minor">
+            <a:schemeClr val="lt1"/>
+          </a:fontRef>
+        </p:style>
+        <p:txBody>
+          <a:bodyPr rtlCol="0" anchor="ctr"/>
+          <a:lstStyle/>
+          <a:p>
+            <a:pPr algn="ctr"/>
+          </a:p>
+        </p:txBody>
+      </p:sp>
+      <p:sp>
+        <p:nvSpPr>
+          <p:cNvPr id="3" name="Rectangle 2"/>
+          <p:cNvSpPr/>
+          <p:nvPr/>
+        </p:nvSpPr>
+        <p:spPr>
+          <a:xfrm>
             <a:off x="914400" y="1463040"/>
             <a:ext cx="109728" cy="3931920"/>
           </a:xfrm>
@@ -3150,7 +3195,7 @@
       </p:sp>
       <p:sp>
         <p:nvSpPr>
-          <p:cNvPr id="3" name="TextBox 2"/>
+          <p:cNvPr id="4" name="TextBox 3"/>
           <p:cNvSpPr txBox="1"/>
           <p:nvPr/>
         </p:nvSpPr>
@@ -3218,7 +3263,7 @@
       </p:sp>
       <p:sp>
         <p:nvSpPr>
-          <p:cNvPr id="4" name="TextBox 3"/>
+          <p:cNvPr id="5" name="TextBox 4"/>
           <p:cNvSpPr txBox="1"/>
           <p:nvPr/>
         </p:nvSpPr>
@@ -3242,7 +3287,7 @@
               <a:spcAft>
                 <a:spcPts val="600"/>
               </a:spcAft>
-              <a:defRPr sz="1100" b="1">
+              <a:defRPr sz="1300" b="1">
                 <a:solidFill>
                   <a:srgbClr val="29B6D8"/>
                 </a:solidFill>
@@ -3258,7 +3303,7 @@
               <a:spcAft>
                 <a:spcPts val="400"/>
               </a:spcAft>
-              <a:defRPr sz="1100" b="1">
+              <a:defRPr sz="1200" b="1">
                 <a:solidFill>
                   <a:srgbClr val="FFFFFF"/>
                 </a:solidFill>
@@ -3271,7 +3316,7 @@
           </a:p>
           <a:p>
             <a:pPr>
-              <a:defRPr sz="1100" b="1">
+              <a:defRPr sz="1200" b="1">
                 <a:solidFill>
                   <a:srgbClr val="FFFFFF"/>
                 </a:solidFill>
@@ -3286,7 +3331,7 @@
       </p:sp>
       <p:pic>
         <p:nvPicPr>
-          <p:cNvPr id="5" name="Picture 4" descr="logo_icon.png"/>
+          <p:cNvPr id="6" name="Picture 5" descr="logo_icon.png"/>
           <p:cNvPicPr>
             <a:picLocks noChangeAspect="1"/>
           </p:cNvPicPr>
@@ -3310,7 +3355,7 @@
       </p:pic>
       <p:sp>
         <p:nvSpPr>
-          <p:cNvPr id="6" name="TextBox 5"/>
+          <p:cNvPr id="7" name="TextBox 6"/>
           <p:cNvSpPr txBox="1"/>
           <p:nvPr/>
         </p:nvSpPr>
@@ -3340,6 +3385,529 @@
             </a:pPr>
             <a:r>
               <a:t>Greentech Challenge 2026  |  Pitch de Validation Industrielle</a:t>
+            </a:r>
+          </a:p>
+        </p:txBody>
+      </p:sp>
+    </p:spTree>
+  </p:cSld>
+  <p:clrMapOvr>
+    <a:masterClrMapping/>
+  </p:clrMapOvr>
+</p:sld>
+</file>
+
+<file path=ppt/slides/slide10.xml><?xml version="1.0" encoding="utf-8"?>
+<p:sld xmlns:a="http://schemas.openxmlformats.org/drawingml/2006/main" xmlns:p="http://schemas.openxmlformats.org/presentationml/2006/main" xmlns:r="http://schemas.openxmlformats.org/officeDocument/2006/relationships">
+  <p:cSld>
+    <p:bg>
+      <p:bgPr>
+        <a:solidFill>
+          <a:srgbClr val="071321"/>
+        </a:solidFill>
+        <a:effectLst/>
+      </p:bgPr>
+    </p:bg>
+    <p:spTree>
+      <p:nvGrpSpPr>
+        <p:cNvPr id="1" name=""/>
+        <p:cNvGrpSpPr/>
+        <p:nvPr/>
+      </p:nvGrpSpPr>
+      <p:grpSpPr/>
+      <p:sp>
+        <p:nvSpPr>
+          <p:cNvPr id="2" name="Rectangle 1"/>
+          <p:cNvSpPr/>
+          <p:nvPr/>
+        </p:nvSpPr>
+        <p:spPr>
+          <a:xfrm>
+            <a:off x="137160" y="137160"/>
+            <a:ext cx="11914632" cy="6583680"/>
+          </a:xfrm>
+          <a:prstGeom prst="rect">
+            <a:avLst/>
+          </a:prstGeom>
+          <a:noFill/>
+          <a:ln w="19050">
+            <a:solidFill>
+              <a:srgbClr val="1E293B"/>
+            </a:solidFill>
+          </a:ln>
+        </p:spPr>
+        <p:style>
+          <a:lnRef idx="1">
+            <a:schemeClr val="accent1"/>
+          </a:lnRef>
+          <a:fillRef idx="3">
+            <a:schemeClr val="accent1"/>
+          </a:fillRef>
+          <a:effectRef idx="2">
+            <a:schemeClr val="accent1"/>
+          </a:effectRef>
+          <a:fontRef idx="minor">
+            <a:schemeClr val="lt1"/>
+          </a:fontRef>
+        </p:style>
+        <p:txBody>
+          <a:bodyPr rtlCol="0" anchor="ctr"/>
+          <a:lstStyle/>
+          <a:p>
+            <a:pPr algn="ctr"/>
+          </a:p>
+        </p:txBody>
+      </p:sp>
+      <p:sp>
+        <p:nvSpPr>
+          <p:cNvPr id="3" name="TextBox 2"/>
+          <p:cNvSpPr txBox="1"/>
+          <p:nvPr/>
+        </p:nvSpPr>
+        <p:spPr>
+          <a:xfrm>
+            <a:off x="731520" y="365760"/>
+            <a:ext cx="10698480" cy="274320"/>
+          </a:xfrm>
+          <a:prstGeom prst="rect">
+            <a:avLst/>
+          </a:prstGeom>
+          <a:noFill/>
+        </p:spPr>
+        <p:txBody>
+          <a:bodyPr wrap="square" lIns="0" tIns="0" rIns="0" bIns="0">
+            <a:spAutoFit/>
+          </a:bodyPr>
+          <a:lstStyle/>
+          <a:p>
+            <a:pPr>
+              <a:defRPr sz="1000" b="1">
+                <a:solidFill>
+                  <a:srgbClr val="29B6D8"/>
+                </a:solidFill>
+                <a:latin typeface="Segoe UI"/>
+              </a:defRPr>
+            </a:pPr>
+            <a:r>
+              <a:t>SYNERGIE &amp; FORCE HUMAINE</a:t>
+            </a:r>
+          </a:p>
+        </p:txBody>
+      </p:sp>
+      <p:sp>
+        <p:nvSpPr>
+          <p:cNvPr id="4" name="TextBox 3"/>
+          <p:cNvSpPr txBox="1"/>
+          <p:nvPr/>
+        </p:nvSpPr>
+        <p:spPr>
+          <a:xfrm>
+            <a:off x="731520" y="594360"/>
+            <a:ext cx="10698480" cy="731520"/>
+          </a:xfrm>
+          <a:prstGeom prst="rect">
+            <a:avLst/>
+          </a:prstGeom>
+          <a:noFill/>
+        </p:spPr>
+        <p:txBody>
+          <a:bodyPr wrap="square" lIns="0" tIns="0" rIns="0" bIns="0">
+            <a:spAutoFit/>
+          </a:bodyPr>
+          <a:lstStyle/>
+          <a:p>
+            <a:pPr>
+              <a:defRPr sz="2800" b="1">
+                <a:solidFill>
+                  <a:srgbClr val="FFFFFF"/>
+                </a:solidFill>
+                <a:latin typeface="Segoe UI"/>
+              </a:defRPr>
+            </a:pPr>
+            <a:r>
+              <a:t>Une Équipe Pluridisciplinaire Complète</a:t>
+            </a:r>
+          </a:p>
+        </p:txBody>
+      </p:sp>
+      <p:sp>
+        <p:nvSpPr>
+          <p:cNvPr id="5" name="Rounded Rectangle 4"/>
+          <p:cNvSpPr/>
+          <p:nvPr/>
+        </p:nvSpPr>
+        <p:spPr>
+          <a:xfrm>
+            <a:off x="731520" y="1463040"/>
+            <a:ext cx="5120640" cy="4754880"/>
+          </a:xfrm>
+          <a:prstGeom prst="roundRect">
+            <a:avLst/>
+          </a:prstGeom>
+          <a:solidFill>
+            <a:srgbClr val="101C30"/>
+          </a:solidFill>
+          <a:ln w="19050">
+            <a:solidFill>
+              <a:srgbClr val="1B2C49"/>
+            </a:solidFill>
+          </a:ln>
+        </p:spPr>
+        <p:style>
+          <a:lnRef idx="1">
+            <a:schemeClr val="accent1"/>
+          </a:lnRef>
+          <a:fillRef idx="3">
+            <a:schemeClr val="accent1"/>
+          </a:fillRef>
+          <a:effectRef idx="2">
+            <a:schemeClr val="accent1"/>
+          </a:effectRef>
+          <a:fontRef idx="minor">
+            <a:schemeClr val="lt1"/>
+          </a:fontRef>
+        </p:style>
+        <p:txBody>
+          <a:bodyPr rtlCol="0" anchor="ctr"/>
+          <a:lstStyle/>
+          <a:p>
+            <a:pPr algn="ctr"/>
+          </a:p>
+        </p:txBody>
+      </p:sp>
+      <p:sp>
+        <p:nvSpPr>
+          <p:cNvPr id="6" name="Rounded Rectangle 5"/>
+          <p:cNvSpPr/>
+          <p:nvPr/>
+        </p:nvSpPr>
+        <p:spPr>
+          <a:xfrm>
+            <a:off x="731520" y="1463040"/>
+            <a:ext cx="5120640" cy="73152"/>
+          </a:xfrm>
+          <a:prstGeom prst="roundRect">
+            <a:avLst/>
+          </a:prstGeom>
+          <a:solidFill>
+            <a:srgbClr val="29B6D8"/>
+          </a:solidFill>
+          <a:ln>
+            <a:noFill/>
+          </a:ln>
+        </p:spPr>
+        <p:style>
+          <a:lnRef idx="1">
+            <a:schemeClr val="accent1"/>
+          </a:lnRef>
+          <a:fillRef idx="3">
+            <a:schemeClr val="accent1"/>
+          </a:fillRef>
+          <a:effectRef idx="2">
+            <a:schemeClr val="accent1"/>
+          </a:effectRef>
+          <a:fontRef idx="minor">
+            <a:schemeClr val="lt1"/>
+          </a:fontRef>
+        </p:style>
+        <p:txBody>
+          <a:bodyPr rtlCol="0" anchor="ctr"/>
+          <a:lstStyle/>
+          <a:p>
+            <a:pPr algn="ctr"/>
+          </a:p>
+        </p:txBody>
+      </p:sp>
+      <p:sp>
+        <p:nvSpPr>
+          <p:cNvPr id="7" name="TextBox 6"/>
+          <p:cNvSpPr txBox="1"/>
+          <p:nvPr/>
+        </p:nvSpPr>
+        <p:spPr>
+          <a:xfrm>
+            <a:off x="1005840" y="1737360"/>
+            <a:ext cx="4572000" cy="4206240"/>
+          </a:xfrm>
+          <a:prstGeom prst="rect">
+            <a:avLst/>
+          </a:prstGeom>
+          <a:noFill/>
+        </p:spPr>
+        <p:txBody>
+          <a:bodyPr wrap="square" lIns="0" rIns="0" tIns="0" bIns="0" anchor="ctr">
+            <a:spAutoFit/>
+          </a:bodyPr>
+          <a:lstStyle/>
+          <a:p>
+            <a:pPr algn="ctr">
+              <a:spcAft>
+                <a:spcPts val="1000"/>
+              </a:spcAft>
+              <a:defRPr sz="1700" b="1">
+                <a:solidFill>
+                  <a:srgbClr val="29B6D8"/>
+                </a:solidFill>
+                <a:latin typeface="Segoe UI"/>
+              </a:defRPr>
+            </a:pPr>
+            <a:r>
+              <a:t>BOUIRA Islem Akram</a:t>
+            </a:r>
+          </a:p>
+          <a:p>
+            <a:pPr algn="ctr">
+              <a:spcAft>
+                <a:spcPts val="800"/>
+              </a:spcAft>
+              <a:defRPr sz="1150">
+                <a:solidFill>
+                  <a:srgbClr val="FFFFFF"/>
+                </a:solidFill>
+                <a:latin typeface="Segoe UI"/>
+              </a:defRPr>
+            </a:pPr>
+            <a:r>
+              <a:t>Étudiant en 5ème année mécanique (Système Énergétique) @ ENPO</a:t>
+            </a:r>
+          </a:p>
+          <a:p>
+            <a:pPr algn="ctr">
+              <a:spcAft>
+                <a:spcPts val="800"/>
+              </a:spcAft>
+              <a:defRPr sz="1150">
+                <a:solidFill>
+                  <a:srgbClr val="FFFFFF"/>
+                </a:solidFill>
+                <a:latin typeface="Segoe UI"/>
+              </a:defRPr>
+            </a:pPr>
+            <a:r>
+              <a:t>• Modélisation Physique &amp; Thermique : Analyse transitoire du changement de phase solide-liquide (MCP) et résolution des flux de chaleur.</a:t>
+            </a:r>
+          </a:p>
+          <a:p>
+            <a:pPr algn="ctr">
+              <a:spcAft>
+                <a:spcPts val="800"/>
+              </a:spcAft>
+              <a:defRPr sz="1150">
+                <a:solidFill>
+                  <a:srgbClr val="FFFFFF"/>
+                </a:solidFill>
+                <a:latin typeface="Segoe UI"/>
+              </a:defRPr>
+            </a:pPr>
+            <a:r>
+              <a:t>• Conception Mécanique CAO : Conception de l'échangeur de chaleur, modélisation des ailettes en étoile, et système d'ancrage modulaire.</a:t>
+            </a:r>
+          </a:p>
+          <a:p>
+            <a:pPr algn="ctr">
+              <a:spcAft>
+                <a:spcPts val="800"/>
+              </a:spcAft>
+              <a:defRPr sz="1150">
+                <a:solidFill>
+                  <a:srgbClr val="FFFFFF"/>
+                </a:solidFill>
+                <a:latin typeface="Segoe UI"/>
+              </a:defRPr>
+            </a:pPr>
+            <a:r>
+              <a:t>• Résistance des Matériaux (RDM) : Tenue mécanique des suspentes M14, flèche des cylindres et calculs DFM de fabrication locale.</a:t>
+            </a:r>
+          </a:p>
+        </p:txBody>
+      </p:sp>
+      <p:sp>
+        <p:nvSpPr>
+          <p:cNvPr id="8" name="Rounded Rectangle 7"/>
+          <p:cNvSpPr/>
+          <p:nvPr/>
+        </p:nvSpPr>
+        <p:spPr>
+          <a:xfrm>
+            <a:off x="6309360" y="1463040"/>
+            <a:ext cx="5120640" cy="4754880"/>
+          </a:xfrm>
+          <a:prstGeom prst="roundRect">
+            <a:avLst/>
+          </a:prstGeom>
+          <a:solidFill>
+            <a:srgbClr val="101C30"/>
+          </a:solidFill>
+          <a:ln w="19050">
+            <a:solidFill>
+              <a:srgbClr val="1B2C49"/>
+            </a:solidFill>
+          </a:ln>
+        </p:spPr>
+        <p:style>
+          <a:lnRef idx="1">
+            <a:schemeClr val="accent1"/>
+          </a:lnRef>
+          <a:fillRef idx="3">
+            <a:schemeClr val="accent1"/>
+          </a:fillRef>
+          <a:effectRef idx="2">
+            <a:schemeClr val="accent1"/>
+          </a:effectRef>
+          <a:fontRef idx="minor">
+            <a:schemeClr val="lt1"/>
+          </a:fontRef>
+        </p:style>
+        <p:txBody>
+          <a:bodyPr rtlCol="0" anchor="ctr"/>
+          <a:lstStyle/>
+          <a:p>
+            <a:pPr algn="ctr"/>
+          </a:p>
+        </p:txBody>
+      </p:sp>
+      <p:sp>
+        <p:nvSpPr>
+          <p:cNvPr id="9" name="Rounded Rectangle 8"/>
+          <p:cNvSpPr/>
+          <p:nvPr/>
+        </p:nvSpPr>
+        <p:spPr>
+          <a:xfrm>
+            <a:off x="6309360" y="1463040"/>
+            <a:ext cx="5120640" cy="73152"/>
+          </a:xfrm>
+          <a:prstGeom prst="roundRect">
+            <a:avLst/>
+          </a:prstGeom>
+          <a:solidFill>
+            <a:srgbClr val="29B6D8"/>
+          </a:solidFill>
+          <a:ln>
+            <a:noFill/>
+          </a:ln>
+        </p:spPr>
+        <p:style>
+          <a:lnRef idx="1">
+            <a:schemeClr val="accent1"/>
+          </a:lnRef>
+          <a:fillRef idx="3">
+            <a:schemeClr val="accent1"/>
+          </a:fillRef>
+          <a:effectRef idx="2">
+            <a:schemeClr val="accent1"/>
+          </a:effectRef>
+          <a:fontRef idx="minor">
+            <a:schemeClr val="lt1"/>
+          </a:fontRef>
+        </p:style>
+        <p:txBody>
+          <a:bodyPr rtlCol="0" anchor="ctr"/>
+          <a:lstStyle/>
+          <a:p>
+            <a:pPr algn="ctr"/>
+          </a:p>
+        </p:txBody>
+      </p:sp>
+      <p:sp>
+        <p:nvSpPr>
+          <p:cNvPr id="10" name="TextBox 9"/>
+          <p:cNvSpPr txBox="1"/>
+          <p:nvPr/>
+        </p:nvSpPr>
+        <p:spPr>
+          <a:xfrm>
+            <a:off x="6583680" y="1737360"/>
+            <a:ext cx="4572000" cy="4206240"/>
+          </a:xfrm>
+          <a:prstGeom prst="rect">
+            <a:avLst/>
+          </a:prstGeom>
+          <a:noFill/>
+        </p:spPr>
+        <p:txBody>
+          <a:bodyPr wrap="square" lIns="0" rIns="0" tIns="0" bIns="0" anchor="ctr">
+            <a:spAutoFit/>
+          </a:bodyPr>
+          <a:lstStyle/>
+          <a:p>
+            <a:pPr algn="ctr">
+              <a:spcAft>
+                <a:spcPts val="1000"/>
+              </a:spcAft>
+              <a:defRPr sz="1700" b="1">
+                <a:solidFill>
+                  <a:srgbClr val="29B6D8"/>
+                </a:solidFill>
+                <a:latin typeface="Segoe UI"/>
+              </a:defRPr>
+            </a:pPr>
+            <a:r>
+              <a:t>ZANE Mohamed Elamine</a:t>
+            </a:r>
+          </a:p>
+          <a:p>
+            <a:pPr algn="ctr">
+              <a:spcAft>
+                <a:spcPts val="800"/>
+              </a:spcAft>
+              <a:defRPr sz="1150">
+                <a:solidFill>
+                  <a:srgbClr val="FFFFFF"/>
+                </a:solidFill>
+                <a:latin typeface="Segoe UI"/>
+              </a:defRPr>
+            </a:pPr>
+            <a:r>
+              <a:t>Étudiant en 4ème année électrotechnique @ ENPA</a:t>
+            </a:r>
+          </a:p>
+          <a:p>
+            <a:pPr algn="ctr">
+              <a:spcAft>
+                <a:spcPts val="800"/>
+              </a:spcAft>
+              <a:defRPr sz="1150">
+                <a:solidFill>
+                  <a:srgbClr val="FFFFFF"/>
+                </a:solidFill>
+                <a:latin typeface="Segoe UI"/>
+              </a:defRPr>
+            </a:pPr>
+            <a:r>
+              <a:t>• Armoire Électrique &amp; Puissance : Conception du câblage de puissance, des relais thermiques et des sectionneurs de protection.</a:t>
+            </a:r>
+          </a:p>
+          <a:p>
+            <a:pPr algn="ctr">
+              <a:spcAft>
+                <a:spcPts val="800"/>
+              </a:spcAft>
+              <a:defRPr sz="1150">
+                <a:solidFill>
+                  <a:srgbClr val="FFFFFF"/>
+                </a:solidFill>
+                <a:latin typeface="Segoe UI"/>
+              </a:defRPr>
+            </a:pPr>
+            <a:r>
+              <a:t>• Automatisme PLC &amp; IHM : Écriture de la logique PID de régulation du basculement charge/décharge et interface de contrôle locale.</a:t>
+            </a:r>
+          </a:p>
+          <a:p>
+            <a:pPr algn="ctr">
+              <a:spcAft>
+                <a:spcPts val="800"/>
+              </a:spcAft>
+              <a:defRPr sz="1150">
+                <a:solidFill>
+                  <a:srgbClr val="FFFFFF"/>
+                </a:solidFill>
+                <a:latin typeface="Segoe UI"/>
+              </a:defRPr>
+            </a:pPr>
+            <a:r>
+              <a:t>• Secours Électrique (UPS) : Dimensionnement et supervision du pack de batteries de secours LiFePO4 pour sécuriser la soufflerie en cas de panne.</a:t>
             </a:r>
           </a:p>
         </p:txBody>
@@ -3372,7 +3940,50 @@
       <p:grpSpPr/>
       <p:sp>
         <p:nvSpPr>
-          <p:cNvPr id="2" name="TextBox 1"/>
+          <p:cNvPr id="2" name="Rectangle 1"/>
+          <p:cNvSpPr/>
+          <p:nvPr/>
+        </p:nvSpPr>
+        <p:spPr>
+          <a:xfrm>
+            <a:off x="137160" y="137160"/>
+            <a:ext cx="11914632" cy="6583680"/>
+          </a:xfrm>
+          <a:prstGeom prst="rect">
+            <a:avLst/>
+          </a:prstGeom>
+          <a:noFill/>
+          <a:ln w="19050">
+            <a:solidFill>
+              <a:srgbClr val="1E293B"/>
+            </a:solidFill>
+          </a:ln>
+        </p:spPr>
+        <p:style>
+          <a:lnRef idx="1">
+            <a:schemeClr val="accent1"/>
+          </a:lnRef>
+          <a:fillRef idx="3">
+            <a:schemeClr val="accent1"/>
+          </a:fillRef>
+          <a:effectRef idx="2">
+            <a:schemeClr val="accent1"/>
+          </a:effectRef>
+          <a:fontRef idx="minor">
+            <a:schemeClr val="lt1"/>
+          </a:fontRef>
+        </p:style>
+        <p:txBody>
+          <a:bodyPr rtlCol="0" anchor="ctr"/>
+          <a:lstStyle/>
+          <a:p>
+            <a:pPr algn="ctr"/>
+          </a:p>
+        </p:txBody>
+      </p:sp>
+      <p:sp>
+        <p:nvSpPr>
+          <p:cNvPr id="3" name="TextBox 2"/>
           <p:cNvSpPr txBox="1"/>
           <p:nvPr/>
         </p:nvSpPr>
@@ -3408,7 +4019,7 @@
       </p:sp>
       <p:sp>
         <p:nvSpPr>
-          <p:cNvPr id="3" name="TextBox 2"/>
+          <p:cNvPr id="4" name="TextBox 3"/>
           <p:cNvSpPr txBox="1"/>
           <p:nvPr/>
         </p:nvSpPr>
@@ -3444,7 +4055,7 @@
       </p:sp>
       <p:sp>
         <p:nvSpPr>
-          <p:cNvPr id="4" name="Rounded Rectangle 3"/>
+          <p:cNvPr id="5" name="Rounded Rectangle 4"/>
           <p:cNvSpPr/>
           <p:nvPr/>
         </p:nvSpPr>
@@ -3489,7 +4100,7 @@
       </p:sp>
       <p:sp>
         <p:nvSpPr>
-          <p:cNvPr id="5" name="TextBox 4"/>
+          <p:cNvPr id="6" name="TextBox 5"/>
           <p:cNvSpPr txBox="1"/>
           <p:nvPr/>
         </p:nvSpPr>
@@ -3525,7 +4136,7 @@
       </p:sp>
       <p:sp>
         <p:nvSpPr>
-          <p:cNvPr id="6" name="TextBox 5"/>
+          <p:cNvPr id="7" name="TextBox 6"/>
           <p:cNvSpPr txBox="1"/>
           <p:nvPr/>
         </p:nvSpPr>
@@ -3577,7 +4188,7 @@
       </p:sp>
       <p:sp>
         <p:nvSpPr>
-          <p:cNvPr id="7" name="Rounded Rectangle 6"/>
+          <p:cNvPr id="8" name="Rounded Rectangle 7"/>
           <p:cNvSpPr/>
           <p:nvPr/>
         </p:nvSpPr>
@@ -3622,7 +4233,7 @@
       </p:sp>
       <p:sp>
         <p:nvSpPr>
-          <p:cNvPr id="8" name="TextBox 7"/>
+          <p:cNvPr id="9" name="TextBox 8"/>
           <p:cNvSpPr txBox="1"/>
           <p:nvPr/>
         </p:nvSpPr>
@@ -3658,7 +4269,7 @@
       </p:sp>
       <p:sp>
         <p:nvSpPr>
-          <p:cNvPr id="9" name="TextBox 8"/>
+          <p:cNvPr id="10" name="TextBox 9"/>
           <p:cNvSpPr txBox="1"/>
           <p:nvPr/>
         </p:nvSpPr>
@@ -3710,7 +4321,7 @@
       </p:sp>
       <p:sp>
         <p:nvSpPr>
-          <p:cNvPr id="10" name="Rounded Rectangle 9"/>
+          <p:cNvPr id="11" name="Rounded Rectangle 10"/>
           <p:cNvSpPr/>
           <p:nvPr/>
         </p:nvSpPr>
@@ -3755,7 +4366,7 @@
       </p:sp>
       <p:sp>
         <p:nvSpPr>
-          <p:cNvPr id="11" name="TextBox 10"/>
+          <p:cNvPr id="12" name="TextBox 11"/>
           <p:cNvSpPr txBox="1"/>
           <p:nvPr/>
         </p:nvSpPr>
@@ -3791,7 +4402,7 @@
       </p:sp>
       <p:sp>
         <p:nvSpPr>
-          <p:cNvPr id="12" name="TextBox 11"/>
+          <p:cNvPr id="13" name="TextBox 12"/>
           <p:cNvSpPr txBox="1"/>
           <p:nvPr/>
         </p:nvSpPr>
@@ -3843,7 +4454,7 @@
       </p:sp>
       <p:sp>
         <p:nvSpPr>
-          <p:cNvPr id="13" name="Rounded Rectangle 12"/>
+          <p:cNvPr id="14" name="Rounded Rectangle 13"/>
           <p:cNvSpPr/>
           <p:nvPr/>
         </p:nvSpPr>
@@ -3888,7 +4499,50 @@
       </p:sp>
       <p:sp>
         <p:nvSpPr>
-          <p:cNvPr id="14" name="TextBox 13"/>
+          <p:cNvPr id="15" name="Rounded Rectangle 14"/>
+          <p:cNvSpPr/>
+          <p:nvPr/>
+        </p:nvSpPr>
+        <p:spPr>
+          <a:xfrm>
+            <a:off x="731520" y="4846320"/>
+            <a:ext cx="3291840" cy="73152"/>
+          </a:xfrm>
+          <a:prstGeom prst="roundRect">
+            <a:avLst/>
+          </a:prstGeom>
+          <a:solidFill>
+            <a:srgbClr val="EF4444"/>
+          </a:solidFill>
+          <a:ln>
+            <a:noFill/>
+          </a:ln>
+        </p:spPr>
+        <p:style>
+          <a:lnRef idx="1">
+            <a:schemeClr val="accent1"/>
+          </a:lnRef>
+          <a:fillRef idx="3">
+            <a:schemeClr val="accent1"/>
+          </a:fillRef>
+          <a:effectRef idx="2">
+            <a:schemeClr val="accent1"/>
+          </a:effectRef>
+          <a:fontRef idx="minor">
+            <a:schemeClr val="lt1"/>
+          </a:fontRef>
+        </p:style>
+        <p:txBody>
+          <a:bodyPr rtlCol="0" anchor="ctr"/>
+          <a:lstStyle/>
+          <a:p>
+            <a:pPr algn="ctr"/>
+          </a:p>
+        </p:txBody>
+      </p:sp>
+      <p:sp>
+        <p:nvSpPr>
+          <p:cNvPr id="16" name="TextBox 15"/>
           <p:cNvSpPr txBox="1"/>
           <p:nvPr/>
         </p:nvSpPr>
@@ -3940,7 +4594,7 @@
       </p:sp>
       <p:sp>
         <p:nvSpPr>
-          <p:cNvPr id="15" name="Rounded Rectangle 14"/>
+          <p:cNvPr id="17" name="Rounded Rectangle 16"/>
           <p:cNvSpPr/>
           <p:nvPr/>
         </p:nvSpPr>
@@ -3985,7 +4639,50 @@
       </p:sp>
       <p:sp>
         <p:nvSpPr>
-          <p:cNvPr id="16" name="TextBox 15"/>
+          <p:cNvPr id="18" name="Rounded Rectangle 17"/>
+          <p:cNvSpPr/>
+          <p:nvPr/>
+        </p:nvSpPr>
+        <p:spPr>
+          <a:xfrm>
+            <a:off x="4389120" y="4846320"/>
+            <a:ext cx="3291840" cy="73152"/>
+          </a:xfrm>
+          <a:prstGeom prst="roundRect">
+            <a:avLst/>
+          </a:prstGeom>
+          <a:solidFill>
+            <a:srgbClr val="EF4444"/>
+          </a:solidFill>
+          <a:ln>
+            <a:noFill/>
+          </a:ln>
+        </p:spPr>
+        <p:style>
+          <a:lnRef idx="1">
+            <a:schemeClr val="accent1"/>
+          </a:lnRef>
+          <a:fillRef idx="3">
+            <a:schemeClr val="accent1"/>
+          </a:fillRef>
+          <a:effectRef idx="2">
+            <a:schemeClr val="accent1"/>
+          </a:effectRef>
+          <a:fontRef idx="minor">
+            <a:schemeClr val="lt1"/>
+          </a:fontRef>
+        </p:style>
+        <p:txBody>
+          <a:bodyPr rtlCol="0" anchor="ctr"/>
+          <a:lstStyle/>
+          <a:p>
+            <a:pPr algn="ctr"/>
+          </a:p>
+        </p:txBody>
+      </p:sp>
+      <p:sp>
+        <p:nvSpPr>
+          <p:cNvPr id="19" name="TextBox 18"/>
           <p:cNvSpPr txBox="1"/>
           <p:nvPr/>
         </p:nvSpPr>
@@ -4037,7 +4734,7 @@
       </p:sp>
       <p:sp>
         <p:nvSpPr>
-          <p:cNvPr id="17" name="Rounded Rectangle 16"/>
+          <p:cNvPr id="20" name="Rounded Rectangle 19"/>
           <p:cNvSpPr/>
           <p:nvPr/>
         </p:nvSpPr>
@@ -4082,7 +4779,50 @@
       </p:sp>
       <p:sp>
         <p:nvSpPr>
-          <p:cNvPr id="18" name="TextBox 17"/>
+          <p:cNvPr id="21" name="Rounded Rectangle 20"/>
+          <p:cNvSpPr/>
+          <p:nvPr/>
+        </p:nvSpPr>
+        <p:spPr>
+          <a:xfrm>
+            <a:off x="8046720" y="4846320"/>
+            <a:ext cx="3291840" cy="73152"/>
+          </a:xfrm>
+          <a:prstGeom prst="roundRect">
+            <a:avLst/>
+          </a:prstGeom>
+          <a:solidFill>
+            <a:srgbClr val="EF4444"/>
+          </a:solidFill>
+          <a:ln>
+            <a:noFill/>
+          </a:ln>
+        </p:spPr>
+        <p:style>
+          <a:lnRef idx="1">
+            <a:schemeClr val="accent1"/>
+          </a:lnRef>
+          <a:fillRef idx="3">
+            <a:schemeClr val="accent1"/>
+          </a:fillRef>
+          <a:effectRef idx="2">
+            <a:schemeClr val="accent1"/>
+          </a:effectRef>
+          <a:fontRef idx="minor">
+            <a:schemeClr val="lt1"/>
+          </a:fontRef>
+        </p:style>
+        <p:txBody>
+          <a:bodyPr rtlCol="0" anchor="ctr"/>
+          <a:lstStyle/>
+          <a:p>
+            <a:pPr algn="ctr"/>
+          </a:p>
+        </p:txBody>
+      </p:sp>
+      <p:sp>
+        <p:nvSpPr>
+          <p:cNvPr id="22" name="TextBox 21"/>
           <p:cNvSpPr txBox="1"/>
           <p:nvPr/>
         </p:nvSpPr>
@@ -4160,7 +4900,50 @@
       <p:grpSpPr/>
       <p:sp>
         <p:nvSpPr>
-          <p:cNvPr id="2" name="TextBox 1"/>
+          <p:cNvPr id="2" name="Rectangle 1"/>
+          <p:cNvSpPr/>
+          <p:nvPr/>
+        </p:nvSpPr>
+        <p:spPr>
+          <a:xfrm>
+            <a:off x="137160" y="137160"/>
+            <a:ext cx="11914632" cy="6583680"/>
+          </a:xfrm>
+          <a:prstGeom prst="rect">
+            <a:avLst/>
+          </a:prstGeom>
+          <a:noFill/>
+          <a:ln w="19050">
+            <a:solidFill>
+              <a:srgbClr val="1E293B"/>
+            </a:solidFill>
+          </a:ln>
+        </p:spPr>
+        <p:style>
+          <a:lnRef idx="1">
+            <a:schemeClr val="accent1"/>
+          </a:lnRef>
+          <a:fillRef idx="3">
+            <a:schemeClr val="accent1"/>
+          </a:fillRef>
+          <a:effectRef idx="2">
+            <a:schemeClr val="accent1"/>
+          </a:effectRef>
+          <a:fontRef idx="minor">
+            <a:schemeClr val="lt1"/>
+          </a:fontRef>
+        </p:style>
+        <p:txBody>
+          <a:bodyPr rtlCol="0" anchor="ctr"/>
+          <a:lstStyle/>
+          <a:p>
+            <a:pPr algn="ctr"/>
+          </a:p>
+        </p:txBody>
+      </p:sp>
+      <p:sp>
+        <p:nvSpPr>
+          <p:cNvPr id="3" name="TextBox 2"/>
           <p:cNvSpPr txBox="1"/>
           <p:nvPr/>
         </p:nvSpPr>
@@ -4196,7 +4979,7 @@
       </p:sp>
       <p:sp>
         <p:nvSpPr>
-          <p:cNvPr id="3" name="TextBox 2"/>
+          <p:cNvPr id="4" name="TextBox 3"/>
           <p:cNvSpPr txBox="1"/>
           <p:nvPr/>
         </p:nvSpPr>
@@ -4232,7 +5015,7 @@
       </p:sp>
       <p:sp>
         <p:nvSpPr>
-          <p:cNvPr id="4" name="Rounded Rectangle 3"/>
+          <p:cNvPr id="5" name="Rounded Rectangle 4"/>
           <p:cNvSpPr/>
           <p:nvPr/>
         </p:nvSpPr>
@@ -4277,7 +5060,50 @@
       </p:sp>
       <p:sp>
         <p:nvSpPr>
-          <p:cNvPr id="5" name="TextBox 4"/>
+          <p:cNvPr id="6" name="Rounded Rectangle 5"/>
+          <p:cNvSpPr/>
+          <p:nvPr/>
+        </p:nvSpPr>
+        <p:spPr>
+          <a:xfrm>
+            <a:off x="731520" y="1463040"/>
+            <a:ext cx="5669280" cy="73152"/>
+          </a:xfrm>
+          <a:prstGeom prst="roundRect">
+            <a:avLst/>
+          </a:prstGeom>
+          <a:solidFill>
+            <a:srgbClr val="29B6D8"/>
+          </a:solidFill>
+          <a:ln>
+            <a:noFill/>
+          </a:ln>
+        </p:spPr>
+        <p:style>
+          <a:lnRef idx="1">
+            <a:schemeClr val="accent1"/>
+          </a:lnRef>
+          <a:fillRef idx="3">
+            <a:schemeClr val="accent1"/>
+          </a:fillRef>
+          <a:effectRef idx="2">
+            <a:schemeClr val="accent1"/>
+          </a:effectRef>
+          <a:fontRef idx="minor">
+            <a:schemeClr val="lt1"/>
+          </a:fontRef>
+        </p:style>
+        <p:txBody>
+          <a:bodyPr rtlCol="0" anchor="ctr"/>
+          <a:lstStyle/>
+          <a:p>
+            <a:pPr algn="ctr"/>
+          </a:p>
+        </p:txBody>
+      </p:sp>
+      <p:sp>
+        <p:nvSpPr>
+          <p:cNvPr id="7" name="TextBox 6"/>
           <p:cNvSpPr txBox="1"/>
           <p:nvPr/>
         </p:nvSpPr>
@@ -4317,7 +5143,7 @@
               <a:spcAft>
                 <a:spcPts val="800"/>
               </a:spcAft>
-              <a:defRPr sz="1250">
+              <a:defRPr sz="1150">
                 <a:solidFill>
                   <a:srgbClr val="FFFFFF"/>
                 </a:solidFill>
@@ -4333,7 +5159,7 @@
               <a:spcAft>
                 <a:spcPts val="800"/>
               </a:spcAft>
-              <a:defRPr sz="1250">
+              <a:defRPr sz="1150">
                 <a:solidFill>
                   <a:srgbClr val="FFFFFF"/>
                 </a:solidFill>
@@ -4349,7 +5175,7 @@
               <a:spcAft>
                 <a:spcPts val="800"/>
               </a:spcAft>
-              <a:defRPr sz="1250">
+              <a:defRPr sz="1150">
                 <a:solidFill>
                   <a:srgbClr val="FFFFFF"/>
                 </a:solidFill>
@@ -4364,7 +5190,7 @@
       </p:sp>
       <p:sp>
         <p:nvSpPr>
-          <p:cNvPr id="6" name="Rounded Rectangle 5"/>
+          <p:cNvPr id="8" name="Rounded Rectangle 7"/>
           <p:cNvSpPr/>
           <p:nvPr/>
         </p:nvSpPr>
@@ -4409,7 +5235,7 @@
       </p:sp>
       <p:sp>
         <p:nvSpPr>
-          <p:cNvPr id="7" name="TextBox 6"/>
+          <p:cNvPr id="9" name="TextBox 8"/>
           <p:cNvSpPr txBox="1"/>
           <p:nvPr/>
         </p:nvSpPr>
@@ -4461,7 +5287,7 @@
       </p:sp>
       <p:sp>
         <p:nvSpPr>
-          <p:cNvPr id="8" name="Rounded Rectangle 7"/>
+          <p:cNvPr id="10" name="Rounded Rectangle 9"/>
           <p:cNvSpPr/>
           <p:nvPr/>
         </p:nvSpPr>
@@ -4506,7 +5332,7 @@
       </p:sp>
       <p:sp>
         <p:nvSpPr>
-          <p:cNvPr id="9" name="TextBox 8"/>
+          <p:cNvPr id="11" name="TextBox 10"/>
           <p:cNvSpPr txBox="1"/>
           <p:nvPr/>
         </p:nvSpPr>
@@ -4558,7 +5384,7 @@
       </p:sp>
       <p:sp>
         <p:nvSpPr>
-          <p:cNvPr id="10" name="Rectangle 9"/>
+          <p:cNvPr id="12" name="Rectangle 11"/>
           <p:cNvSpPr/>
           <p:nvPr/>
         </p:nvSpPr>
@@ -4603,7 +5429,7 @@
       </p:sp>
       <p:sp>
         <p:nvSpPr>
-          <p:cNvPr id="11" name="Rectangle 10"/>
+          <p:cNvPr id="13" name="Rectangle 12"/>
           <p:cNvSpPr/>
           <p:nvPr/>
         </p:nvSpPr>
@@ -4674,7 +5500,50 @@
       <p:grpSpPr/>
       <p:sp>
         <p:nvSpPr>
-          <p:cNvPr id="2" name="TextBox 1"/>
+          <p:cNvPr id="2" name="Rectangle 1"/>
+          <p:cNvSpPr/>
+          <p:nvPr/>
+        </p:nvSpPr>
+        <p:spPr>
+          <a:xfrm>
+            <a:off x="137160" y="137160"/>
+            <a:ext cx="11914632" cy="6583680"/>
+          </a:xfrm>
+          <a:prstGeom prst="rect">
+            <a:avLst/>
+          </a:prstGeom>
+          <a:noFill/>
+          <a:ln w="19050">
+            <a:solidFill>
+              <a:srgbClr val="1E293B"/>
+            </a:solidFill>
+          </a:ln>
+        </p:spPr>
+        <p:style>
+          <a:lnRef idx="1">
+            <a:schemeClr val="accent1"/>
+          </a:lnRef>
+          <a:fillRef idx="3">
+            <a:schemeClr val="accent1"/>
+          </a:fillRef>
+          <a:effectRef idx="2">
+            <a:schemeClr val="accent1"/>
+          </a:effectRef>
+          <a:fontRef idx="minor">
+            <a:schemeClr val="lt1"/>
+          </a:fontRef>
+        </p:style>
+        <p:txBody>
+          <a:bodyPr rtlCol="0" anchor="ctr"/>
+          <a:lstStyle/>
+          <a:p>
+            <a:pPr algn="ctr"/>
+          </a:p>
+        </p:txBody>
+      </p:sp>
+      <p:sp>
+        <p:nvSpPr>
+          <p:cNvPr id="3" name="TextBox 2"/>
           <p:cNvSpPr txBox="1"/>
           <p:nvPr/>
         </p:nvSpPr>
@@ -4710,7 +5579,7 @@
       </p:sp>
       <p:sp>
         <p:nvSpPr>
-          <p:cNvPr id="3" name="TextBox 2"/>
+          <p:cNvPr id="4" name="TextBox 3"/>
           <p:cNvSpPr txBox="1"/>
           <p:nvPr/>
         </p:nvSpPr>
@@ -4746,14 +5615,14 @@
       </p:sp>
       <p:sp>
         <p:nvSpPr>
-          <p:cNvPr id="4" name="Rounded Rectangle 3"/>
+          <p:cNvPr id="5" name="Rounded Rectangle 4"/>
           <p:cNvSpPr/>
           <p:nvPr/>
         </p:nvSpPr>
         <p:spPr>
           <a:xfrm>
-            <a:off x="731520" y="1463040"/>
-            <a:ext cx="4754880" cy="4754880"/>
+            <a:off x="548640" y="1463040"/>
+            <a:ext cx="3657600" cy="4754880"/>
           </a:xfrm>
           <a:prstGeom prst="roundRect">
             <a:avLst/>
@@ -4791,14 +5660,57 @@
       </p:sp>
       <p:sp>
         <p:nvSpPr>
-          <p:cNvPr id="5" name="TextBox 4"/>
+          <p:cNvPr id="6" name="Rounded Rectangle 5"/>
+          <p:cNvSpPr/>
+          <p:nvPr/>
+        </p:nvSpPr>
+        <p:spPr>
+          <a:xfrm>
+            <a:off x="548640" y="1463040"/>
+            <a:ext cx="3657600" cy="73152"/>
+          </a:xfrm>
+          <a:prstGeom prst="roundRect">
+            <a:avLst/>
+          </a:prstGeom>
+          <a:solidFill>
+            <a:srgbClr val="29B6D8"/>
+          </a:solidFill>
+          <a:ln>
+            <a:noFill/>
+          </a:ln>
+        </p:spPr>
+        <p:style>
+          <a:lnRef idx="1">
+            <a:schemeClr val="accent1"/>
+          </a:lnRef>
+          <a:fillRef idx="3">
+            <a:schemeClr val="accent1"/>
+          </a:fillRef>
+          <a:effectRef idx="2">
+            <a:schemeClr val="accent1"/>
+          </a:effectRef>
+          <a:fontRef idx="minor">
+            <a:schemeClr val="lt1"/>
+          </a:fontRef>
+        </p:style>
+        <p:txBody>
+          <a:bodyPr rtlCol="0" anchor="ctr"/>
+          <a:lstStyle/>
+          <a:p>
+            <a:pPr algn="ctr"/>
+          </a:p>
+        </p:txBody>
+      </p:sp>
+      <p:sp>
+        <p:nvSpPr>
+          <p:cNvPr id="7" name="TextBox 6"/>
           <p:cNvSpPr txBox="1"/>
           <p:nvPr/>
         </p:nvSpPr>
         <p:spPr>
           <a:xfrm>
-            <a:off x="1005840" y="1737360"/>
-            <a:ext cx="4206240" cy="4206240"/>
+            <a:off x="822960" y="1737360"/>
+            <a:ext cx="3108960" cy="4206240"/>
           </a:xfrm>
           <a:prstGeom prst="rect">
             <a:avLst/>
@@ -4823,7 +5735,7 @@
               </a:defRPr>
             </a:pPr>
             <a:r>
-              <a:t>Dimensionnement Sur-Mesure par Algorithme</a:t>
+              <a:t>Dimensionnement Sur-Mesure</a:t>
             </a:r>
           </a:p>
           <a:p>
@@ -4831,7 +5743,7 @@
               <a:spcAft>
                 <a:spcPts val="800"/>
               </a:spcAft>
-              <a:defRPr sz="1250">
+              <a:defRPr sz="1150">
                 <a:solidFill>
                   <a:srgbClr val="FFFFFF"/>
                 </a:solidFill>
@@ -4847,7 +5759,7 @@
               <a:spcAft>
                 <a:spcPts val="800"/>
               </a:spcAft>
-              <a:defRPr sz="1250">
+              <a:defRPr sz="1150">
                 <a:solidFill>
                   <a:srgbClr val="FFFFFF"/>
                 </a:solidFill>
@@ -4863,7 +5775,7 @@
               <a:spcAft>
                 <a:spcPts val="800"/>
               </a:spcAft>
-              <a:defRPr sz="1250">
+              <a:defRPr sz="1150">
                 <a:solidFill>
                   <a:srgbClr val="FFFFFF"/>
                 </a:solidFill>
@@ -4879,7 +5791,7 @@
               <a:spcAft>
                 <a:spcPts val="800"/>
               </a:spcAft>
-              <a:defRPr sz="1250">
+              <a:defRPr sz="1150">
                 <a:solidFill>
                   <a:srgbClr val="FFFFFF"/>
                 </a:solidFill>
@@ -4894,14 +5806,14 @@
       </p:sp>
       <p:sp>
         <p:nvSpPr>
-          <p:cNvPr id="6" name="Rounded Rectangle 5"/>
+          <p:cNvPr id="8" name="Rounded Rectangle 7"/>
           <p:cNvSpPr/>
           <p:nvPr/>
         </p:nvSpPr>
         <p:spPr>
           <a:xfrm>
-            <a:off x="5852160" y="1463040"/>
-            <a:ext cx="5577840" cy="4754880"/>
+            <a:off x="4389120" y="1463040"/>
+            <a:ext cx="7223760" cy="4754880"/>
           </a:xfrm>
           <a:prstGeom prst="roundRect">
             <a:avLst/>
@@ -4939,14 +5851,14 @@
       </p:sp>
       <p:sp>
         <p:nvSpPr>
-          <p:cNvPr id="7" name="Rectangle 6"/>
+          <p:cNvPr id="9" name="Rectangle 8"/>
           <p:cNvSpPr/>
           <p:nvPr/>
         </p:nvSpPr>
         <p:spPr>
           <a:xfrm>
-            <a:off x="5989320" y="1874520"/>
-            <a:ext cx="5303520" cy="3931920"/>
+            <a:off x="4434840" y="1600200"/>
+            <a:ext cx="7132320" cy="4480560"/>
           </a:xfrm>
           <a:prstGeom prst="rect">
             <a:avLst/>
@@ -4984,7 +5896,7 @@
       </p:sp>
       <p:pic>
         <p:nvPicPr>
-          <p:cNvPr id="8" name="Picture 7" descr="streamlit_app.png"/>
+          <p:cNvPr id="10" name="Picture 9" descr="streamlit_app.png"/>
           <p:cNvPicPr>
             <a:picLocks noChangeAspect="1"/>
           </p:cNvPicPr>
@@ -4998,8 +5910,8 @@
         </p:blipFill>
         <p:spPr>
           <a:xfrm>
-            <a:off x="6035040" y="1920240"/>
-            <a:ext cx="5212080" cy="3840480"/>
+            <a:off x="4480560" y="1645920"/>
+            <a:ext cx="7040880" cy="4389120"/>
           </a:xfrm>
           <a:prstGeom prst="rect">
             <a:avLst/>
@@ -5034,7 +5946,50 @@
       <p:grpSpPr/>
       <p:sp>
         <p:nvSpPr>
-          <p:cNvPr id="2" name="TextBox 1"/>
+          <p:cNvPr id="2" name="Rectangle 1"/>
+          <p:cNvSpPr/>
+          <p:nvPr/>
+        </p:nvSpPr>
+        <p:spPr>
+          <a:xfrm>
+            <a:off x="137160" y="137160"/>
+            <a:ext cx="11914632" cy="6583680"/>
+          </a:xfrm>
+          <a:prstGeom prst="rect">
+            <a:avLst/>
+          </a:prstGeom>
+          <a:noFill/>
+          <a:ln w="19050">
+            <a:solidFill>
+              <a:srgbClr val="1E293B"/>
+            </a:solidFill>
+          </a:ln>
+        </p:spPr>
+        <p:style>
+          <a:lnRef idx="1">
+            <a:schemeClr val="accent1"/>
+          </a:lnRef>
+          <a:fillRef idx="3">
+            <a:schemeClr val="accent1"/>
+          </a:fillRef>
+          <a:effectRef idx="2">
+            <a:schemeClr val="accent1"/>
+          </a:effectRef>
+          <a:fontRef idx="minor">
+            <a:schemeClr val="lt1"/>
+          </a:fontRef>
+        </p:style>
+        <p:txBody>
+          <a:bodyPr rtlCol="0" anchor="ctr"/>
+          <a:lstStyle/>
+          <a:p>
+            <a:pPr algn="ctr"/>
+          </a:p>
+        </p:txBody>
+      </p:sp>
+      <p:sp>
+        <p:nvSpPr>
+          <p:cNvPr id="3" name="TextBox 2"/>
           <p:cNvSpPr txBox="1"/>
           <p:nvPr/>
         </p:nvSpPr>
@@ -5070,7 +6025,7 @@
       </p:sp>
       <p:sp>
         <p:nvSpPr>
-          <p:cNvPr id="3" name="TextBox 2"/>
+          <p:cNvPr id="4" name="TextBox 3"/>
           <p:cNvSpPr txBox="1"/>
           <p:nvPr/>
         </p:nvSpPr>
@@ -5106,14 +6061,14 @@
       </p:sp>
       <p:sp>
         <p:nvSpPr>
-          <p:cNvPr id="4" name="Rounded Rectangle 3"/>
+          <p:cNvPr id="5" name="Rounded Rectangle 4"/>
           <p:cNvSpPr/>
           <p:nvPr/>
         </p:nvSpPr>
         <p:spPr>
           <a:xfrm>
-            <a:off x="731520" y="1463040"/>
-            <a:ext cx="4754880" cy="4754880"/>
+            <a:off x="548640" y="1463040"/>
+            <a:ext cx="3657600" cy="4754880"/>
           </a:xfrm>
           <a:prstGeom prst="roundRect">
             <a:avLst/>
@@ -5151,14 +6106,57 @@
       </p:sp>
       <p:sp>
         <p:nvSpPr>
-          <p:cNvPr id="5" name="TextBox 4"/>
+          <p:cNvPr id="6" name="Rounded Rectangle 5"/>
+          <p:cNvSpPr/>
+          <p:nvPr/>
+        </p:nvSpPr>
+        <p:spPr>
+          <a:xfrm>
+            <a:off x="548640" y="1463040"/>
+            <a:ext cx="3657600" cy="73152"/>
+          </a:xfrm>
+          <a:prstGeom prst="roundRect">
+            <a:avLst/>
+          </a:prstGeom>
+          <a:solidFill>
+            <a:srgbClr val="29B6D8"/>
+          </a:solidFill>
+          <a:ln>
+            <a:noFill/>
+          </a:ln>
+        </p:spPr>
+        <p:style>
+          <a:lnRef idx="1">
+            <a:schemeClr val="accent1"/>
+          </a:lnRef>
+          <a:fillRef idx="3">
+            <a:schemeClr val="accent1"/>
+          </a:fillRef>
+          <a:effectRef idx="2">
+            <a:schemeClr val="accent1"/>
+          </a:effectRef>
+          <a:fontRef idx="minor">
+            <a:schemeClr val="lt1"/>
+          </a:fontRef>
+        </p:style>
+        <p:txBody>
+          <a:bodyPr rtlCol="0" anchor="ctr"/>
+          <a:lstStyle/>
+          <a:p>
+            <a:pPr algn="ctr"/>
+          </a:p>
+        </p:txBody>
+      </p:sp>
+      <p:sp>
+        <p:nvSpPr>
+          <p:cNvPr id="7" name="TextBox 6"/>
           <p:cNvSpPr txBox="1"/>
           <p:nvPr/>
         </p:nvSpPr>
         <p:spPr>
           <a:xfrm>
-            <a:off x="1005840" y="1737360"/>
-            <a:ext cx="4206240" cy="4206240"/>
+            <a:off x="822960" y="1737360"/>
+            <a:ext cx="3108960" cy="4206240"/>
           </a:xfrm>
           <a:prstGeom prst="rect">
             <a:avLst/>
@@ -5183,7 +6181,7 @@
               </a:defRPr>
             </a:pPr>
             <a:r>
-              <a:t>Un Design Optimisé pour la Fabrication (DFM)</a:t>
+              <a:t>Design Optimisé (DFM)</a:t>
             </a:r>
           </a:p>
           <a:p>
@@ -5191,7 +6189,7 @@
               <a:spcAft>
                 <a:spcPts val="800"/>
               </a:spcAft>
-              <a:defRPr sz="1250">
+              <a:defRPr sz="1150">
                 <a:solidFill>
                   <a:srgbClr val="FFFFFF"/>
                 </a:solidFill>
@@ -5207,7 +6205,7 @@
               <a:spcAft>
                 <a:spcPts val="800"/>
               </a:spcAft>
-              <a:defRPr sz="1250">
+              <a:defRPr sz="1150">
                 <a:solidFill>
                   <a:srgbClr val="FFFFFF"/>
                 </a:solidFill>
@@ -5223,7 +6221,7 @@
               <a:spcAft>
                 <a:spcPts val="800"/>
               </a:spcAft>
-              <a:defRPr sz="1250">
+              <a:defRPr sz="1150">
                 <a:solidFill>
                   <a:srgbClr val="FFFFFF"/>
                 </a:solidFill>
@@ -5239,7 +6237,7 @@
               <a:spcAft>
                 <a:spcPts val="800"/>
               </a:spcAft>
-              <a:defRPr sz="1250">
+              <a:defRPr sz="1150">
                 <a:solidFill>
                   <a:srgbClr val="FFFFFF"/>
                 </a:solidFill>
@@ -5254,14 +6252,14 @@
       </p:sp>
       <p:sp>
         <p:nvSpPr>
-          <p:cNvPr id="6" name="Rounded Rectangle 5"/>
+          <p:cNvPr id="8" name="Rounded Rectangle 7"/>
           <p:cNvSpPr/>
           <p:nvPr/>
         </p:nvSpPr>
         <p:spPr>
           <a:xfrm>
-            <a:off x="5852160" y="1463040"/>
-            <a:ext cx="5577840" cy="4754880"/>
+            <a:off x="4389120" y="1463040"/>
+            <a:ext cx="7223760" cy="4754880"/>
           </a:xfrm>
           <a:prstGeom prst="roundRect">
             <a:avLst/>
@@ -5299,14 +6297,14 @@
       </p:sp>
       <p:sp>
         <p:nvSpPr>
-          <p:cNvPr id="7" name="Rectangle 6"/>
+          <p:cNvPr id="9" name="Rectangle 8"/>
           <p:cNvSpPr/>
           <p:nvPr/>
         </p:nvSpPr>
         <p:spPr>
           <a:xfrm>
-            <a:off x="5989320" y="1874520"/>
-            <a:ext cx="5303520" cy="3931920"/>
+            <a:off x="4434840" y="1600200"/>
+            <a:ext cx="7132320" cy="4480560"/>
           </a:xfrm>
           <a:prstGeom prst="rect">
             <a:avLst/>
@@ -5344,7 +6342,7 @@
       </p:sp>
       <p:pic>
         <p:nvPicPr>
-          <p:cNvPr id="8" name="Picture 7" descr="Capture d'écran 2026-07-08 192651.png"/>
+          <p:cNvPr id="10" name="Picture 9" descr="Capture d'écran 2026-07-08 192651.png"/>
           <p:cNvPicPr>
             <a:picLocks noChangeAspect="1"/>
           </p:cNvPicPr>
@@ -5358,8 +6356,8 @@
         </p:blipFill>
         <p:spPr>
           <a:xfrm>
-            <a:off x="6035040" y="1920240"/>
-            <a:ext cx="5212080" cy="3840480"/>
+            <a:off x="4480560" y="1645920"/>
+            <a:ext cx="7040880" cy="4389120"/>
           </a:xfrm>
           <a:prstGeom prst="rect">
             <a:avLst/>
@@ -5394,7 +6392,50 @@
       <p:grpSpPr/>
       <p:sp>
         <p:nvSpPr>
-          <p:cNvPr id="2" name="TextBox 1"/>
+          <p:cNvPr id="2" name="Rectangle 1"/>
+          <p:cNvSpPr/>
+          <p:nvPr/>
+        </p:nvSpPr>
+        <p:spPr>
+          <a:xfrm>
+            <a:off x="137160" y="137160"/>
+            <a:ext cx="11914632" cy="6583680"/>
+          </a:xfrm>
+          <a:prstGeom prst="rect">
+            <a:avLst/>
+          </a:prstGeom>
+          <a:noFill/>
+          <a:ln w="19050">
+            <a:solidFill>
+              <a:srgbClr val="1E293B"/>
+            </a:solidFill>
+          </a:ln>
+        </p:spPr>
+        <p:style>
+          <a:lnRef idx="1">
+            <a:schemeClr val="accent1"/>
+          </a:lnRef>
+          <a:fillRef idx="3">
+            <a:schemeClr val="accent1"/>
+          </a:fillRef>
+          <a:effectRef idx="2">
+            <a:schemeClr val="accent1"/>
+          </a:effectRef>
+          <a:fontRef idx="minor">
+            <a:schemeClr val="lt1"/>
+          </a:fontRef>
+        </p:style>
+        <p:txBody>
+          <a:bodyPr rtlCol="0" anchor="ctr"/>
+          <a:lstStyle/>
+          <a:p>
+            <a:pPr algn="ctr"/>
+          </a:p>
+        </p:txBody>
+      </p:sp>
+      <p:sp>
+        <p:nvSpPr>
+          <p:cNvPr id="3" name="TextBox 2"/>
           <p:cNvSpPr txBox="1"/>
           <p:nvPr/>
         </p:nvSpPr>
@@ -5430,7 +6471,7 @@
       </p:sp>
       <p:sp>
         <p:nvSpPr>
-          <p:cNvPr id="3" name="TextBox 2"/>
+          <p:cNvPr id="4" name="TextBox 3"/>
           <p:cNvSpPr txBox="1"/>
           <p:nvPr/>
         </p:nvSpPr>
@@ -5459,14 +6500,14 @@
               </a:defRPr>
             </a:pPr>
             <a:r>
-              <a:t>Contrôle-Commande &amp; Automatisation</a:t>
-            </a:r>
-          </a:p>
-        </p:txBody>
-      </p:sp>
-      <p:sp>
-        <p:nvSpPr>
-          <p:cNvPr id="4" name="Rounded Rectangle 3"/>
+              <a:t>Architecture Électrotechnique &amp; Instrumentation</a:t>
+            </a:r>
+          </a:p>
+        </p:txBody>
+      </p:sp>
+      <p:sp>
+        <p:nvSpPr>
+          <p:cNvPr id="5" name="Rounded Rectangle 4"/>
           <p:cNvSpPr/>
           <p:nvPr/>
         </p:nvSpPr>
@@ -5511,7 +6552,50 @@
       </p:sp>
       <p:sp>
         <p:nvSpPr>
-          <p:cNvPr id="5" name="TextBox 4"/>
+          <p:cNvPr id="6" name="Rounded Rectangle 5"/>
+          <p:cNvSpPr/>
+          <p:nvPr/>
+        </p:nvSpPr>
+        <p:spPr>
+          <a:xfrm>
+            <a:off x="731520" y="1463040"/>
+            <a:ext cx="5120640" cy="73152"/>
+          </a:xfrm>
+          <a:prstGeom prst="roundRect">
+            <a:avLst/>
+          </a:prstGeom>
+          <a:solidFill>
+            <a:srgbClr val="29B6D8"/>
+          </a:solidFill>
+          <a:ln>
+            <a:noFill/>
+          </a:ln>
+        </p:spPr>
+        <p:style>
+          <a:lnRef idx="1">
+            <a:schemeClr val="accent1"/>
+          </a:lnRef>
+          <a:fillRef idx="3">
+            <a:schemeClr val="accent1"/>
+          </a:fillRef>
+          <a:effectRef idx="2">
+            <a:schemeClr val="accent1"/>
+          </a:effectRef>
+          <a:fontRef idx="minor">
+            <a:schemeClr val="lt1"/>
+          </a:fontRef>
+        </p:style>
+        <p:txBody>
+          <a:bodyPr rtlCol="0" anchor="ctr"/>
+          <a:lstStyle/>
+          <a:p>
+            <a:pPr algn="ctr"/>
+          </a:p>
+        </p:txBody>
+      </p:sp>
+      <p:sp>
+        <p:nvSpPr>
+          <p:cNvPr id="7" name="TextBox 6"/>
           <p:cNvSpPr txBox="1"/>
           <p:nvPr/>
         </p:nvSpPr>
@@ -5543,7 +6627,7 @@
               </a:defRPr>
             </a:pPr>
             <a:r>
-              <a:t>Le Cerveau Électrique et Régulation</a:t>
+              <a:t>Le Cerveau Industriel Siemens S7-1200</a:t>
             </a:r>
           </a:p>
           <a:p>
@@ -5551,7 +6635,7 @@
               <a:spcAft>
                 <a:spcPts val="800"/>
               </a:spcAft>
-              <a:defRPr sz="1250">
+              <a:defRPr sz="1150">
                 <a:solidFill>
                   <a:srgbClr val="FFFFFF"/>
                 </a:solidFill>
@@ -5559,7 +6643,7 @@
               </a:defRPr>
             </a:pPr>
             <a:r>
-              <a:t>• Automate Industriel (PLC) : Régulation intelligente PID des flux thermiques. Basculement automatique entre les phases de charge nocturne et de décharge diurne.</a:t>
+              <a:t>• Cas de Référence Soummam : Solution conçue pour décarboner la logistique froide (20 000 m³ de stockage, 110 chambres froides, 1 200 camions frigorifiques) en Algérie.</a:t>
             </a:r>
           </a:p>
           <a:p>
@@ -5567,7 +6651,7 @@
               <a:spcAft>
                 <a:spcPts val="800"/>
               </a:spcAft>
-              <a:defRPr sz="1250">
+              <a:defRPr sz="1150">
                 <a:solidFill>
                   <a:srgbClr val="FFFFFF"/>
                 </a:solidFill>
@@ -5575,7 +6659,7 @@
               </a:defRPr>
             </a:pPr>
             <a:r>
-              <a:t>• Interface IHM (Écran Tactile) : Supervision locale et affichage en temps réel de l'état de charge (SOC) de la batterie thermique et des températures MCP.</a:t>
+              <a:t>• Technologie Scroll Optimale : Choix de compresseurs Scroll triphasés (1.5 à 3.5 kW) des marques de référence Bitzer, Copeland, Danfoss.</a:t>
             </a:r>
           </a:p>
           <a:p>
@@ -5583,7 +6667,7 @@
               <a:spcAft>
                 <a:spcPts val="800"/>
               </a:spcAft>
-              <a:defRPr sz="1250">
+              <a:defRPr sz="1150">
                 <a:solidFill>
                   <a:srgbClr val="FFFFFF"/>
                 </a:solidFill>
@@ -5591,7 +6675,7 @@
               </a:defRPr>
             </a:pPr>
             <a:r>
-              <a:t>• Gestion de Secours Intégrée : En cas de coupure réseau, l'automate pilote le passage instantané de la ventilation sur l'onduleur de secours (UPS) pour continuer à diffuser le froid stocké.</a:t>
+              <a:t>• Instrumentation Terrain : Sondes de température PT100 (RTD classe A) pour le suivi de charge du MCP et analyseur de réseau sur le secteur principal.</a:t>
             </a:r>
           </a:p>
           <a:p>
@@ -5599,7 +6683,7 @@
               <a:spcAft>
                 <a:spcPts val="800"/>
               </a:spcAft>
-              <a:defRPr sz="1250">
+              <a:defRPr sz="1150">
                 <a:solidFill>
                   <a:srgbClr val="FFFFFF"/>
                 </a:solidFill>
@@ -5607,14 +6691,14 @@
               </a:defRPr>
             </a:pPr>
             <a:r>
-              <a:t>• Protection Électrique : Coffret câblé selon les normes industrielles avec sectionneurs, relais thermiques et contacteurs de puissance.</a:t>
-            </a:r>
-          </a:p>
-        </p:txBody>
-      </p:sp>
-      <p:sp>
-        <p:nvSpPr>
-          <p:cNvPr id="6" name="Rounded Rectangle 5"/>
+              <a:t>• Commande Centralisée : Automate Siemens S7-1200 avec cartes d'extension analogiques régulant l'ensemble par boucle de contrôle fermée.</a:t>
+            </a:r>
+          </a:p>
+        </p:txBody>
+      </p:sp>
+      <p:sp>
+        <p:nvSpPr>
+          <p:cNvPr id="8" name="Rounded Rectangle 7"/>
           <p:cNvSpPr/>
           <p:nvPr/>
         </p:nvSpPr>
@@ -5628,145 +6712,6 @@
           </a:prstGeom>
           <a:solidFill>
             <a:srgbClr val="101C30"/>
-          </a:solidFill>
-          <a:ln w="19050">
-            <a:solidFill>
-              <a:srgbClr val="1B2C49"/>
-            </a:solidFill>
-          </a:ln>
-        </p:spPr>
-        <p:style>
-          <a:lnRef idx="1">
-            <a:schemeClr val="accent1"/>
-          </a:lnRef>
-          <a:fillRef idx="3">
-            <a:schemeClr val="accent1"/>
-          </a:fillRef>
-          <a:effectRef idx="2">
-            <a:schemeClr val="accent1"/>
-          </a:effectRef>
-          <a:fontRef idx="minor">
-            <a:schemeClr val="lt1"/>
-          </a:fontRef>
-        </p:style>
-        <p:txBody>
-          <a:bodyPr rtlCol="0" anchor="ctr"/>
-          <a:lstStyle/>
-          <a:p>
-            <a:pPr algn="ctr"/>
-          </a:p>
-        </p:txBody>
-      </p:sp>
-      <p:sp>
-        <p:nvSpPr>
-          <p:cNvPr id="7" name="Rounded Rectangle 6"/>
-          <p:cNvSpPr/>
-          <p:nvPr/>
-        </p:nvSpPr>
-        <p:spPr>
-          <a:xfrm>
-            <a:off x="6675120" y="1828800"/>
-            <a:ext cx="4297680" cy="1051560"/>
-          </a:xfrm>
-          <a:prstGeom prst="roundRect">
-            <a:avLst/>
-          </a:prstGeom>
-          <a:solidFill>
-            <a:srgbClr val="101C30"/>
-          </a:solidFill>
-          <a:ln w="19050">
-            <a:solidFill>
-              <a:srgbClr val="1B2C49"/>
-            </a:solidFill>
-          </a:ln>
-        </p:spPr>
-        <p:style>
-          <a:lnRef idx="1">
-            <a:schemeClr val="accent1"/>
-          </a:lnRef>
-          <a:fillRef idx="3">
-            <a:schemeClr val="accent1"/>
-          </a:fillRef>
-          <a:effectRef idx="2">
-            <a:schemeClr val="accent1"/>
-          </a:effectRef>
-          <a:fontRef idx="minor">
-            <a:schemeClr val="lt1"/>
-          </a:fontRef>
-        </p:style>
-        <p:txBody>
-          <a:bodyPr rtlCol="0" anchor="ctr"/>
-          <a:lstStyle/>
-          <a:p>
-            <a:pPr algn="ctr"/>
-          </a:p>
-        </p:txBody>
-      </p:sp>
-      <p:sp>
-        <p:nvSpPr>
-          <p:cNvPr id="8" name="TextBox 7"/>
-          <p:cNvSpPr txBox="1"/>
-          <p:nvPr/>
-        </p:nvSpPr>
-        <p:spPr>
-          <a:xfrm>
-            <a:off x="6858000" y="1920240"/>
-            <a:ext cx="3931920" cy="822960"/>
-          </a:xfrm>
-          <a:prstGeom prst="rect">
-            <a:avLst/>
-          </a:prstGeom>
-          <a:noFill/>
-        </p:spPr>
-        <p:txBody>
-          <a:bodyPr wrap="square" lIns="0" tIns="0" rIns="0" bIns="0" anchor="ctr">
-            <a:spAutoFit/>
-          </a:bodyPr>
-          <a:lstStyle/>
-          <a:p>
-            <a:pPr algn="ctr">
-              <a:defRPr sz="1200" b="1">
-                <a:solidFill>
-                  <a:srgbClr val="29B6D8"/>
-                </a:solidFill>
-                <a:latin typeface="Segoe UI"/>
-              </a:defRPr>
-            </a:pPr>
-            <a:r>
-              <a:t>1. Capteurs Thermiques (MCP &amp; Air)</a:t>
-            </a:r>
-          </a:p>
-          <a:p>
-            <a:pPr algn="ctr">
-              <a:defRPr sz="1100">
-                <a:solidFill>
-                  <a:srgbClr val="FFFFFF"/>
-                </a:solidFill>
-                <a:latin typeface="Segoe UI"/>
-              </a:defRPr>
-            </a:pPr>
-            <a:r>
-              <a:t>Mesure en continu des températures du MCP et de l'air pour calculer l'état de charge (SOC).</a:t>
-            </a:r>
-          </a:p>
-        </p:txBody>
-      </p:sp>
-      <p:sp>
-        <p:nvSpPr>
-          <p:cNvPr id="9" name="Rounded Rectangle 8"/>
-          <p:cNvSpPr/>
-          <p:nvPr/>
-        </p:nvSpPr>
-        <p:spPr>
-          <a:xfrm>
-            <a:off x="6675120" y="3200400"/>
-            <a:ext cx="4297680" cy="1051560"/>
-          </a:xfrm>
-          <a:prstGeom prst="roundRect">
-            <a:avLst/>
-          </a:prstGeom>
-          <a:solidFill>
-            <a:srgbClr val="1B365D"/>
           </a:solidFill>
           <a:ln w="19050">
             <a:solidFill>
@@ -5798,74 +6743,23 @@
       </p:sp>
       <p:sp>
         <p:nvSpPr>
-          <p:cNvPr id="10" name="TextBox 9"/>
-          <p:cNvSpPr txBox="1"/>
-          <p:nvPr/>
-        </p:nvSpPr>
-        <p:spPr>
-          <a:xfrm>
-            <a:off x="6858000" y="3291840"/>
-            <a:ext cx="3931920" cy="822960"/>
-          </a:xfrm>
-          <a:prstGeom prst="rect">
-            <a:avLst/>
-          </a:prstGeom>
-          <a:noFill/>
-        </p:spPr>
-        <p:txBody>
-          <a:bodyPr wrap="square" lIns="0" tIns="0" rIns="0" bIns="0" anchor="ctr">
-            <a:spAutoFit/>
-          </a:bodyPr>
-          <a:lstStyle/>
-          <a:p>
-            <a:pPr algn="ctr">
-              <a:defRPr sz="1200" b="1">
-                <a:solidFill>
-                  <a:srgbClr val="29B6D8"/>
-                </a:solidFill>
-                <a:latin typeface="Segoe UI"/>
-              </a:defRPr>
-            </a:pPr>
-            <a:r>
-              <a:t>2. Automate PLC &amp; Écran IHM</a:t>
-            </a:r>
-          </a:p>
-          <a:p>
-            <a:pPr algn="ctr">
-              <a:defRPr sz="1100">
-                <a:solidFill>
-                  <a:srgbClr val="FFFFFF"/>
-                </a:solidFill>
-                <a:latin typeface="Segoe UI"/>
-              </a:defRPr>
-            </a:pPr>
-            <a:r>
-              <a:t>Traitement des données, régulation PID, gestion des vannes et interface de contrôle opérateur.</a:t>
-            </a:r>
-          </a:p>
-        </p:txBody>
-      </p:sp>
-      <p:sp>
-        <p:nvSpPr>
-          <p:cNvPr id="11" name="Rounded Rectangle 10"/>
+          <p:cNvPr id="9" name="Rounded Rectangle 8"/>
           <p:cNvSpPr/>
           <p:nvPr/>
         </p:nvSpPr>
         <p:spPr>
           <a:xfrm>
-            <a:off x="6675120" y="4572000"/>
-            <a:ext cx="4297680" cy="1051560"/>
+            <a:off x="6217920" y="1463040"/>
+            <a:ext cx="5212080" cy="73152"/>
           </a:xfrm>
           <a:prstGeom prst="roundRect">
             <a:avLst/>
           </a:prstGeom>
           <a:solidFill>
-            <a:srgbClr val="101C30"/>
+            <a:srgbClr val="29B6D8"/>
           </a:solidFill>
-          <a:ln w="19050">
-            <a:solidFill>
-              <a:srgbClr val="1B2C49"/>
-            </a:solidFill>
+          <a:ln>
+            <a:noFill/>
           </a:ln>
         </p:spPr>
         <p:style>
@@ -5892,14 +6786,14 @@
       </p:sp>
       <p:sp>
         <p:nvSpPr>
-          <p:cNvPr id="12" name="TextBox 11"/>
+          <p:cNvPr id="10" name="TextBox 9"/>
           <p:cNvSpPr txBox="1"/>
           <p:nvPr/>
         </p:nvSpPr>
         <p:spPr>
           <a:xfrm>
-            <a:off x="6858000" y="4663440"/>
-            <a:ext cx="3931920" cy="822960"/>
+            <a:off x="6492240" y="1737360"/>
+            <a:ext cx="4663440" cy="4206240"/>
           </a:xfrm>
           <a:prstGeom prst="rect">
             <a:avLst/>
@@ -5907,13 +6801,16 @@
           <a:noFill/>
         </p:spPr>
         <p:txBody>
-          <a:bodyPr wrap="square" lIns="0" tIns="0" rIns="0" bIns="0" anchor="ctr">
+          <a:bodyPr wrap="square" lIns="0" rIns="0" tIns="0" bIns="0" anchor="ctr">
             <a:spAutoFit/>
           </a:bodyPr>
           <a:lstStyle/>
           <a:p>
             <a:pPr algn="ctr">
-              <a:defRPr sz="1200" b="1">
+              <a:spcAft>
+                <a:spcPts val="1000"/>
+              </a:spcAft>
+              <a:defRPr sz="1700" b="1">
                 <a:solidFill>
                   <a:srgbClr val="29B6D8"/>
                 </a:solidFill>
@@ -5921,12 +6818,15 @@
               </a:defRPr>
             </a:pPr>
             <a:r>
-              <a:t>3. Ventilation &amp; Onduleur UPS</a:t>
+              <a:t>Bilan des Puissances &amp; Secours (UPS)</a:t>
             </a:r>
           </a:p>
           <a:p>
             <a:pPr algn="ctr">
-              <a:defRPr sz="1100">
+              <a:spcAft>
+                <a:spcPts val="800"/>
+              </a:spcAft>
+              <a:defRPr sz="1150">
                 <a:solidFill>
                   <a:srgbClr val="FFFFFF"/>
                 </a:solidFill>
@@ -5934,7 +6834,55 @@
               </a:defRPr>
             </a:pPr>
             <a:r>
-              <a:t>Activation de la soufflerie (60W-120W) secourue par UPS (LiFePO4 1.6 kWh) pendant 13 heures de délestage.</a:t>
+              <a:t>• Ventilation Forcée Active : Soufflerie de 15W par module, consommant un total extrêmement bas de 120W à 240W (négligeable face au compresseur de 15 kW).</a:t>
+            </a:r>
+          </a:p>
+          <a:p>
+            <a:pPr algn="ctr">
+              <a:spcAft>
+                <a:spcPts val="800"/>
+              </a:spcAft>
+              <a:defRPr sz="1150">
+                <a:solidFill>
+                  <a:srgbClr val="FFFFFF"/>
+                </a:solidFill>
+                <a:latin typeface="Segoe UI"/>
+              </a:defRPr>
+            </a:pPr>
+            <a:r>
+              <a:t>• Onduleur de Secours (UPS) : Dimensionnement d'un onduleur Line-Interactive de 1000 VA pour maintenir la ventilation active en cas de coupure de courant.</a:t>
+            </a:r>
+          </a:p>
+          <a:p>
+            <a:pPr algn="ctr">
+              <a:spcAft>
+                <a:spcPts val="800"/>
+              </a:spcAft>
+              <a:defRPr sz="1150">
+                <a:solidFill>
+                  <a:srgbClr val="FFFFFF"/>
+                </a:solidFill>
+                <a:latin typeface="Segoe UI"/>
+              </a:defRPr>
+            </a:pPr>
+            <a:r>
+              <a:t>• Technologie Batterie LiFePO4 : Pack de batteries lithium-fer-phosphate (48V / 25Ah ou 12V / 100Ah) supportant 80% de décharge profonde pour assurer 13h d'autonomie électrique.</a:t>
+            </a:r>
+          </a:p>
+          <a:p>
+            <a:pPr algn="ctr">
+              <a:spcAft>
+                <a:spcPts val="800"/>
+              </a:spcAft>
+              <a:defRPr sz="1150">
+                <a:solidFill>
+                  <a:srgbClr val="FFFFFF"/>
+                </a:solidFill>
+                <a:latin typeface="Segoe UI"/>
+              </a:defRPr>
+            </a:pPr>
+            <a:r>
+              <a:t>• Sécurité Maximale : Chimie LiFePO4 hautement stable thermiquement pour une installation sûre en local technique industriel.</a:t>
             </a:r>
           </a:p>
         </p:txBody>
@@ -5967,7 +6915,50 @@
       <p:grpSpPr/>
       <p:sp>
         <p:nvSpPr>
-          <p:cNvPr id="2" name="TextBox 1"/>
+          <p:cNvPr id="2" name="Rectangle 1"/>
+          <p:cNvSpPr/>
+          <p:nvPr/>
+        </p:nvSpPr>
+        <p:spPr>
+          <a:xfrm>
+            <a:off x="137160" y="137160"/>
+            <a:ext cx="11914632" cy="6583680"/>
+          </a:xfrm>
+          <a:prstGeom prst="rect">
+            <a:avLst/>
+          </a:prstGeom>
+          <a:noFill/>
+          <a:ln w="19050">
+            <a:solidFill>
+              <a:srgbClr val="1E293B"/>
+            </a:solidFill>
+          </a:ln>
+        </p:spPr>
+        <p:style>
+          <a:lnRef idx="1">
+            <a:schemeClr val="accent1"/>
+          </a:lnRef>
+          <a:fillRef idx="3">
+            <a:schemeClr val="accent1"/>
+          </a:fillRef>
+          <a:effectRef idx="2">
+            <a:schemeClr val="accent1"/>
+          </a:effectRef>
+          <a:fontRef idx="minor">
+            <a:schemeClr val="lt1"/>
+          </a:fontRef>
+        </p:style>
+        <p:txBody>
+          <a:bodyPr rtlCol="0" anchor="ctr"/>
+          <a:lstStyle/>
+          <a:p>
+            <a:pPr algn="ctr"/>
+          </a:p>
+        </p:txBody>
+      </p:sp>
+      <p:sp>
+        <p:nvSpPr>
+          <p:cNvPr id="3" name="TextBox 2"/>
           <p:cNvSpPr txBox="1"/>
           <p:nvPr/>
         </p:nvSpPr>
@@ -5996,14 +6987,14 @@
               </a:defRPr>
             </a:pPr>
             <a:r>
-              <a:t>BUSINESS MODEL &amp; ROI</a:t>
-            </a:r>
-          </a:p>
-        </p:txBody>
-      </p:sp>
-      <p:sp>
-        <p:nvSpPr>
-          <p:cNvPr id="3" name="TextBox 2"/>
+              <a:t>SCHÉMA UNIFILAIRE INDUSTRIEL</a:t>
+            </a:r>
+          </a:p>
+        </p:txBody>
+      </p:sp>
+      <p:sp>
+        <p:nvSpPr>
+          <p:cNvPr id="4" name="TextBox 3"/>
           <p:cNvSpPr txBox="1"/>
           <p:nvPr/>
         </p:nvSpPr>
@@ -6032,21 +7023,21 @@
               </a:defRPr>
             </a:pPr>
             <a:r>
-              <a:t>Une Solution Rentable aux Amortissements Rapides</a:t>
-            </a:r>
-          </a:p>
-        </p:txBody>
-      </p:sp>
-      <p:sp>
-        <p:nvSpPr>
-          <p:cNvPr id="4" name="Rounded Rectangle 3"/>
+              <a:t>Schéma Électrique de Principe (AutoCAD)</a:t>
+            </a:r>
+          </a:p>
+        </p:txBody>
+      </p:sp>
+      <p:sp>
+        <p:nvSpPr>
+          <p:cNvPr id="5" name="Rounded Rectangle 4"/>
           <p:cNvSpPr/>
           <p:nvPr/>
         </p:nvSpPr>
         <p:spPr>
           <a:xfrm>
-            <a:off x="731520" y="1463040"/>
-            <a:ext cx="3657600" cy="1463040"/>
+            <a:off x="548640" y="1463040"/>
+            <a:ext cx="3657600" cy="4754880"/>
           </a:xfrm>
           <a:prstGeom prst="roundRect">
             <a:avLst/>
@@ -6084,14 +7075,57 @@
       </p:sp>
       <p:sp>
         <p:nvSpPr>
-          <p:cNvPr id="5" name="TextBox 4"/>
+          <p:cNvPr id="6" name="Rounded Rectangle 5"/>
+          <p:cNvSpPr/>
+          <p:nvPr/>
+        </p:nvSpPr>
+        <p:spPr>
+          <a:xfrm>
+            <a:off x="548640" y="1463040"/>
+            <a:ext cx="3657600" cy="73152"/>
+          </a:xfrm>
+          <a:prstGeom prst="roundRect">
+            <a:avLst/>
+          </a:prstGeom>
+          <a:solidFill>
+            <a:srgbClr val="29B6D8"/>
+          </a:solidFill>
+          <a:ln>
+            <a:noFill/>
+          </a:ln>
+        </p:spPr>
+        <p:style>
+          <a:lnRef idx="1">
+            <a:schemeClr val="accent1"/>
+          </a:lnRef>
+          <a:fillRef idx="3">
+            <a:schemeClr val="accent1"/>
+          </a:fillRef>
+          <a:effectRef idx="2">
+            <a:schemeClr val="accent1"/>
+          </a:effectRef>
+          <a:fontRef idx="minor">
+            <a:schemeClr val="lt1"/>
+          </a:fontRef>
+        </p:style>
+        <p:txBody>
+          <a:bodyPr rtlCol="0" anchor="ctr"/>
+          <a:lstStyle/>
+          <a:p>
+            <a:pPr algn="ctr"/>
+          </a:p>
+        </p:txBody>
+      </p:sp>
+      <p:sp>
+        <p:nvSpPr>
+          <p:cNvPr id="7" name="TextBox 6"/>
           <p:cNvSpPr txBox="1"/>
           <p:nvPr/>
         </p:nvSpPr>
         <p:spPr>
           <a:xfrm>
-            <a:off x="914400" y="1645920"/>
-            <a:ext cx="3291840" cy="1097280"/>
+            <a:off x="822960" y="1737360"/>
+            <a:ext cx="3108960" cy="4206240"/>
           </a:xfrm>
           <a:prstGeom prst="rect">
             <a:avLst/>
@@ -6105,45 +7139,351 @@
           <a:lstStyle/>
           <a:p>
             <a:pPr algn="ctr">
-              <a:defRPr sz="4000" b="1">
-                <a:solidFill>
-                  <a:srgbClr val="22C55E"/>
-                </a:solidFill>
-                <a:latin typeface="Segoe UI"/>
-              </a:defRPr>
-            </a:pPr>
-            <a:r>
-              <a:t>&lt; 3 Ans</a:t>
+              <a:spcAft>
+                <a:spcPts val="1000"/>
+              </a:spcAft>
+              <a:defRPr sz="1700" b="1">
+                <a:solidFill>
+                  <a:srgbClr val="29B6D8"/>
+                </a:solidFill>
+                <a:latin typeface="Segoe UI"/>
+              </a:defRPr>
+            </a:pPr>
+            <a:r>
+              <a:t>Câblage Commande &amp; Puissance</a:t>
             </a:r>
           </a:p>
           <a:p>
             <a:pPr algn="ctr">
-              <a:spcBef>
-                <a:spcPts val="400"/>
-              </a:spcBef>
+              <a:spcAft>
+                <a:spcPts val="800"/>
+              </a:spcAft>
+              <a:defRPr sz="1150">
+                <a:solidFill>
+                  <a:srgbClr val="FFFFFF"/>
+                </a:solidFill>
+                <a:latin typeface="Segoe UI"/>
+              </a:defRPr>
+            </a:pPr>
+            <a:r>
+              <a:t>• Circuit de Puissance : Alimentation réseau triphasé 400V, disjoncteur moteur pour le compresseur Scroll, contacteur de ligne KM et disjoncteurs bipolaires pour les ventilateurs (220V).</a:t>
+            </a:r>
+          </a:p>
+          <a:p>
+            <a:pPr algn="ctr">
+              <a:spcAft>
+                <a:spcPts val="800"/>
+              </a:spcAft>
+              <a:defRPr sz="1150">
+                <a:solidFill>
+                  <a:srgbClr val="FFFFFF"/>
+                </a:solidFill>
+                <a:latin typeface="Segoe UI"/>
+              </a:defRPr>
+            </a:pPr>
+            <a:r>
+              <a:t>• Circuit de Commande : Alimentation 24V DC pour l'automate S7-1200, entrées analogiques pour PT100 et sorties digitales relayées pour le pilotage des contacteurs KM, KM1 (évaporateur) et KM2 (condenseur).</a:t>
+            </a:r>
+          </a:p>
+          <a:p>
+            <a:pPr algn="ctr">
+              <a:spcAft>
+                <a:spcPts val="800"/>
+              </a:spcAft>
+              <a:defRPr sz="1150">
+                <a:solidFill>
+                  <a:srgbClr val="FFFFFF"/>
+                </a:solidFill>
+                <a:latin typeface="Segoe UI"/>
+              </a:defRPr>
+            </a:pPr>
+            <a:r>
+              <a:t>• Protection Électrique : Coffret équipé de relais thermiques, de sectionneurs de protection et d'un bouton d'arrêt d'urgence direct.</a:t>
+            </a:r>
+          </a:p>
+          <a:p>
+            <a:pPr algn="ctr">
+              <a:spcAft>
+                <a:spcPts val="800"/>
+              </a:spcAft>
+              <a:defRPr sz="1150">
+                <a:solidFill>
+                  <a:srgbClr val="FFFFFF"/>
+                </a:solidFill>
+                <a:latin typeface="Segoe UI"/>
+              </a:defRPr>
+            </a:pPr>
+            <a:r>
+              <a:t>• Prêt pour Production : Plan unifilaire AutoCAD directement exploitable par les tableautiers et électriciens.</a:t>
+            </a:r>
+          </a:p>
+        </p:txBody>
+      </p:sp>
+      <p:sp>
+        <p:nvSpPr>
+          <p:cNvPr id="8" name="Rounded Rectangle 7"/>
+          <p:cNvSpPr/>
+          <p:nvPr/>
+        </p:nvSpPr>
+        <p:spPr>
+          <a:xfrm>
+            <a:off x="4389120" y="1463040"/>
+            <a:ext cx="7223760" cy="4754880"/>
+          </a:xfrm>
+          <a:prstGeom prst="roundRect">
+            <a:avLst/>
+          </a:prstGeom>
+          <a:solidFill>
+            <a:srgbClr val="101C30"/>
+          </a:solidFill>
+          <a:ln w="19050">
+            <a:solidFill>
+              <a:srgbClr val="29B6D8"/>
+            </a:solidFill>
+          </a:ln>
+        </p:spPr>
+        <p:style>
+          <a:lnRef idx="1">
+            <a:schemeClr val="accent1"/>
+          </a:lnRef>
+          <a:fillRef idx="3">
+            <a:schemeClr val="accent1"/>
+          </a:fillRef>
+          <a:effectRef idx="2">
+            <a:schemeClr val="accent1"/>
+          </a:effectRef>
+          <a:fontRef idx="minor">
+            <a:schemeClr val="lt1"/>
+          </a:fontRef>
+        </p:style>
+        <p:txBody>
+          <a:bodyPr rtlCol="0" anchor="ctr"/>
+          <a:lstStyle/>
+          <a:p>
+            <a:pPr algn="ctr"/>
+          </a:p>
+        </p:txBody>
+      </p:sp>
+      <p:sp>
+        <p:nvSpPr>
+          <p:cNvPr id="9" name="Rectangle 8"/>
+          <p:cNvSpPr/>
+          <p:nvPr/>
+        </p:nvSpPr>
+        <p:spPr>
+          <a:xfrm>
+            <a:off x="4434840" y="1600200"/>
+            <a:ext cx="7132320" cy="4480560"/>
+          </a:xfrm>
+          <a:prstGeom prst="rect">
+            <a:avLst/>
+          </a:prstGeom>
+          <a:solidFill>
+            <a:srgbClr val="101C30"/>
+          </a:solidFill>
+          <a:ln w="19050">
+            <a:solidFill>
+              <a:srgbClr val="29B6D8"/>
+            </a:solidFill>
+          </a:ln>
+        </p:spPr>
+        <p:style>
+          <a:lnRef idx="1">
+            <a:schemeClr val="accent1"/>
+          </a:lnRef>
+          <a:fillRef idx="3">
+            <a:schemeClr val="accent1"/>
+          </a:fillRef>
+          <a:effectRef idx="2">
+            <a:schemeClr val="accent1"/>
+          </a:effectRef>
+          <a:fontRef idx="minor">
+            <a:schemeClr val="lt1"/>
+          </a:fontRef>
+        </p:style>
+        <p:txBody>
+          <a:bodyPr rtlCol="0" anchor="ctr"/>
+          <a:lstStyle/>
+          <a:p>
+            <a:pPr algn="ctr"/>
+          </a:p>
+        </p:txBody>
+      </p:sp>
+      <p:pic>
+        <p:nvPicPr>
+          <p:cNvPr id="10" name="Picture 9" descr="autocad_schema_page_1.png"/>
+          <p:cNvPicPr>
+            <a:picLocks noChangeAspect="1"/>
+          </p:cNvPicPr>
+          <p:nvPr/>
+        </p:nvPicPr>
+        <p:blipFill>
+          <a:blip r:embed="rId2"/>
+          <a:stretch>
+            <a:fillRect/>
+          </a:stretch>
+        </p:blipFill>
+        <p:spPr>
+          <a:xfrm>
+            <a:off x="4480560" y="1645920"/>
+            <a:ext cx="7040880" cy="4389120"/>
+          </a:xfrm>
+          <a:prstGeom prst="rect">
+            <a:avLst/>
+          </a:prstGeom>
+        </p:spPr>
+      </p:pic>
+    </p:spTree>
+  </p:cSld>
+  <p:clrMapOvr>
+    <a:masterClrMapping/>
+  </p:clrMapOvr>
+</p:sld>
+</file>
+
+<file path=ppt/slides/slide8.xml><?xml version="1.0" encoding="utf-8"?>
+<p:sld xmlns:a="http://schemas.openxmlformats.org/drawingml/2006/main" xmlns:p="http://schemas.openxmlformats.org/presentationml/2006/main" xmlns:r="http://schemas.openxmlformats.org/officeDocument/2006/relationships">
+  <p:cSld>
+    <p:bg>
+      <p:bgPr>
+        <a:solidFill>
+          <a:srgbClr val="071321"/>
+        </a:solidFill>
+        <a:effectLst/>
+      </p:bgPr>
+    </p:bg>
+    <p:spTree>
+      <p:nvGrpSpPr>
+        <p:cNvPr id="1" name=""/>
+        <p:cNvGrpSpPr/>
+        <p:nvPr/>
+      </p:nvGrpSpPr>
+      <p:grpSpPr/>
+      <p:sp>
+        <p:nvSpPr>
+          <p:cNvPr id="2" name="Rectangle 1"/>
+          <p:cNvSpPr/>
+          <p:nvPr/>
+        </p:nvSpPr>
+        <p:spPr>
+          <a:xfrm>
+            <a:off x="137160" y="137160"/>
+            <a:ext cx="11914632" cy="6583680"/>
+          </a:xfrm>
+          <a:prstGeom prst="rect">
+            <a:avLst/>
+          </a:prstGeom>
+          <a:noFill/>
+          <a:ln w="19050">
+            <a:solidFill>
+              <a:srgbClr val="1E293B"/>
+            </a:solidFill>
+          </a:ln>
+        </p:spPr>
+        <p:style>
+          <a:lnRef idx="1">
+            <a:schemeClr val="accent1"/>
+          </a:lnRef>
+          <a:fillRef idx="3">
+            <a:schemeClr val="accent1"/>
+          </a:fillRef>
+          <a:effectRef idx="2">
+            <a:schemeClr val="accent1"/>
+          </a:effectRef>
+          <a:fontRef idx="minor">
+            <a:schemeClr val="lt1"/>
+          </a:fontRef>
+        </p:style>
+        <p:txBody>
+          <a:bodyPr rtlCol="0" anchor="ctr"/>
+          <a:lstStyle/>
+          <a:p>
+            <a:pPr algn="ctr"/>
+          </a:p>
+        </p:txBody>
+      </p:sp>
+      <p:sp>
+        <p:nvSpPr>
+          <p:cNvPr id="3" name="TextBox 2"/>
+          <p:cNvSpPr txBox="1"/>
+          <p:nvPr/>
+        </p:nvSpPr>
+        <p:spPr>
+          <a:xfrm>
+            <a:off x="731520" y="365760"/>
+            <a:ext cx="10698480" cy="274320"/>
+          </a:xfrm>
+          <a:prstGeom prst="rect">
+            <a:avLst/>
+          </a:prstGeom>
+          <a:noFill/>
+        </p:spPr>
+        <p:txBody>
+          <a:bodyPr wrap="square" lIns="0" tIns="0" rIns="0" bIns="0">
+            <a:spAutoFit/>
+          </a:bodyPr>
+          <a:lstStyle/>
+          <a:p>
+            <a:pPr>
               <a:defRPr sz="1000" b="1">
                 <a:solidFill>
+                  <a:srgbClr val="29B6D8"/>
+                </a:solidFill>
+                <a:latin typeface="Segoe UI"/>
+              </a:defRPr>
+            </a:pPr>
+            <a:r>
+              <a:t>LOGIQUE DE COMMANDE / GRAFCET</a:t>
+            </a:r>
+          </a:p>
+        </p:txBody>
+      </p:sp>
+      <p:sp>
+        <p:nvSpPr>
+          <p:cNvPr id="4" name="TextBox 3"/>
+          <p:cNvSpPr txBox="1"/>
+          <p:nvPr/>
+        </p:nvSpPr>
+        <p:spPr>
+          <a:xfrm>
+            <a:off x="731520" y="594360"/>
+            <a:ext cx="10698480" cy="731520"/>
+          </a:xfrm>
+          <a:prstGeom prst="rect">
+            <a:avLst/>
+          </a:prstGeom>
+          <a:noFill/>
+        </p:spPr>
+        <p:txBody>
+          <a:bodyPr wrap="square" lIns="0" tIns="0" rIns="0" bIns="0">
+            <a:spAutoFit/>
+          </a:bodyPr>
+          <a:lstStyle/>
+          <a:p>
+            <a:pPr>
+              <a:defRPr sz="2800" b="1">
+                <a:solidFill>
                   <a:srgbClr val="FFFFFF"/>
                 </a:solidFill>
                 <a:latin typeface="Segoe UI"/>
               </a:defRPr>
             </a:pPr>
             <a:r>
-              <a:t>Temps de Retour Simple (Payback)</a:t>
-            </a:r>
-          </a:p>
-        </p:txBody>
-      </p:sp>
-      <p:sp>
-        <p:nvSpPr>
-          <p:cNvPr id="6" name="Rounded Rectangle 5"/>
+              <a:t>Logique de Décision Smart-Grid (Grafcet Final)</a:t>
+            </a:r>
+          </a:p>
+        </p:txBody>
+      </p:sp>
+      <p:sp>
+        <p:nvSpPr>
+          <p:cNvPr id="5" name="Rounded Rectangle 4"/>
           <p:cNvSpPr/>
           <p:nvPr/>
         </p:nvSpPr>
         <p:spPr>
           <a:xfrm>
-            <a:off x="731520" y="3108960"/>
-            <a:ext cx="3657600" cy="1463040"/>
+            <a:off x="548640" y="1463040"/>
+            <a:ext cx="3657600" cy="4754880"/>
           </a:xfrm>
           <a:prstGeom prst="roundRect">
             <a:avLst/>
@@ -6181,14 +7521,57 @@
       </p:sp>
       <p:sp>
         <p:nvSpPr>
+          <p:cNvPr id="6" name="Rounded Rectangle 5"/>
+          <p:cNvSpPr/>
+          <p:nvPr/>
+        </p:nvSpPr>
+        <p:spPr>
+          <a:xfrm>
+            <a:off x="548640" y="1463040"/>
+            <a:ext cx="3657600" cy="73152"/>
+          </a:xfrm>
+          <a:prstGeom prst="roundRect">
+            <a:avLst/>
+          </a:prstGeom>
+          <a:solidFill>
+            <a:srgbClr val="29B6D8"/>
+          </a:solidFill>
+          <a:ln>
+            <a:noFill/>
+          </a:ln>
+        </p:spPr>
+        <p:style>
+          <a:lnRef idx="1">
+            <a:schemeClr val="accent1"/>
+          </a:lnRef>
+          <a:fillRef idx="3">
+            <a:schemeClr val="accent1"/>
+          </a:fillRef>
+          <a:effectRef idx="2">
+            <a:schemeClr val="accent1"/>
+          </a:effectRef>
+          <a:fontRef idx="minor">
+            <a:schemeClr val="lt1"/>
+          </a:fontRef>
+        </p:style>
+        <p:txBody>
+          <a:bodyPr rtlCol="0" anchor="ctr"/>
+          <a:lstStyle/>
+          <a:p>
+            <a:pPr algn="ctr"/>
+          </a:p>
+        </p:txBody>
+      </p:sp>
+      <p:sp>
+        <p:nvSpPr>
           <p:cNvPr id="7" name="TextBox 6"/>
           <p:cNvSpPr txBox="1"/>
           <p:nvPr/>
         </p:nvSpPr>
         <p:spPr>
           <a:xfrm>
-            <a:off x="914400" y="3291840"/>
-            <a:ext cx="3291840" cy="1097280"/>
+            <a:off x="822960" y="1737360"/>
+            <a:ext cx="3108960" cy="4206240"/>
           </a:xfrm>
           <a:prstGeom prst="rect">
             <a:avLst/>
@@ -6202,23 +7585,26 @@
           <a:lstStyle/>
           <a:p>
             <a:pPr algn="ctr">
-              <a:defRPr sz="4000" b="1">
-                <a:solidFill>
-                  <a:srgbClr val="22C55E"/>
-                </a:solidFill>
-                <a:latin typeface="Segoe UI"/>
-              </a:defRPr>
-            </a:pPr>
-            <a:r>
-              <a:t>&gt; 25 %</a:t>
+              <a:spcAft>
+                <a:spcPts val="1000"/>
+              </a:spcAft>
+              <a:defRPr sz="1700" b="1">
+                <a:solidFill>
+                  <a:srgbClr val="29B6D8"/>
+                </a:solidFill>
+                <a:latin typeface="Segoe UI"/>
+              </a:defRPr>
+            </a:pPr>
+            <a:r>
+              <a:t>Algorithme à 4 États Opérationnels</a:t>
             </a:r>
           </a:p>
           <a:p>
             <a:pPr algn="ctr">
-              <a:spcBef>
-                <a:spcPts val="400"/>
-              </a:spcBef>
-              <a:defRPr sz="1000" b="1">
+              <a:spcAft>
+                <a:spcPts val="800"/>
+              </a:spcAft>
+              <a:defRPr sz="1150">
                 <a:solidFill>
                   <a:srgbClr val="FFFFFF"/>
                 </a:solidFill>
@@ -6226,7 +7612,71 @@
               </a:defRPr>
             </a:pPr>
             <a:r>
-              <a:t>Taux de Rentabilité Interne (TRI)</a:t>
+              <a:t>• Étape X0 (Veille) : Compresseur et ventilateur condenseur éteints (KM=0, KM2=0). Ventilateur évaporateur actif en continu (KM1=1) pour diffuser le froid du MCP.</a:t>
+            </a:r>
+          </a:p>
+          <a:p>
+            <a:pPr algn="ctr">
+              <a:spcAft>
+                <a:spcPts val="800"/>
+              </a:spcAft>
+              <a:defRPr sz="1150">
+                <a:solidFill>
+                  <a:srgbClr val="FFFFFF"/>
+                </a:solidFill>
+                <a:latin typeface="Segoe UI"/>
+              </a:defRPr>
+            </a:pPr>
+            <a:r>
+              <a:t>• Étape X1 (Charge Nocturne) : Compresseur, condenseur et évaporateur actifs (KM=1, KM1=1, KM2=1) pour solidifier le MCP sous tarif Heures Creuses.</a:t>
+            </a:r>
+          </a:p>
+          <a:p>
+            <a:pPr algn="ctr">
+              <a:spcAft>
+                <a:spcPts val="800"/>
+              </a:spcAft>
+              <a:defRPr sz="1150">
+                <a:solidFill>
+                  <a:srgbClr val="FFFFFF"/>
+                </a:solidFill>
+                <a:latin typeface="Segoe UI"/>
+              </a:defRPr>
+            </a:pPr>
+            <a:r>
+              <a:t>• Étape X2 (Délestage Réseau) : Coupure secteur détectée. Compresseur et condenseur OFF. Soufflerie secourue par l'onduleur UPS.</a:t>
+            </a:r>
+          </a:p>
+          <a:p>
+            <a:pPr algn="ctr">
+              <a:spcAft>
+                <a:spcPts val="800"/>
+              </a:spcAft>
+              <a:defRPr sz="1150">
+                <a:solidFill>
+                  <a:srgbClr val="FFFFFF"/>
+                </a:solidFill>
+                <a:latin typeface="Segoe UI"/>
+              </a:defRPr>
+            </a:pPr>
+            <a:r>
+              <a:t>• Étape X3 (Effacement Heures Pleines) : Compresseur éteint (KM=0) durant les tarifs de pointe. Restitution froide exclusive par fusion du MCP.</a:t>
+            </a:r>
+          </a:p>
+          <a:p>
+            <a:pPr algn="ctr">
+              <a:spcAft>
+                <a:spcPts val="800"/>
+              </a:spcAft>
+              <a:defRPr sz="1150">
+                <a:solidFill>
+                  <a:srgbClr val="FFFFFF"/>
+                </a:solidFill>
+                <a:latin typeface="Segoe UI"/>
+              </a:defRPr>
+            </a:pPr>
+            <a:r>
+              <a:t>• Priorité Réseau (T2) : La perte secteur interrompt instantanément n'importe quelle phase en cours pour protéger les équipements.</a:t>
             </a:r>
           </a:p>
         </p:txBody>
@@ -6239,7 +7689,262 @@
         </p:nvSpPr>
         <p:spPr>
           <a:xfrm>
-            <a:off x="731520" y="4754880"/>
+            <a:off x="4389120" y="1463040"/>
+            <a:ext cx="7223760" cy="4754880"/>
+          </a:xfrm>
+          <a:prstGeom prst="roundRect">
+            <a:avLst/>
+          </a:prstGeom>
+          <a:solidFill>
+            <a:srgbClr val="101C30"/>
+          </a:solidFill>
+          <a:ln w="19050">
+            <a:solidFill>
+              <a:srgbClr val="29B6D8"/>
+            </a:solidFill>
+          </a:ln>
+        </p:spPr>
+        <p:style>
+          <a:lnRef idx="1">
+            <a:schemeClr val="accent1"/>
+          </a:lnRef>
+          <a:fillRef idx="3">
+            <a:schemeClr val="accent1"/>
+          </a:fillRef>
+          <a:effectRef idx="2">
+            <a:schemeClr val="accent1"/>
+          </a:effectRef>
+          <a:fontRef idx="minor">
+            <a:schemeClr val="lt1"/>
+          </a:fontRef>
+        </p:style>
+        <p:txBody>
+          <a:bodyPr rtlCol="0" anchor="ctr"/>
+          <a:lstStyle/>
+          <a:p>
+            <a:pPr algn="ctr"/>
+          </a:p>
+        </p:txBody>
+      </p:sp>
+      <p:sp>
+        <p:nvSpPr>
+          <p:cNvPr id="9" name="Rectangle 8"/>
+          <p:cNvSpPr/>
+          <p:nvPr/>
+        </p:nvSpPr>
+        <p:spPr>
+          <a:xfrm>
+            <a:off x="4434840" y="1600200"/>
+            <a:ext cx="7132320" cy="4480560"/>
+          </a:xfrm>
+          <a:prstGeom prst="rect">
+            <a:avLst/>
+          </a:prstGeom>
+          <a:solidFill>
+            <a:srgbClr val="101C30"/>
+          </a:solidFill>
+          <a:ln w="19050">
+            <a:solidFill>
+              <a:srgbClr val="29B6D8"/>
+            </a:solidFill>
+          </a:ln>
+        </p:spPr>
+        <p:style>
+          <a:lnRef idx="1">
+            <a:schemeClr val="accent1"/>
+          </a:lnRef>
+          <a:fillRef idx="3">
+            <a:schemeClr val="accent1"/>
+          </a:fillRef>
+          <a:effectRef idx="2">
+            <a:schemeClr val="accent1"/>
+          </a:effectRef>
+          <a:fontRef idx="minor">
+            <a:schemeClr val="lt1"/>
+          </a:fontRef>
+        </p:style>
+        <p:txBody>
+          <a:bodyPr rtlCol="0" anchor="ctr"/>
+          <a:lstStyle/>
+          <a:p>
+            <a:pPr algn="ctr"/>
+          </a:p>
+        </p:txBody>
+      </p:sp>
+      <p:pic>
+        <p:nvPicPr>
+          <p:cNvPr id="10" name="Picture 9" descr="grafcet_mcp_final.png"/>
+          <p:cNvPicPr>
+            <a:picLocks noChangeAspect="1"/>
+          </p:cNvPicPr>
+          <p:nvPr/>
+        </p:nvPicPr>
+        <p:blipFill>
+          <a:blip r:embed="rId2"/>
+          <a:stretch>
+            <a:fillRect/>
+          </a:stretch>
+        </p:blipFill>
+        <p:spPr>
+          <a:xfrm>
+            <a:off x="4480560" y="1645920"/>
+            <a:ext cx="7040880" cy="4389120"/>
+          </a:xfrm>
+          <a:prstGeom prst="rect">
+            <a:avLst/>
+          </a:prstGeom>
+        </p:spPr>
+      </p:pic>
+    </p:spTree>
+  </p:cSld>
+  <p:clrMapOvr>
+    <a:masterClrMapping/>
+  </p:clrMapOvr>
+</p:sld>
+</file>
+
+<file path=ppt/slides/slide9.xml><?xml version="1.0" encoding="utf-8"?>
+<p:sld xmlns:a="http://schemas.openxmlformats.org/drawingml/2006/main" xmlns:p="http://schemas.openxmlformats.org/presentationml/2006/main" xmlns:r="http://schemas.openxmlformats.org/officeDocument/2006/relationships">
+  <p:cSld>
+    <p:bg>
+      <p:bgPr>
+        <a:solidFill>
+          <a:srgbClr val="071321"/>
+        </a:solidFill>
+        <a:effectLst/>
+      </p:bgPr>
+    </p:bg>
+    <p:spTree>
+      <p:nvGrpSpPr>
+        <p:cNvPr id="1" name=""/>
+        <p:cNvGrpSpPr/>
+        <p:nvPr/>
+      </p:nvGrpSpPr>
+      <p:grpSpPr/>
+      <p:sp>
+        <p:nvSpPr>
+          <p:cNvPr id="2" name="Rectangle 1"/>
+          <p:cNvSpPr/>
+          <p:nvPr/>
+        </p:nvSpPr>
+        <p:spPr>
+          <a:xfrm>
+            <a:off x="137160" y="137160"/>
+            <a:ext cx="11914632" cy="6583680"/>
+          </a:xfrm>
+          <a:prstGeom prst="rect">
+            <a:avLst/>
+          </a:prstGeom>
+          <a:noFill/>
+          <a:ln w="19050">
+            <a:solidFill>
+              <a:srgbClr val="1E293B"/>
+            </a:solidFill>
+          </a:ln>
+        </p:spPr>
+        <p:style>
+          <a:lnRef idx="1">
+            <a:schemeClr val="accent1"/>
+          </a:lnRef>
+          <a:fillRef idx="3">
+            <a:schemeClr val="accent1"/>
+          </a:fillRef>
+          <a:effectRef idx="2">
+            <a:schemeClr val="accent1"/>
+          </a:effectRef>
+          <a:fontRef idx="minor">
+            <a:schemeClr val="lt1"/>
+          </a:fontRef>
+        </p:style>
+        <p:txBody>
+          <a:bodyPr rtlCol="0" anchor="ctr"/>
+          <a:lstStyle/>
+          <a:p>
+            <a:pPr algn="ctr"/>
+          </a:p>
+        </p:txBody>
+      </p:sp>
+      <p:sp>
+        <p:nvSpPr>
+          <p:cNvPr id="3" name="TextBox 2"/>
+          <p:cNvSpPr txBox="1"/>
+          <p:nvPr/>
+        </p:nvSpPr>
+        <p:spPr>
+          <a:xfrm>
+            <a:off x="731520" y="365760"/>
+            <a:ext cx="10698480" cy="274320"/>
+          </a:xfrm>
+          <a:prstGeom prst="rect">
+            <a:avLst/>
+          </a:prstGeom>
+          <a:noFill/>
+        </p:spPr>
+        <p:txBody>
+          <a:bodyPr wrap="square" lIns="0" tIns="0" rIns="0" bIns="0">
+            <a:spAutoFit/>
+          </a:bodyPr>
+          <a:lstStyle/>
+          <a:p>
+            <a:pPr>
+              <a:defRPr sz="1000" b="1">
+                <a:solidFill>
+                  <a:srgbClr val="29B6D8"/>
+                </a:solidFill>
+                <a:latin typeface="Segoe UI"/>
+              </a:defRPr>
+            </a:pPr>
+            <a:r>
+              <a:t>BUSINESS MODEL &amp; ROI</a:t>
+            </a:r>
+          </a:p>
+        </p:txBody>
+      </p:sp>
+      <p:sp>
+        <p:nvSpPr>
+          <p:cNvPr id="4" name="TextBox 3"/>
+          <p:cNvSpPr txBox="1"/>
+          <p:nvPr/>
+        </p:nvSpPr>
+        <p:spPr>
+          <a:xfrm>
+            <a:off x="731520" y="594360"/>
+            <a:ext cx="10698480" cy="731520"/>
+          </a:xfrm>
+          <a:prstGeom prst="rect">
+            <a:avLst/>
+          </a:prstGeom>
+          <a:noFill/>
+        </p:spPr>
+        <p:txBody>
+          <a:bodyPr wrap="square" lIns="0" tIns="0" rIns="0" bIns="0">
+            <a:spAutoFit/>
+          </a:bodyPr>
+          <a:lstStyle/>
+          <a:p>
+            <a:pPr>
+              <a:defRPr sz="2800" b="1">
+                <a:solidFill>
+                  <a:srgbClr val="FFFFFF"/>
+                </a:solidFill>
+                <a:latin typeface="Segoe UI"/>
+              </a:defRPr>
+            </a:pPr>
+            <a:r>
+              <a:t>Une Solution Rentable aux Amortissements Rapides</a:t>
+            </a:r>
+          </a:p>
+        </p:txBody>
+      </p:sp>
+      <p:sp>
+        <p:nvSpPr>
+          <p:cNvPr id="5" name="Rounded Rectangle 4"/>
+          <p:cNvSpPr/>
+          <p:nvPr/>
+        </p:nvSpPr>
+        <p:spPr>
+          <a:xfrm>
+            <a:off x="731520" y="1463040"/>
             <a:ext cx="3657600" cy="1463040"/>
           </a:xfrm>
           <a:prstGeom prst="roundRect">
@@ -6278,13 +7983,56 @@
       </p:sp>
       <p:sp>
         <p:nvSpPr>
-          <p:cNvPr id="9" name="TextBox 8"/>
+          <p:cNvPr id="6" name="Rounded Rectangle 5"/>
+          <p:cNvSpPr/>
+          <p:nvPr/>
+        </p:nvSpPr>
+        <p:spPr>
+          <a:xfrm>
+            <a:off x="731520" y="1463040"/>
+            <a:ext cx="3657600" cy="73152"/>
+          </a:xfrm>
+          <a:prstGeom prst="roundRect">
+            <a:avLst/>
+          </a:prstGeom>
+          <a:solidFill>
+            <a:srgbClr val="22C55E"/>
+          </a:solidFill>
+          <a:ln>
+            <a:noFill/>
+          </a:ln>
+        </p:spPr>
+        <p:style>
+          <a:lnRef idx="1">
+            <a:schemeClr val="accent1"/>
+          </a:lnRef>
+          <a:fillRef idx="3">
+            <a:schemeClr val="accent1"/>
+          </a:fillRef>
+          <a:effectRef idx="2">
+            <a:schemeClr val="accent1"/>
+          </a:effectRef>
+          <a:fontRef idx="minor">
+            <a:schemeClr val="lt1"/>
+          </a:fontRef>
+        </p:style>
+        <p:txBody>
+          <a:bodyPr rtlCol="0" anchor="ctr"/>
+          <a:lstStyle/>
+          <a:p>
+            <a:pPr algn="ctr"/>
+          </a:p>
+        </p:txBody>
+      </p:sp>
+      <p:sp>
+        <p:nvSpPr>
+          <p:cNvPr id="7" name="TextBox 6"/>
           <p:cNvSpPr txBox="1"/>
           <p:nvPr/>
         </p:nvSpPr>
         <p:spPr>
           <a:xfrm>
-            <a:off x="914400" y="4937760"/>
+            <a:off x="914400" y="1645920"/>
             <a:ext cx="3291840" cy="1097280"/>
           </a:xfrm>
           <a:prstGeom prst="rect">
@@ -6307,7 +8055,7 @@
               </a:defRPr>
             </a:pPr>
             <a:r>
-              <a:t>VAN &gt; 0</a:t>
+              <a:t>&lt; 3 Ans</a:t>
             </a:r>
           </a:p>
           <a:p>
@@ -6323,21 +8071,21 @@
               </a:defRPr>
             </a:pPr>
             <a:r>
-              <a:t>Valeur Actuelle Nette (Projet Rentable)</a:t>
-            </a:r>
-          </a:p>
-        </p:txBody>
-      </p:sp>
-      <p:sp>
-        <p:nvSpPr>
-          <p:cNvPr id="10" name="Rounded Rectangle 9"/>
+              <a:t>Temps de Retour Simple (Payback)</a:t>
+            </a:r>
+          </a:p>
+        </p:txBody>
+      </p:sp>
+      <p:sp>
+        <p:nvSpPr>
+          <p:cNvPr id="8" name="Rounded Rectangle 7"/>
           <p:cNvSpPr/>
           <p:nvPr/>
         </p:nvSpPr>
         <p:spPr>
           <a:xfrm>
-            <a:off x="4754880" y="1463040"/>
-            <a:ext cx="6675120" cy="4754880"/>
+            <a:off x="731520" y="3108960"/>
+            <a:ext cx="3657600" cy="1463040"/>
           </a:xfrm>
           <a:prstGeom prst="roundRect">
             <a:avLst/>
@@ -6373,9 +8121,289 @@
           </a:p>
         </p:txBody>
       </p:sp>
+      <p:sp>
+        <p:nvSpPr>
+          <p:cNvPr id="9" name="Rounded Rectangle 8"/>
+          <p:cNvSpPr/>
+          <p:nvPr/>
+        </p:nvSpPr>
+        <p:spPr>
+          <a:xfrm>
+            <a:off x="731520" y="3108960"/>
+            <a:ext cx="3657600" cy="73152"/>
+          </a:xfrm>
+          <a:prstGeom prst="roundRect">
+            <a:avLst/>
+          </a:prstGeom>
+          <a:solidFill>
+            <a:srgbClr val="22C55E"/>
+          </a:solidFill>
+          <a:ln>
+            <a:noFill/>
+          </a:ln>
+        </p:spPr>
+        <p:style>
+          <a:lnRef idx="1">
+            <a:schemeClr val="accent1"/>
+          </a:lnRef>
+          <a:fillRef idx="3">
+            <a:schemeClr val="accent1"/>
+          </a:fillRef>
+          <a:effectRef idx="2">
+            <a:schemeClr val="accent1"/>
+          </a:effectRef>
+          <a:fontRef idx="minor">
+            <a:schemeClr val="lt1"/>
+          </a:fontRef>
+        </p:style>
+        <p:txBody>
+          <a:bodyPr rtlCol="0" anchor="ctr"/>
+          <a:lstStyle/>
+          <a:p>
+            <a:pPr algn="ctr"/>
+          </a:p>
+        </p:txBody>
+      </p:sp>
+      <p:sp>
+        <p:nvSpPr>
+          <p:cNvPr id="10" name="TextBox 9"/>
+          <p:cNvSpPr txBox="1"/>
+          <p:nvPr/>
+        </p:nvSpPr>
+        <p:spPr>
+          <a:xfrm>
+            <a:off x="914400" y="3291840"/>
+            <a:ext cx="3291840" cy="1097280"/>
+          </a:xfrm>
+          <a:prstGeom prst="rect">
+            <a:avLst/>
+          </a:prstGeom>
+          <a:noFill/>
+        </p:spPr>
+        <p:txBody>
+          <a:bodyPr wrap="square" lIns="0" rIns="0" tIns="0" bIns="0" anchor="ctr">
+            <a:spAutoFit/>
+          </a:bodyPr>
+          <a:lstStyle/>
+          <a:p>
+            <a:pPr algn="ctr">
+              <a:defRPr sz="4000" b="1">
+                <a:solidFill>
+                  <a:srgbClr val="22C55E"/>
+                </a:solidFill>
+                <a:latin typeface="Segoe UI"/>
+              </a:defRPr>
+            </a:pPr>
+            <a:r>
+              <a:t>&gt; 25 %</a:t>
+            </a:r>
+          </a:p>
+          <a:p>
+            <a:pPr algn="ctr">
+              <a:spcBef>
+                <a:spcPts val="400"/>
+              </a:spcBef>
+              <a:defRPr sz="1000" b="1">
+                <a:solidFill>
+                  <a:srgbClr val="FFFFFF"/>
+                </a:solidFill>
+                <a:latin typeface="Segoe UI"/>
+              </a:defRPr>
+            </a:pPr>
+            <a:r>
+              <a:t>Taux de Rentabilité Interne (TRI)</a:t>
+            </a:r>
+          </a:p>
+        </p:txBody>
+      </p:sp>
+      <p:sp>
+        <p:nvSpPr>
+          <p:cNvPr id="11" name="Rounded Rectangle 10"/>
+          <p:cNvSpPr/>
+          <p:nvPr/>
+        </p:nvSpPr>
+        <p:spPr>
+          <a:xfrm>
+            <a:off x="731520" y="4754880"/>
+            <a:ext cx="3657600" cy="1463040"/>
+          </a:xfrm>
+          <a:prstGeom prst="roundRect">
+            <a:avLst/>
+          </a:prstGeom>
+          <a:solidFill>
+            <a:srgbClr val="101C30"/>
+          </a:solidFill>
+          <a:ln w="19050">
+            <a:solidFill>
+              <a:srgbClr val="1B2C49"/>
+            </a:solidFill>
+          </a:ln>
+        </p:spPr>
+        <p:style>
+          <a:lnRef idx="1">
+            <a:schemeClr val="accent1"/>
+          </a:lnRef>
+          <a:fillRef idx="3">
+            <a:schemeClr val="accent1"/>
+          </a:fillRef>
+          <a:effectRef idx="2">
+            <a:schemeClr val="accent1"/>
+          </a:effectRef>
+          <a:fontRef idx="minor">
+            <a:schemeClr val="lt1"/>
+          </a:fontRef>
+        </p:style>
+        <p:txBody>
+          <a:bodyPr rtlCol="0" anchor="ctr"/>
+          <a:lstStyle/>
+          <a:p>
+            <a:pPr algn="ctr"/>
+          </a:p>
+        </p:txBody>
+      </p:sp>
+      <p:sp>
+        <p:nvSpPr>
+          <p:cNvPr id="12" name="Rounded Rectangle 11"/>
+          <p:cNvSpPr/>
+          <p:nvPr/>
+        </p:nvSpPr>
+        <p:spPr>
+          <a:xfrm>
+            <a:off x="731520" y="4754880"/>
+            <a:ext cx="3657600" cy="73152"/>
+          </a:xfrm>
+          <a:prstGeom prst="roundRect">
+            <a:avLst/>
+          </a:prstGeom>
+          <a:solidFill>
+            <a:srgbClr val="22C55E"/>
+          </a:solidFill>
+          <a:ln>
+            <a:noFill/>
+          </a:ln>
+        </p:spPr>
+        <p:style>
+          <a:lnRef idx="1">
+            <a:schemeClr val="accent1"/>
+          </a:lnRef>
+          <a:fillRef idx="3">
+            <a:schemeClr val="accent1"/>
+          </a:fillRef>
+          <a:effectRef idx="2">
+            <a:schemeClr val="accent1"/>
+          </a:effectRef>
+          <a:fontRef idx="minor">
+            <a:schemeClr val="lt1"/>
+          </a:fontRef>
+        </p:style>
+        <p:txBody>
+          <a:bodyPr rtlCol="0" anchor="ctr"/>
+          <a:lstStyle/>
+          <a:p>
+            <a:pPr algn="ctr"/>
+          </a:p>
+        </p:txBody>
+      </p:sp>
+      <p:sp>
+        <p:nvSpPr>
+          <p:cNvPr id="13" name="TextBox 12"/>
+          <p:cNvSpPr txBox="1"/>
+          <p:nvPr/>
+        </p:nvSpPr>
+        <p:spPr>
+          <a:xfrm>
+            <a:off x="914400" y="4937760"/>
+            <a:ext cx="3291840" cy="1097280"/>
+          </a:xfrm>
+          <a:prstGeom prst="rect">
+            <a:avLst/>
+          </a:prstGeom>
+          <a:noFill/>
+        </p:spPr>
+        <p:txBody>
+          <a:bodyPr wrap="square" lIns="0" rIns="0" tIns="0" bIns="0" anchor="ctr">
+            <a:spAutoFit/>
+          </a:bodyPr>
+          <a:lstStyle/>
+          <a:p>
+            <a:pPr algn="ctr">
+              <a:defRPr sz="4000" b="1">
+                <a:solidFill>
+                  <a:srgbClr val="22C55E"/>
+                </a:solidFill>
+                <a:latin typeface="Segoe UI"/>
+              </a:defRPr>
+            </a:pPr>
+            <a:r>
+              <a:t>VAN &gt; 0</a:t>
+            </a:r>
+          </a:p>
+          <a:p>
+            <a:pPr algn="ctr">
+              <a:spcBef>
+                <a:spcPts val="400"/>
+              </a:spcBef>
+              <a:defRPr sz="1000" b="1">
+                <a:solidFill>
+                  <a:srgbClr val="FFFFFF"/>
+                </a:solidFill>
+                <a:latin typeface="Segoe UI"/>
+              </a:defRPr>
+            </a:pPr>
+            <a:r>
+              <a:t>Valeur Actuelle Nette (Projet Rentable)</a:t>
+            </a:r>
+          </a:p>
+        </p:txBody>
+      </p:sp>
+      <p:sp>
+        <p:nvSpPr>
+          <p:cNvPr id="14" name="Rounded Rectangle 13"/>
+          <p:cNvSpPr/>
+          <p:nvPr/>
+        </p:nvSpPr>
+        <p:spPr>
+          <a:xfrm>
+            <a:off x="4754880" y="1463040"/>
+            <a:ext cx="6675120" cy="4754880"/>
+          </a:xfrm>
+          <a:prstGeom prst="roundRect">
+            <a:avLst/>
+          </a:prstGeom>
+          <a:solidFill>
+            <a:srgbClr val="101C30"/>
+          </a:solidFill>
+          <a:ln w="19050">
+            <a:solidFill>
+              <a:srgbClr val="1B2C49"/>
+            </a:solidFill>
+          </a:ln>
+        </p:spPr>
+        <p:style>
+          <a:lnRef idx="1">
+            <a:schemeClr val="accent1"/>
+          </a:lnRef>
+          <a:fillRef idx="3">
+            <a:schemeClr val="accent1"/>
+          </a:fillRef>
+          <a:effectRef idx="2">
+            <a:schemeClr val="accent1"/>
+          </a:effectRef>
+          <a:fontRef idx="minor">
+            <a:schemeClr val="lt1"/>
+          </a:fontRef>
+        </p:style>
+        <p:txBody>
+          <a:bodyPr rtlCol="0" anchor="ctr"/>
+          <a:lstStyle/>
+          <a:p>
+            <a:pPr algn="ctr"/>
+          </a:p>
+        </p:txBody>
+      </p:sp>
       <p:graphicFrame>
         <p:nvGraphicFramePr>
-          <p:cNvPr id="11" name="Table 10"/>
+          <p:cNvPr id="15" name="Table 14"/>
           <p:cNvGraphicFramePr>
             <a:graphicFrameLocks noGrp="1"/>
           </p:cNvGraphicFramePr>
@@ -6778,400 +8806,6 @@
 </p:sld>
 </file>
 
-<file path=ppt/slides/slide8.xml><?xml version="1.0" encoding="utf-8"?>
-<p:sld xmlns:a="http://schemas.openxmlformats.org/drawingml/2006/main" xmlns:p="http://schemas.openxmlformats.org/presentationml/2006/main" xmlns:r="http://schemas.openxmlformats.org/officeDocument/2006/relationships">
-  <p:cSld>
-    <p:bg>
-      <p:bgPr>
-        <a:solidFill>
-          <a:srgbClr val="071321"/>
-        </a:solidFill>
-        <a:effectLst/>
-      </p:bgPr>
-    </p:bg>
-    <p:spTree>
-      <p:nvGrpSpPr>
-        <p:cNvPr id="1" name=""/>
-        <p:cNvGrpSpPr/>
-        <p:nvPr/>
-      </p:nvGrpSpPr>
-      <p:grpSpPr/>
-      <p:sp>
-        <p:nvSpPr>
-          <p:cNvPr id="2" name="TextBox 1"/>
-          <p:cNvSpPr txBox="1"/>
-          <p:nvPr/>
-        </p:nvSpPr>
-        <p:spPr>
-          <a:xfrm>
-            <a:off x="731520" y="365760"/>
-            <a:ext cx="10698480" cy="274320"/>
-          </a:xfrm>
-          <a:prstGeom prst="rect">
-            <a:avLst/>
-          </a:prstGeom>
-          <a:noFill/>
-        </p:spPr>
-        <p:txBody>
-          <a:bodyPr wrap="square" lIns="0" tIns="0" rIns="0" bIns="0">
-            <a:spAutoFit/>
-          </a:bodyPr>
-          <a:lstStyle/>
-          <a:p>
-            <a:pPr>
-              <a:defRPr sz="1000" b="1">
-                <a:solidFill>
-                  <a:srgbClr val="29B6D8"/>
-                </a:solidFill>
-                <a:latin typeface="Segoe UI"/>
-              </a:defRPr>
-            </a:pPr>
-            <a:r>
-              <a:t>SYNERGIE &amp; FORCE HUMAINE</a:t>
-            </a:r>
-          </a:p>
-        </p:txBody>
-      </p:sp>
-      <p:sp>
-        <p:nvSpPr>
-          <p:cNvPr id="3" name="TextBox 2"/>
-          <p:cNvSpPr txBox="1"/>
-          <p:nvPr/>
-        </p:nvSpPr>
-        <p:spPr>
-          <a:xfrm>
-            <a:off x="731520" y="594360"/>
-            <a:ext cx="10698480" cy="731520"/>
-          </a:xfrm>
-          <a:prstGeom prst="rect">
-            <a:avLst/>
-          </a:prstGeom>
-          <a:noFill/>
-        </p:spPr>
-        <p:txBody>
-          <a:bodyPr wrap="square" lIns="0" tIns="0" rIns="0" bIns="0">
-            <a:spAutoFit/>
-          </a:bodyPr>
-          <a:lstStyle/>
-          <a:p>
-            <a:pPr>
-              <a:defRPr sz="2800" b="1">
-                <a:solidFill>
-                  <a:srgbClr val="FFFFFF"/>
-                </a:solidFill>
-                <a:latin typeface="Segoe UI"/>
-              </a:defRPr>
-            </a:pPr>
-            <a:r>
-              <a:t>Une Équipe Pluridisciplinaire Complète</a:t>
-            </a:r>
-          </a:p>
-        </p:txBody>
-      </p:sp>
-      <p:sp>
-        <p:nvSpPr>
-          <p:cNvPr id="4" name="Rounded Rectangle 3"/>
-          <p:cNvSpPr/>
-          <p:nvPr/>
-        </p:nvSpPr>
-        <p:spPr>
-          <a:xfrm>
-            <a:off x="731520" y="1463040"/>
-            <a:ext cx="5120640" cy="4754880"/>
-          </a:xfrm>
-          <a:prstGeom prst="roundRect">
-            <a:avLst/>
-          </a:prstGeom>
-          <a:solidFill>
-            <a:srgbClr val="101C30"/>
-          </a:solidFill>
-          <a:ln w="19050">
-            <a:solidFill>
-              <a:srgbClr val="1B2C49"/>
-            </a:solidFill>
-          </a:ln>
-        </p:spPr>
-        <p:style>
-          <a:lnRef idx="1">
-            <a:schemeClr val="accent1"/>
-          </a:lnRef>
-          <a:fillRef idx="3">
-            <a:schemeClr val="accent1"/>
-          </a:fillRef>
-          <a:effectRef idx="2">
-            <a:schemeClr val="accent1"/>
-          </a:effectRef>
-          <a:fontRef idx="minor">
-            <a:schemeClr val="lt1"/>
-          </a:fontRef>
-        </p:style>
-        <p:txBody>
-          <a:bodyPr rtlCol="0" anchor="ctr"/>
-          <a:lstStyle/>
-          <a:p>
-            <a:pPr algn="ctr"/>
-          </a:p>
-        </p:txBody>
-      </p:sp>
-      <p:sp>
-        <p:nvSpPr>
-          <p:cNvPr id="5" name="TextBox 4"/>
-          <p:cNvSpPr txBox="1"/>
-          <p:nvPr/>
-        </p:nvSpPr>
-        <p:spPr>
-          <a:xfrm>
-            <a:off x="1005840" y="1737360"/>
-            <a:ext cx="4572000" cy="4206240"/>
-          </a:xfrm>
-          <a:prstGeom prst="rect">
-            <a:avLst/>
-          </a:prstGeom>
-          <a:noFill/>
-        </p:spPr>
-        <p:txBody>
-          <a:bodyPr wrap="square" lIns="0" rIns="0" tIns="0" bIns="0" anchor="ctr">
-            <a:spAutoFit/>
-          </a:bodyPr>
-          <a:lstStyle/>
-          <a:p>
-            <a:pPr algn="ctr">
-              <a:spcAft>
-                <a:spcPts val="1000"/>
-              </a:spcAft>
-              <a:defRPr sz="1700" b="1">
-                <a:solidFill>
-                  <a:srgbClr val="29B6D8"/>
-                </a:solidFill>
-                <a:latin typeface="Segoe UI"/>
-              </a:defRPr>
-            </a:pPr>
-            <a:r>
-              <a:t>BOUIRA Islem Akram</a:t>
-            </a:r>
-          </a:p>
-          <a:p>
-            <a:pPr algn="ctr">
-              <a:spcAft>
-                <a:spcPts val="800"/>
-              </a:spcAft>
-              <a:defRPr sz="1250">
-                <a:solidFill>
-                  <a:srgbClr val="FFFFFF"/>
-                </a:solidFill>
-                <a:latin typeface="Segoe UI"/>
-              </a:defRPr>
-            </a:pPr>
-            <a:r>
-              <a:t>Étudiant en 5ème année mécanique (Système Énergétique) @ ENPO</a:t>
-            </a:r>
-          </a:p>
-          <a:p>
-            <a:pPr algn="ctr">
-              <a:spcAft>
-                <a:spcPts val="800"/>
-              </a:spcAft>
-              <a:defRPr sz="1250">
-                <a:solidFill>
-                  <a:srgbClr val="FFFFFF"/>
-                </a:solidFill>
-                <a:latin typeface="Segoe UI"/>
-              </a:defRPr>
-            </a:pPr>
-            <a:r>
-              <a:t>• Modélisation Physique &amp; Thermique : Analyse transitoire du changement de phase solide-liquide (MCP) et résolution des flux de chaleur.</a:t>
-            </a:r>
-          </a:p>
-          <a:p>
-            <a:pPr algn="ctr">
-              <a:spcAft>
-                <a:spcPts val="800"/>
-              </a:spcAft>
-              <a:defRPr sz="1250">
-                <a:solidFill>
-                  <a:srgbClr val="FFFFFF"/>
-                </a:solidFill>
-                <a:latin typeface="Segoe UI"/>
-              </a:defRPr>
-            </a:pPr>
-            <a:r>
-              <a:t>• Conception Mécanique CAO : Conception de l'échangeur de chaleur, modélisation des ailettes en étoile, et système d'ancrage modulaire.</a:t>
-            </a:r>
-          </a:p>
-          <a:p>
-            <a:pPr algn="ctr">
-              <a:spcAft>
-                <a:spcPts val="800"/>
-              </a:spcAft>
-              <a:defRPr sz="1250">
-                <a:solidFill>
-                  <a:srgbClr val="FFFFFF"/>
-                </a:solidFill>
-                <a:latin typeface="Segoe UI"/>
-              </a:defRPr>
-            </a:pPr>
-            <a:r>
-              <a:t>• Résistance des Matériaux (RDM) : Tenue mécanique des suspentes M14, flèche des cylindres et calculs DFM de fabrication locale.</a:t>
-            </a:r>
-          </a:p>
-        </p:txBody>
-      </p:sp>
-      <p:sp>
-        <p:nvSpPr>
-          <p:cNvPr id="6" name="Rounded Rectangle 5"/>
-          <p:cNvSpPr/>
-          <p:nvPr/>
-        </p:nvSpPr>
-        <p:spPr>
-          <a:xfrm>
-            <a:off x="6309360" y="1463040"/>
-            <a:ext cx="5120640" cy="4754880"/>
-          </a:xfrm>
-          <a:prstGeom prst="roundRect">
-            <a:avLst/>
-          </a:prstGeom>
-          <a:solidFill>
-            <a:srgbClr val="101C30"/>
-          </a:solidFill>
-          <a:ln w="19050">
-            <a:solidFill>
-              <a:srgbClr val="1B2C49"/>
-            </a:solidFill>
-          </a:ln>
-        </p:spPr>
-        <p:style>
-          <a:lnRef idx="1">
-            <a:schemeClr val="accent1"/>
-          </a:lnRef>
-          <a:fillRef idx="3">
-            <a:schemeClr val="accent1"/>
-          </a:fillRef>
-          <a:effectRef idx="2">
-            <a:schemeClr val="accent1"/>
-          </a:effectRef>
-          <a:fontRef idx="minor">
-            <a:schemeClr val="lt1"/>
-          </a:fontRef>
-        </p:style>
-        <p:txBody>
-          <a:bodyPr rtlCol="0" anchor="ctr"/>
-          <a:lstStyle/>
-          <a:p>
-            <a:pPr algn="ctr"/>
-          </a:p>
-        </p:txBody>
-      </p:sp>
-      <p:sp>
-        <p:nvSpPr>
-          <p:cNvPr id="7" name="TextBox 6"/>
-          <p:cNvSpPr txBox="1"/>
-          <p:nvPr/>
-        </p:nvSpPr>
-        <p:spPr>
-          <a:xfrm>
-            <a:off x="6583680" y="1737360"/>
-            <a:ext cx="4572000" cy="4206240"/>
-          </a:xfrm>
-          <a:prstGeom prst="rect">
-            <a:avLst/>
-          </a:prstGeom>
-          <a:noFill/>
-        </p:spPr>
-        <p:txBody>
-          <a:bodyPr wrap="square" lIns="0" rIns="0" tIns="0" bIns="0" anchor="ctr">
-            <a:spAutoFit/>
-          </a:bodyPr>
-          <a:lstStyle/>
-          <a:p>
-            <a:pPr algn="ctr">
-              <a:spcAft>
-                <a:spcPts val="1000"/>
-              </a:spcAft>
-              <a:defRPr sz="1700" b="1">
-                <a:solidFill>
-                  <a:srgbClr val="29B6D8"/>
-                </a:solidFill>
-                <a:latin typeface="Segoe UI"/>
-              </a:defRPr>
-            </a:pPr>
-            <a:r>
-              <a:t>ZANE Mohamed Elamine</a:t>
-            </a:r>
-          </a:p>
-          <a:p>
-            <a:pPr algn="ctr">
-              <a:spcAft>
-                <a:spcPts val="800"/>
-              </a:spcAft>
-              <a:defRPr sz="1250">
-                <a:solidFill>
-                  <a:srgbClr val="FFFFFF"/>
-                </a:solidFill>
-                <a:latin typeface="Segoe UI"/>
-              </a:defRPr>
-            </a:pPr>
-            <a:r>
-              <a:t>Étudiant en 4ème année électrotechnique @ ENPA</a:t>
-            </a:r>
-          </a:p>
-          <a:p>
-            <a:pPr algn="ctr">
-              <a:spcAft>
-                <a:spcPts val="800"/>
-              </a:spcAft>
-              <a:defRPr sz="1250">
-                <a:solidFill>
-                  <a:srgbClr val="FFFFFF"/>
-                </a:solidFill>
-                <a:latin typeface="Segoe UI"/>
-              </a:defRPr>
-            </a:pPr>
-            <a:r>
-              <a:t>• Armoire Électrique &amp; Puissance : Conception du câblage de puissance, des relais thermiques et des sectionneurs de protection.</a:t>
-            </a:r>
-          </a:p>
-          <a:p>
-            <a:pPr algn="ctr">
-              <a:spcAft>
-                <a:spcPts val="800"/>
-              </a:spcAft>
-              <a:defRPr sz="1250">
-                <a:solidFill>
-                  <a:srgbClr val="FFFFFF"/>
-                </a:solidFill>
-                <a:latin typeface="Segoe UI"/>
-              </a:defRPr>
-            </a:pPr>
-            <a:r>
-              <a:t>• Automatisme PLC &amp; IHM : Écriture de la logique PID de régulation du basculement charge/décharge et interface de contrôle locale.</a:t>
-            </a:r>
-          </a:p>
-          <a:p>
-            <a:pPr algn="ctr">
-              <a:spcAft>
-                <a:spcPts val="800"/>
-              </a:spcAft>
-              <a:defRPr sz="1250">
-                <a:solidFill>
-                  <a:srgbClr val="FFFFFF"/>
-                </a:solidFill>
-                <a:latin typeface="Segoe UI"/>
-              </a:defRPr>
-            </a:pPr>
-            <a:r>
-              <a:t>• Secours Électrique (UPS) : Dimensionnement et supervision du pack de batteries de secours LiFePO4 pour sécuriser la soufflerie en cas de panne.</a:t>
-            </a:r>
-          </a:p>
-        </p:txBody>
-      </p:sp>
-    </p:spTree>
-  </p:cSld>
-  <p:clrMapOvr>
-    <a:masterClrMapping/>
-  </p:clrMapOvr>
-</p:sld>
-</file>
-
 <file path=ppt/theme/theme1.xml><?xml version="1.0" encoding="utf-8"?>
 <a:theme xmlns:a="http://schemas.openxmlformats.org/drawingml/2006/main" name="Office Theme">
   <a:themeElements>

</xml_diff>